<commit_message>
Updated slides and code for lectures 1.1, 1.2, 1.3
</commit_message>
<xml_diff>
--- a/Module 1/class_1.2/deep_learning_course_class_1.2.pptx
+++ b/Module 1/class_1.2/deep_learning_course_class_1.2.pptx
@@ -7196,7 +7196,7 @@
         <p:spPr>
           <a:xfrm>
             <a:off x="4639075" y="3342200"/>
-            <a:ext cx="4176000" cy="1215900"/>
+            <a:ext cx="4176000" cy="1816200"/>
           </a:xfrm>
           <a:prstGeom prst="rect">
             <a:avLst/>
@@ -7283,7 +7283,35 @@
                   <a:schemeClr val="dk2"/>
                 </a:solidFill>
               </a:rPr>
-              <a:t>Gradient provides both direction and size of the step. However, it is common to decrease the </a:t>
+              <a:t>The step size is a combination of learning rate and current value of the gradient</a:t>
+            </a:r>
+            <a:endParaRPr sz="1300">
+              <a:solidFill>
+                <a:schemeClr val="dk2"/>
+              </a:solidFill>
+            </a:endParaRPr>
+          </a:p>
+          <a:p>
+            <a:pPr indent="-311150" lvl="0" marL="457200" rtl="0" algn="l">
+              <a:spcBef>
+                <a:spcPts val="0"/>
+              </a:spcBef>
+              <a:spcAft>
+                <a:spcPts val="0"/>
+              </a:spcAft>
+              <a:buClr>
+                <a:schemeClr val="dk2"/>
+              </a:buClr>
+              <a:buSzPts val="1300"/>
+              <a:buChar char="-"/>
+            </a:pPr>
+            <a:r>
+              <a:rPr lang="en" sz="1300">
+                <a:solidFill>
+                  <a:schemeClr val="dk2"/>
+                </a:solidFill>
+              </a:rPr>
+              <a:t>Gradient provides both direction and size of the step. However, it is common to decrease the learning rate as we approach the minimum</a:t>
             </a:r>
             <a:endParaRPr sz="1300">
               <a:solidFill>
@@ -8815,7 +8843,7 @@
         <p:spPr>
           <a:xfrm>
             <a:off x="480050" y="1195250"/>
-            <a:ext cx="6747300" cy="2401200"/>
+            <a:ext cx="6747300" cy="2678100"/>
           </a:xfrm>
           <a:prstGeom prst="rect">
             <a:avLst/>
@@ -8924,6 +8952,43 @@
             </a:endParaRPr>
           </a:p>
           <a:p>
+            <a:pPr indent="-342900" lvl="0" marL="457200" rtl="0" algn="l">
+              <a:spcBef>
+                <a:spcPts val="0"/>
+              </a:spcBef>
+              <a:spcAft>
+                <a:spcPts val="0"/>
+              </a:spcAft>
+              <a:buClr>
+                <a:schemeClr val="dk2"/>
+              </a:buClr>
+              <a:buSzPts val="1800"/>
+              <a:buChar char="-"/>
+            </a:pPr>
+            <a:r>
+              <a:rPr lang="en" sz="1800" u="sng">
+                <a:solidFill>
+                  <a:schemeClr val="hlink"/>
+                </a:solidFill>
+                <a:hlinkClick r:id="rId5"/>
+              </a:rPr>
+              <a:t>Explained.ai</a:t>
+            </a:r>
+            <a:r>
+              <a:rPr lang="en" sz="1800">
+                <a:solidFill>
+                  <a:schemeClr val="dk2"/>
+                </a:solidFill>
+              </a:rPr>
+              <a:t> : Review Scalar derivative rules section</a:t>
+            </a:r>
+            <a:endParaRPr sz="1800">
+              <a:solidFill>
+                <a:schemeClr val="dk2"/>
+              </a:solidFill>
+            </a:endParaRPr>
+          </a:p>
+          <a:p>
             <a:pPr indent="0" lvl="0" marL="457200" rtl="0" algn="l">
               <a:spcBef>
                 <a:spcPts val="0"/>
@@ -8969,7 +9034,7 @@
                 <a:solidFill>
                   <a:schemeClr val="hlink"/>
                 </a:solidFill>
-                <a:hlinkClick r:id="rId5"/>
+                <a:hlinkClick r:id="rId6"/>
               </a:rPr>
               <a:t>Gradient Descent Demystified</a:t>
             </a:r>
@@ -10068,7 +10133,7 @@
         <p:spPr>
           <a:xfrm>
             <a:off x="259350" y="729950"/>
-            <a:ext cx="5032800" cy="1785600"/>
+            <a:ext cx="5032800" cy="1985700"/>
           </a:xfrm>
           <a:prstGeom prst="rect">
             <a:avLst/>
@@ -10146,7 +10211,7 @@
                   <a:schemeClr val="dk2"/>
                 </a:solidFill>
               </a:rPr>
-              <a:t>At the minimum, the derivative is 0. Makes sense, because derivative of a function at a point is the slope of the function at that point, and the slope must be zero at a local minima. Note: slope can be zero both at a minima and maxima!</a:t>
+              <a:t>At the minimum, the derivative is 0. Makes sense, because derivative of a function at a point is the slope of the function at that point, and the slope must be zero. Note: slope can be zero both at a minima and maxima! So how to we tell them apart? Second derivative test!</a:t>
             </a:r>
             <a:endParaRPr sz="1300">
               <a:solidFill>
@@ -10164,8 +10229,8 @@
         </p:nvSpPr>
         <p:spPr>
           <a:xfrm>
-            <a:off x="4516200" y="4561850"/>
-            <a:ext cx="3000000" cy="369300"/>
+            <a:off x="4516200" y="4730500"/>
+            <a:ext cx="4518900" cy="369300"/>
           </a:xfrm>
           <a:prstGeom prst="rect">
             <a:avLst/>
@@ -10196,7 +10261,7 @@
                   <a:schemeClr val="dk2"/>
                 </a:solidFill>
               </a:rPr>
-              <a:t>Code: multiple_local_minima.py</a:t>
+              <a:t>Code: multiple_local_minima.py, derivative_direction.py</a:t>
             </a:r>
             <a:endParaRPr sz="1200">
               <a:solidFill>
@@ -10233,16 +10298,24 @@
           </a:ln>
         </p:spPr>
       </p:pic>
-      <p:sp>
-        <p:nvSpPr>
-          <p:cNvPr id="106" name="Google Shape;106;p19"/>
-          <p:cNvSpPr txBox="1"/>
+      <p:pic>
+        <p:nvPicPr>
+          <p:cNvPr descr="{&quot;backgroundColor&quot;:&quot;#FFFFFF&quot;,&quot;backgroundColorModified&quot;:false,&quot;type&quot;:&quot;lalign*&quot;,&quot;font&quot;:{&quot;size&quot;:9,&quot;family&quot;:&quot;Arial&quot;,&quot;color&quot;:&quot;#000000&quot;},&quot;id&quot;:&quot;6&quot;,&quot;code&quot;:&quot;\\begin{lalign*}\n&amp;{\\text{To}\\;\\text{move}\\;\\text{towards}\\;\\text{the}\\;\\text{minimum}\\;\\text{from}\\;\\text{any}\\;\\text{point,}\\;\\text{I}\\;\\text{need}\\;\\text{to}\\;\\text{know:}}\\\\\n&amp;{1.\\,\\text{Which}\\;\\text{direction}\\;\\text{should}\\;\\text{I}\\;\\text{move}\\;\\text{(left/right)}}\\\\\n&amp;{2.\\,\\text{How}\\;\\text{much}\\;\\text{should}\\;\\text{I}\\;\\text{move}}\\\\\n&amp;{\\text{Gradient}\\;\\text{gives}\\;\\text{us}\\;\\text{both.}\\;\\text{}}\\\\\n&amp;{Eg.,\\,\\text{At}\\;\\text{x}\\;\\text{=}\\;\\text{4.5,}\\;f^{\\prime}\\left(x\\right)=3.\\,\\text{Since}\\;f^{\\prime}\\left(x\\right)&gt;0,\\,\\text{w}\\text{e}\\;\\text{step}\\;\\text{to}\\;\\text{the}\\;\\text{left,}\\;\\text{by}\\;\\text{}}\\\\\n&amp;{\\text{learning}\\;\\text{rate}\\;\\times\\,3}\\\\\n&amp;{\\text{At}\\;\\text{x=-4.5,}\\;f^{\\prime}\\left(x\\right)=-15.\\,\\,\\text{Since}\\;f^{\\prime}\\left(x\\right)&lt;0,\\,\\text{w}\\text{e}\\;\\text{step}\\;\\text{to}\\;\\text{the}\\;\\text{right,}\\;\\text{by}}\\\\\n&amp;{\\text{learning}\\;\\text{rate}\\;\\times\\,15}\t\n\\end{lalign*}&quot;,&quot;aid&quot;:null,&quot;ts&quot;:1759605483807,&quot;cs&quot;:&quot;H30tX8KikYsIGLeUjTG74Q==&quot;,&quot;size&quot;:{&quot;width&quot;:424.99478267716535,&quot;height&quot;:149.5144}}" id="106" name="Google Shape;106;p19"/>
+          <p:cNvPicPr preferRelativeResize="0"/>
           <p:nvPr/>
-        </p:nvSpPr>
-        <p:spPr>
-          <a:xfrm>
-            <a:off x="5873600" y="3035075"/>
-            <a:ext cx="3000000" cy="369300"/>
+        </p:nvPicPr>
+        <p:blipFill>
+          <a:blip r:embed="rId5">
+            <a:alphaModFix/>
+          </a:blip>
+          <a:stretch>
+            <a:fillRect/>
+          </a:stretch>
+        </p:blipFill>
+        <p:spPr>
+          <a:xfrm>
+            <a:off x="4686600" y="3205375"/>
+            <a:ext cx="4048075" cy="1424125"/>
           </a:xfrm>
           <a:prstGeom prst="rect">
             <a:avLst/>
@@ -10252,37 +10325,7 @@
             <a:noFill/>
           </a:ln>
         </p:spPr>
-        <p:txBody>
-          <a:bodyPr anchorCtr="0" anchor="t" bIns="91425" lIns="91425" spcFirstLastPara="1" rIns="91425" wrap="square" tIns="91425">
-            <a:spAutoFit/>
-          </a:bodyPr>
-          <a:lstStyle/>
-          <a:p>
-            <a:pPr indent="0" lvl="0" marL="0" rtl="0" algn="l">
-              <a:spcBef>
-                <a:spcPts val="0"/>
-              </a:spcBef>
-              <a:spcAft>
-                <a:spcPts val="0"/>
-              </a:spcAft>
-              <a:buNone/>
-            </a:pPr>
-            <a:r>
-              <a:rPr lang="en" sz="1200">
-                <a:solidFill>
-                  <a:schemeClr val="dk2"/>
-                </a:solidFill>
-              </a:rPr>
-              <a:t>Code: derivative_direction.py</a:t>
-            </a:r>
-            <a:endParaRPr sz="1200">
-              <a:solidFill>
-                <a:schemeClr val="dk2"/>
-              </a:solidFill>
-            </a:endParaRPr>
-          </a:p>
-        </p:txBody>
-      </p:sp>
+      </p:pic>
     </p:spTree>
   </p:cSld>
   <p:clrMapOvr>
@@ -10779,6 +10822,285 @@
 </file>
 
 <file path=ppt/theme/theme1.xml><?xml version="1.0" encoding="utf-8"?>
+<a:theme xmlns:a="http://schemas.openxmlformats.org/drawingml/2006/main" xmlns:r="http://schemas.openxmlformats.org/officeDocument/2006/relationships">
+  <a:themeElements>
+    <a:clrScheme name="Default">
+      <a:dk1>
+        <a:srgbClr val="000000"/>
+      </a:dk1>
+      <a:lt1>
+        <a:srgbClr val="FFFFFF"/>
+      </a:lt1>
+      <a:dk2>
+        <a:srgbClr val="158158"/>
+      </a:dk2>
+      <a:lt2>
+        <a:srgbClr val="F3F3F3"/>
+      </a:lt2>
+      <a:accent1>
+        <a:srgbClr val="058DC7"/>
+      </a:accent1>
+      <a:accent2>
+        <a:srgbClr val="50B432"/>
+      </a:accent2>
+      <a:accent3>
+        <a:srgbClr val="ED561B"/>
+      </a:accent3>
+      <a:accent4>
+        <a:srgbClr val="EDEF00"/>
+      </a:accent4>
+      <a:accent5>
+        <a:srgbClr val="24CBE5"/>
+      </a:accent5>
+      <a:accent6>
+        <a:srgbClr val="64E572"/>
+      </a:accent6>
+      <a:hlink>
+        <a:srgbClr val="2200CC"/>
+      </a:hlink>
+      <a:folHlink>
+        <a:srgbClr val="551A8B"/>
+      </a:folHlink>
+    </a:clrScheme>
+    <a:fontScheme name="Office">
+      <a:majorFont>
+        <a:latin typeface="Arial"/>
+        <a:ea typeface=""/>
+        <a:cs typeface=""/>
+        <a:font script="Jpan" typeface="ＭＳ Ｐゴシック"/>
+        <a:font script="Hang" typeface="맑은 고딕"/>
+        <a:font script="Hans" typeface="宋体"/>
+        <a:font script="Hant" typeface="新細明體"/>
+        <a:font script="Arab" typeface="Times New Roman"/>
+        <a:font script="Hebr" typeface="Times New Roman"/>
+        <a:font script="Thai" typeface="Angsana New"/>
+        <a:font script="Ethi" typeface="Nyala"/>
+        <a:font script="Beng" typeface="Vrinda"/>
+        <a:font script="Gujr" typeface="Shruti"/>
+        <a:font script="Khmr" typeface="MoolBoran"/>
+        <a:font script="Knda" typeface="Tunga"/>
+        <a:font script="Guru" typeface="Raavi"/>
+        <a:font script="Cans" typeface="Euphemia"/>
+        <a:font script="Cher" typeface="Plantagenet Cherokee"/>
+        <a:font script="Yiii" typeface="Microsoft Yi Baiti"/>
+        <a:font script="Tibt" typeface="Microsoft Himalaya"/>
+        <a:font script="Thaa" typeface="MV Boli"/>
+        <a:font script="Deva" typeface="Mangal"/>
+        <a:font script="Telu" typeface="Gautami"/>
+        <a:font script="Taml" typeface="Latha"/>
+        <a:font script="Syrc" typeface="Estrangelo Edessa"/>
+        <a:font script="Orya" typeface="Kalinga"/>
+        <a:font script="Mlym" typeface="Kartika"/>
+        <a:font script="Laoo" typeface="DokChampa"/>
+        <a:font script="Sinh" typeface="Iskoola Pota"/>
+        <a:font script="Mong" typeface="Mongolian Baiti"/>
+        <a:font script="Viet" typeface="Times New Roman"/>
+        <a:font script="Uigh" typeface="Microsoft Uighur"/>
+        <a:font script="Geor" typeface="Sylfaen"/>
+      </a:majorFont>
+      <a:minorFont>
+        <a:latin typeface="Arial"/>
+        <a:ea typeface=""/>
+        <a:cs typeface=""/>
+        <a:font script="Jpan" typeface="ＭＳ Ｐゴシック"/>
+        <a:font script="Hang" typeface="맑은 고딕"/>
+        <a:font script="Hans" typeface="宋体"/>
+        <a:font script="Hant" typeface="新細明體"/>
+        <a:font script="Arab" typeface="Arial"/>
+        <a:font script="Hebr" typeface="Arial"/>
+        <a:font script="Thai" typeface="Cordia New"/>
+        <a:font script="Ethi" typeface="Nyala"/>
+        <a:font script="Beng" typeface="Vrinda"/>
+        <a:font script="Gujr" typeface="Shruti"/>
+        <a:font script="Khmr" typeface="DaunPenh"/>
+        <a:font script="Knda" typeface="Tunga"/>
+        <a:font script="Guru" typeface="Raavi"/>
+        <a:font script="Cans" typeface="Euphemia"/>
+        <a:font script="Cher" typeface="Plantagenet Cherokee"/>
+        <a:font script="Yiii" typeface="Microsoft Yi Baiti"/>
+        <a:font script="Tibt" typeface="Microsoft Himalaya"/>
+        <a:font script="Thaa" typeface="MV Boli"/>
+        <a:font script="Deva" typeface="Mangal"/>
+        <a:font script="Telu" typeface="Gautami"/>
+        <a:font script="Taml" typeface="Latha"/>
+        <a:font script="Syrc" typeface="Estrangelo Edessa"/>
+        <a:font script="Orya" typeface="Kalinga"/>
+        <a:font script="Mlym" typeface="Kartika"/>
+        <a:font script="Laoo" typeface="DokChampa"/>
+        <a:font script="Sinh" typeface="Iskoola Pota"/>
+        <a:font script="Mong" typeface="Mongolian Baiti"/>
+        <a:font script="Viet" typeface="Arial"/>
+        <a:font script="Uigh" typeface="Microsoft Uighur"/>
+        <a:font script="Geor" typeface="Sylfaen"/>
+      </a:minorFont>
+    </a:fontScheme>
+    <a:fmtScheme name="Office">
+      <a:fillStyleLst>
+        <a:solidFill>
+          <a:schemeClr val="phClr"/>
+        </a:solidFill>
+        <a:gradFill rotWithShape="1">
+          <a:gsLst>
+            <a:gs pos="0">
+              <a:schemeClr val="phClr">
+                <a:tint val="50000"/>
+                <a:satMod val="300000"/>
+              </a:schemeClr>
+            </a:gs>
+            <a:gs pos="35000">
+              <a:schemeClr val="phClr">
+                <a:tint val="37000"/>
+                <a:satMod val="300000"/>
+              </a:schemeClr>
+            </a:gs>
+            <a:gs pos="100000">
+              <a:schemeClr val="phClr">
+                <a:tint val="15000"/>
+                <a:satMod val="350000"/>
+              </a:schemeClr>
+            </a:gs>
+          </a:gsLst>
+          <a:lin ang="16200000" scaled="1"/>
+        </a:gradFill>
+        <a:gradFill rotWithShape="1">
+          <a:gsLst>
+            <a:gs pos="0">
+              <a:schemeClr val="phClr">
+                <a:tint val="100000"/>
+                <a:shade val="100000"/>
+                <a:satMod val="130000"/>
+              </a:schemeClr>
+            </a:gs>
+            <a:gs pos="100000">
+              <a:schemeClr val="phClr">
+                <a:tint val="50000"/>
+                <a:shade val="100000"/>
+                <a:satMod val="350000"/>
+              </a:schemeClr>
+            </a:gs>
+          </a:gsLst>
+          <a:lin ang="16200000" scaled="0"/>
+        </a:gradFill>
+      </a:fillStyleLst>
+      <a:lnStyleLst>
+        <a:ln w="9525" cap="flat" cmpd="sng" algn="ctr">
+          <a:solidFill>
+            <a:schemeClr val="phClr">
+              <a:shade val="95000"/>
+              <a:satMod val="105000"/>
+            </a:schemeClr>
+          </a:solidFill>
+          <a:prstDash val="solid"/>
+        </a:ln>
+        <a:ln w="25400" cap="flat" cmpd="sng" algn="ctr">
+          <a:solidFill>
+            <a:schemeClr val="phClr"/>
+          </a:solidFill>
+          <a:prstDash val="solid"/>
+        </a:ln>
+        <a:ln w="38100" cap="flat" cmpd="sng" algn="ctr">
+          <a:solidFill>
+            <a:schemeClr val="phClr"/>
+          </a:solidFill>
+          <a:prstDash val="solid"/>
+        </a:ln>
+      </a:lnStyleLst>
+      <a:effectStyleLst>
+        <a:effectStyle>
+          <a:effectLst>
+            <a:outerShdw blurRad="40000" dist="20000" dir="5400000" rotWithShape="0">
+              <a:srgbClr val="000000">
+                <a:alpha val="38000"/>
+              </a:srgbClr>
+            </a:outerShdw>
+          </a:effectLst>
+        </a:effectStyle>
+        <a:effectStyle>
+          <a:effectLst>
+            <a:outerShdw blurRad="40000" dist="23000" dir="5400000" rotWithShape="0">
+              <a:srgbClr val="000000">
+                <a:alpha val="35000"/>
+              </a:srgbClr>
+            </a:outerShdw>
+          </a:effectLst>
+        </a:effectStyle>
+        <a:effectStyle>
+          <a:effectLst>
+            <a:outerShdw blurRad="40000" dist="23000" dir="5400000" rotWithShape="0">
+              <a:srgbClr val="000000">
+                <a:alpha val="35000"/>
+              </a:srgbClr>
+            </a:outerShdw>
+          </a:effectLst>
+          <a:scene3d>
+            <a:camera prst="orthographicFront">
+              <a:rot lat="0" lon="0" rev="0"/>
+            </a:camera>
+            <a:lightRig rig="threePt" dir="t">
+              <a:rot lat="0" lon="0" rev="1200000"/>
+            </a:lightRig>
+          </a:scene3d>
+          <a:sp3d>
+            <a:bevelT w="63500" h="25400"/>
+          </a:sp3d>
+        </a:effectStyle>
+      </a:effectStyleLst>
+      <a:bgFillStyleLst>
+        <a:solidFill>
+          <a:schemeClr val="phClr"/>
+        </a:solidFill>
+        <a:gradFill rotWithShape="1">
+          <a:gsLst>
+            <a:gs pos="0">
+              <a:schemeClr val="phClr">
+                <a:tint val="40000"/>
+                <a:satMod val="350000"/>
+              </a:schemeClr>
+            </a:gs>
+            <a:gs pos="40000">
+              <a:schemeClr val="phClr">
+                <a:tint val="45000"/>
+                <a:shade val="99000"/>
+                <a:satMod val="350000"/>
+              </a:schemeClr>
+            </a:gs>
+            <a:gs pos="100000">
+              <a:schemeClr val="phClr">
+                <a:shade val="20000"/>
+                <a:satMod val="255000"/>
+              </a:schemeClr>
+            </a:gs>
+          </a:gsLst>
+          <a:path path="circle">
+            <a:fillToRect l="50000" t="-80000" r="50000" b="180000"/>
+          </a:path>
+        </a:gradFill>
+        <a:gradFill rotWithShape="1">
+          <a:gsLst>
+            <a:gs pos="0">
+              <a:schemeClr val="phClr">
+                <a:tint val="80000"/>
+                <a:satMod val="300000"/>
+              </a:schemeClr>
+            </a:gs>
+            <a:gs pos="100000">
+              <a:schemeClr val="phClr">
+                <a:shade val="30000"/>
+                <a:satMod val="200000"/>
+              </a:schemeClr>
+            </a:gs>
+          </a:gsLst>
+          <a:path path="circle">
+            <a:fillToRect l="50000" t="50000" r="50000" b="50000"/>
+          </a:path>
+        </a:gradFill>
+      </a:bgFillStyleLst>
+    </a:fmtScheme>
+  </a:themeElements>
+</a:theme>
+</file>
+
+<file path=ppt/theme/theme2.xml><?xml version="1.0" encoding="utf-8"?>
 <a:theme xmlns:a="http://schemas.openxmlformats.org/drawingml/2006/main" xmlns:r="http://schemas.openxmlformats.org/officeDocument/2006/relationships" name="Simple Light">
   <a:themeElements>
     <a:clrScheme name="Simple Light">
@@ -11055,283 +11377,4 @@
     </a:fmtScheme>
   </a:themeElements>
 </a:theme>
-</file>
-
-<file path=ppt/theme/theme2.xml><?xml version="1.0" encoding="utf-8"?>
-<a:theme xmlns:a="http://schemas.openxmlformats.org/drawingml/2006/main" xmlns:r="http://schemas.openxmlformats.org/officeDocument/2006/relationships">
-  <a:themeElements>
-    <a:clrScheme name="Default">
-      <a:dk1>
-        <a:srgbClr val="000000"/>
-      </a:dk1>
-      <a:lt1>
-        <a:srgbClr val="FFFFFF"/>
-      </a:lt1>
-      <a:dk2>
-        <a:srgbClr val="158158"/>
-      </a:dk2>
-      <a:lt2>
-        <a:srgbClr val="F3F3F3"/>
-      </a:lt2>
-      <a:accent1>
-        <a:srgbClr val="058DC7"/>
-      </a:accent1>
-      <a:accent2>
-        <a:srgbClr val="50B432"/>
-      </a:accent2>
-      <a:accent3>
-        <a:srgbClr val="ED561B"/>
-      </a:accent3>
-      <a:accent4>
-        <a:srgbClr val="EDEF00"/>
-      </a:accent4>
-      <a:accent5>
-        <a:srgbClr val="24CBE5"/>
-      </a:accent5>
-      <a:accent6>
-        <a:srgbClr val="64E572"/>
-      </a:accent6>
-      <a:hlink>
-        <a:srgbClr val="2200CC"/>
-      </a:hlink>
-      <a:folHlink>
-        <a:srgbClr val="551A8B"/>
-      </a:folHlink>
-    </a:clrScheme>
-    <a:fontScheme name="Office">
-      <a:majorFont>
-        <a:latin typeface="Arial"/>
-        <a:ea typeface=""/>
-        <a:cs typeface=""/>
-        <a:font script="Jpan" typeface="ＭＳ Ｐゴシック"/>
-        <a:font script="Hang" typeface="맑은 고딕"/>
-        <a:font script="Hans" typeface="宋体"/>
-        <a:font script="Hant" typeface="新細明體"/>
-        <a:font script="Arab" typeface="Times New Roman"/>
-        <a:font script="Hebr" typeface="Times New Roman"/>
-        <a:font script="Thai" typeface="Angsana New"/>
-        <a:font script="Ethi" typeface="Nyala"/>
-        <a:font script="Beng" typeface="Vrinda"/>
-        <a:font script="Gujr" typeface="Shruti"/>
-        <a:font script="Khmr" typeface="MoolBoran"/>
-        <a:font script="Knda" typeface="Tunga"/>
-        <a:font script="Guru" typeface="Raavi"/>
-        <a:font script="Cans" typeface="Euphemia"/>
-        <a:font script="Cher" typeface="Plantagenet Cherokee"/>
-        <a:font script="Yiii" typeface="Microsoft Yi Baiti"/>
-        <a:font script="Tibt" typeface="Microsoft Himalaya"/>
-        <a:font script="Thaa" typeface="MV Boli"/>
-        <a:font script="Deva" typeface="Mangal"/>
-        <a:font script="Telu" typeface="Gautami"/>
-        <a:font script="Taml" typeface="Latha"/>
-        <a:font script="Syrc" typeface="Estrangelo Edessa"/>
-        <a:font script="Orya" typeface="Kalinga"/>
-        <a:font script="Mlym" typeface="Kartika"/>
-        <a:font script="Laoo" typeface="DokChampa"/>
-        <a:font script="Sinh" typeface="Iskoola Pota"/>
-        <a:font script="Mong" typeface="Mongolian Baiti"/>
-        <a:font script="Viet" typeface="Times New Roman"/>
-        <a:font script="Uigh" typeface="Microsoft Uighur"/>
-        <a:font script="Geor" typeface="Sylfaen"/>
-      </a:majorFont>
-      <a:minorFont>
-        <a:latin typeface="Arial"/>
-        <a:ea typeface=""/>
-        <a:cs typeface=""/>
-        <a:font script="Jpan" typeface="ＭＳ Ｐゴシック"/>
-        <a:font script="Hang" typeface="맑은 고딕"/>
-        <a:font script="Hans" typeface="宋体"/>
-        <a:font script="Hant" typeface="新細明體"/>
-        <a:font script="Arab" typeface="Arial"/>
-        <a:font script="Hebr" typeface="Arial"/>
-        <a:font script="Thai" typeface="Cordia New"/>
-        <a:font script="Ethi" typeface="Nyala"/>
-        <a:font script="Beng" typeface="Vrinda"/>
-        <a:font script="Gujr" typeface="Shruti"/>
-        <a:font script="Khmr" typeface="DaunPenh"/>
-        <a:font script="Knda" typeface="Tunga"/>
-        <a:font script="Guru" typeface="Raavi"/>
-        <a:font script="Cans" typeface="Euphemia"/>
-        <a:font script="Cher" typeface="Plantagenet Cherokee"/>
-        <a:font script="Yiii" typeface="Microsoft Yi Baiti"/>
-        <a:font script="Tibt" typeface="Microsoft Himalaya"/>
-        <a:font script="Thaa" typeface="MV Boli"/>
-        <a:font script="Deva" typeface="Mangal"/>
-        <a:font script="Telu" typeface="Gautami"/>
-        <a:font script="Taml" typeface="Latha"/>
-        <a:font script="Syrc" typeface="Estrangelo Edessa"/>
-        <a:font script="Orya" typeface="Kalinga"/>
-        <a:font script="Mlym" typeface="Kartika"/>
-        <a:font script="Laoo" typeface="DokChampa"/>
-        <a:font script="Sinh" typeface="Iskoola Pota"/>
-        <a:font script="Mong" typeface="Mongolian Baiti"/>
-        <a:font script="Viet" typeface="Arial"/>
-        <a:font script="Uigh" typeface="Microsoft Uighur"/>
-        <a:font script="Geor" typeface="Sylfaen"/>
-      </a:minorFont>
-    </a:fontScheme>
-    <a:fmtScheme name="Office">
-      <a:fillStyleLst>
-        <a:solidFill>
-          <a:schemeClr val="phClr"/>
-        </a:solidFill>
-        <a:gradFill rotWithShape="1">
-          <a:gsLst>
-            <a:gs pos="0">
-              <a:schemeClr val="phClr">
-                <a:tint val="50000"/>
-                <a:satMod val="300000"/>
-              </a:schemeClr>
-            </a:gs>
-            <a:gs pos="35000">
-              <a:schemeClr val="phClr">
-                <a:tint val="37000"/>
-                <a:satMod val="300000"/>
-              </a:schemeClr>
-            </a:gs>
-            <a:gs pos="100000">
-              <a:schemeClr val="phClr">
-                <a:tint val="15000"/>
-                <a:satMod val="350000"/>
-              </a:schemeClr>
-            </a:gs>
-          </a:gsLst>
-          <a:lin ang="16200000" scaled="1"/>
-        </a:gradFill>
-        <a:gradFill rotWithShape="1">
-          <a:gsLst>
-            <a:gs pos="0">
-              <a:schemeClr val="phClr">
-                <a:tint val="100000"/>
-                <a:shade val="100000"/>
-                <a:satMod val="130000"/>
-              </a:schemeClr>
-            </a:gs>
-            <a:gs pos="100000">
-              <a:schemeClr val="phClr">
-                <a:tint val="50000"/>
-                <a:shade val="100000"/>
-                <a:satMod val="350000"/>
-              </a:schemeClr>
-            </a:gs>
-          </a:gsLst>
-          <a:lin ang="16200000" scaled="0"/>
-        </a:gradFill>
-      </a:fillStyleLst>
-      <a:lnStyleLst>
-        <a:ln w="9525" cap="flat" cmpd="sng" algn="ctr">
-          <a:solidFill>
-            <a:schemeClr val="phClr">
-              <a:shade val="95000"/>
-              <a:satMod val="105000"/>
-            </a:schemeClr>
-          </a:solidFill>
-          <a:prstDash val="solid"/>
-        </a:ln>
-        <a:ln w="25400" cap="flat" cmpd="sng" algn="ctr">
-          <a:solidFill>
-            <a:schemeClr val="phClr"/>
-          </a:solidFill>
-          <a:prstDash val="solid"/>
-        </a:ln>
-        <a:ln w="38100" cap="flat" cmpd="sng" algn="ctr">
-          <a:solidFill>
-            <a:schemeClr val="phClr"/>
-          </a:solidFill>
-          <a:prstDash val="solid"/>
-        </a:ln>
-      </a:lnStyleLst>
-      <a:effectStyleLst>
-        <a:effectStyle>
-          <a:effectLst>
-            <a:outerShdw blurRad="40000" dist="20000" dir="5400000" rotWithShape="0">
-              <a:srgbClr val="000000">
-                <a:alpha val="38000"/>
-              </a:srgbClr>
-            </a:outerShdw>
-          </a:effectLst>
-        </a:effectStyle>
-        <a:effectStyle>
-          <a:effectLst>
-            <a:outerShdw blurRad="40000" dist="23000" dir="5400000" rotWithShape="0">
-              <a:srgbClr val="000000">
-                <a:alpha val="35000"/>
-              </a:srgbClr>
-            </a:outerShdw>
-          </a:effectLst>
-        </a:effectStyle>
-        <a:effectStyle>
-          <a:effectLst>
-            <a:outerShdw blurRad="40000" dist="23000" dir="5400000" rotWithShape="0">
-              <a:srgbClr val="000000">
-                <a:alpha val="35000"/>
-              </a:srgbClr>
-            </a:outerShdw>
-          </a:effectLst>
-          <a:scene3d>
-            <a:camera prst="orthographicFront">
-              <a:rot lat="0" lon="0" rev="0"/>
-            </a:camera>
-            <a:lightRig rig="threePt" dir="t">
-              <a:rot lat="0" lon="0" rev="1200000"/>
-            </a:lightRig>
-          </a:scene3d>
-          <a:sp3d>
-            <a:bevelT w="63500" h="25400"/>
-          </a:sp3d>
-        </a:effectStyle>
-      </a:effectStyleLst>
-      <a:bgFillStyleLst>
-        <a:solidFill>
-          <a:schemeClr val="phClr"/>
-        </a:solidFill>
-        <a:gradFill rotWithShape="1">
-          <a:gsLst>
-            <a:gs pos="0">
-              <a:schemeClr val="phClr">
-                <a:tint val="40000"/>
-                <a:satMod val="350000"/>
-              </a:schemeClr>
-            </a:gs>
-            <a:gs pos="40000">
-              <a:schemeClr val="phClr">
-                <a:tint val="45000"/>
-                <a:shade val="99000"/>
-                <a:satMod val="350000"/>
-              </a:schemeClr>
-            </a:gs>
-            <a:gs pos="100000">
-              <a:schemeClr val="phClr">
-                <a:shade val="20000"/>
-                <a:satMod val="255000"/>
-              </a:schemeClr>
-            </a:gs>
-          </a:gsLst>
-          <a:path path="circle">
-            <a:fillToRect l="50000" t="-80000" r="50000" b="180000"/>
-          </a:path>
-        </a:gradFill>
-        <a:gradFill rotWithShape="1">
-          <a:gsLst>
-            <a:gs pos="0">
-              <a:schemeClr val="phClr">
-                <a:tint val="80000"/>
-                <a:satMod val="300000"/>
-              </a:schemeClr>
-            </a:gs>
-            <a:gs pos="100000">
-              <a:schemeClr val="phClr">
-                <a:shade val="30000"/>
-                <a:satMod val="200000"/>
-              </a:schemeClr>
-            </a:gs>
-          </a:gsLst>
-          <a:path path="circle">
-            <a:fillToRect l="50000" t="50000" r="50000" b="50000"/>
-          </a:path>
-        </a:gradFill>
-      </a:bgFillStyleLst>
-    </a:fmtScheme>
-  </a:themeElements>
-</a:theme>
 </file>
</xml_diff>

<commit_message>
updated code/slides for module 1, class 2,3,4
</commit_message>
<xml_diff>
--- a/Module 1/class_1.2/deep_learning_course_class_1.2.pptx
+++ b/Module 1/class_1.2/deep_learning_course_class_1.2.pptx
@@ -22,6 +22,8 @@
     <p:sldId id="267" r:id="rId17"/>
     <p:sldId id="268" r:id="rId18"/>
     <p:sldId id="269" r:id="rId19"/>
+    <p:sldId id="270" r:id="rId20"/>
+    <p:sldId id="271" r:id="rId21"/>
   </p:sldIdLst>
   <p:sldSz cy="5143500" cx="9144000"/>
   <p:notesSz cx="6858000" cy="9144000"/>
@@ -803,7 +805,7 @@
   <p:cSld>
     <p:spTree>
       <p:nvGrpSpPr>
-        <p:cNvPr id="124" name="Shape 124"/>
+        <p:cNvPr id="122" name="Shape 122"/>
         <p:cNvGrpSpPr/>
         <p:nvPr/>
       </p:nvGrpSpPr>
@@ -817,7 +819,7 @@
       </p:grpSpPr>
       <p:sp>
         <p:nvSpPr>
-          <p:cNvPr id="125" name="Google Shape;125;g38417863650_0_70:notes"/>
+          <p:cNvPr id="123" name="Google Shape;123;g344f3a761b0_0_203:notes"/>
           <p:cNvSpPr/>
           <p:nvPr>
             <p:ph idx="2" type="sldImg"/>
@@ -852,7 +854,7 @@
       </p:sp>
       <p:sp>
         <p:nvSpPr>
-          <p:cNvPr id="126" name="Google Shape;126;g38417863650_0_70:notes"/>
+          <p:cNvPr id="124" name="Google Shape;124;g344f3a761b0_0_203:notes"/>
           <p:cNvSpPr txBox="1"/>
           <p:nvPr>
             <p:ph idx="1" type="body"/>
@@ -902,7 +904,7 @@
   <p:cSld>
     <p:spTree>
       <p:nvGrpSpPr>
-        <p:cNvPr id="137" name="Shape 137"/>
+        <p:cNvPr id="132" name="Shape 132"/>
         <p:cNvGrpSpPr/>
         <p:nvPr/>
       </p:nvGrpSpPr>
@@ -916,7 +918,7 @@
       </p:grpSpPr>
       <p:sp>
         <p:nvSpPr>
-          <p:cNvPr id="138" name="Google Shape;138;g38417863650_0_86:notes"/>
+          <p:cNvPr id="133" name="Google Shape;133;g38417863650_0_61:notes"/>
           <p:cNvSpPr/>
           <p:nvPr>
             <p:ph idx="2" type="sldImg"/>
@@ -951,7 +953,7 @@
       </p:sp>
       <p:sp>
         <p:nvSpPr>
-          <p:cNvPr id="139" name="Google Shape;139;g38417863650_0_86:notes"/>
+          <p:cNvPr id="134" name="Google Shape;134;g38417863650_0_61:notes"/>
           <p:cNvSpPr txBox="1"/>
           <p:nvPr>
             <p:ph idx="1" type="body"/>
@@ -1001,7 +1003,7 @@
   <p:cSld>
     <p:spTree>
       <p:nvGrpSpPr>
-        <p:cNvPr id="149" name="Shape 149"/>
+        <p:cNvPr id="139" name="Shape 139"/>
         <p:cNvGrpSpPr/>
         <p:nvPr/>
       </p:nvGrpSpPr>
@@ -1015,7 +1017,7 @@
       </p:grpSpPr>
       <p:sp>
         <p:nvSpPr>
-          <p:cNvPr id="150" name="Google Shape;150;g38417863650_0_0:notes"/>
+          <p:cNvPr id="140" name="Google Shape;140;g38417863650_0_70:notes"/>
           <p:cNvSpPr/>
           <p:nvPr>
             <p:ph idx="2" type="sldImg"/>
@@ -1050,7 +1052,7 @@
       </p:sp>
       <p:sp>
         <p:nvSpPr>
-          <p:cNvPr id="151" name="Google Shape;151;g38417863650_0_0:notes"/>
+          <p:cNvPr id="141" name="Google Shape;141;g38417863650_0_70:notes"/>
           <p:cNvSpPr txBox="1"/>
           <p:nvPr>
             <p:ph idx="1" type="body"/>
@@ -1100,7 +1102,7 @@
   <p:cSld>
     <p:spTree>
       <p:nvGrpSpPr>
-        <p:cNvPr id="159" name="Shape 159"/>
+        <p:cNvPr id="152" name="Shape 152"/>
         <p:cNvGrpSpPr/>
         <p:nvPr/>
       </p:nvGrpSpPr>
@@ -1114,7 +1116,7 @@
       </p:grpSpPr>
       <p:sp>
         <p:nvSpPr>
-          <p:cNvPr id="160" name="Google Shape;160;g3849334e9f7_0_5:notes"/>
+          <p:cNvPr id="153" name="Google Shape;153;g38417863650_0_86:notes"/>
           <p:cNvSpPr/>
           <p:nvPr>
             <p:ph idx="2" type="sldImg"/>
@@ -1149,7 +1151,7 @@
       </p:sp>
       <p:sp>
         <p:nvSpPr>
-          <p:cNvPr id="161" name="Google Shape;161;g3849334e9f7_0_5:notes"/>
+          <p:cNvPr id="154" name="Google Shape;154;g38417863650_0_86:notes"/>
           <p:cNvSpPr txBox="1"/>
           <p:nvPr>
             <p:ph idx="1" type="body"/>
@@ -1199,7 +1201,7 @@
   <p:cSld>
     <p:spTree>
       <p:nvGrpSpPr>
-        <p:cNvPr id="170" name="Shape 170"/>
+        <p:cNvPr id="164" name="Shape 164"/>
         <p:cNvGrpSpPr/>
         <p:nvPr/>
       </p:nvGrpSpPr>
@@ -1213,7 +1215,7 @@
       </p:grpSpPr>
       <p:sp>
         <p:nvSpPr>
-          <p:cNvPr id="171" name="Google Shape;171;g3640bf93304_0_18:notes"/>
+          <p:cNvPr id="165" name="Google Shape;165;g38417863650_0_0:notes"/>
           <p:cNvSpPr/>
           <p:nvPr>
             <p:ph idx="2" type="sldImg"/>
@@ -1248,7 +1250,205 @@
       </p:sp>
       <p:sp>
         <p:nvSpPr>
-          <p:cNvPr id="172" name="Google Shape;172;g3640bf93304_0_18:notes"/>
+          <p:cNvPr id="166" name="Google Shape;166;g38417863650_0_0:notes"/>
+          <p:cNvSpPr txBox="1"/>
+          <p:nvPr>
+            <p:ph idx="1" type="body"/>
+          </p:nvPr>
+        </p:nvSpPr>
+        <p:spPr>
+          <a:xfrm>
+            <a:off x="685800" y="4343400"/>
+            <a:ext cx="5486400" cy="4114800"/>
+          </a:xfrm>
+          <a:prstGeom prst="rect">
+            <a:avLst/>
+          </a:prstGeom>
+        </p:spPr>
+        <p:txBody>
+          <a:bodyPr anchorCtr="0" anchor="t" bIns="91425" lIns="91425" spcFirstLastPara="1" rIns="91425" wrap="square" tIns="91425">
+            <a:noAutofit/>
+          </a:bodyPr>
+          <a:lstStyle/>
+          <a:p>
+            <a:pPr indent="0" lvl="0" marL="0" rtl="0" algn="l">
+              <a:spcBef>
+                <a:spcPts val="0"/>
+              </a:spcBef>
+              <a:spcAft>
+                <a:spcPts val="0"/>
+              </a:spcAft>
+              <a:buNone/>
+            </a:pPr>
+            <a:r>
+              <a:t/>
+            </a:r>
+            <a:endParaRPr/>
+          </a:p>
+        </p:txBody>
+      </p:sp>
+    </p:spTree>
+  </p:cSld>
+  <p:clrMapOvr>
+    <a:masterClrMapping/>
+  </p:clrMapOvr>
+</p:notes>
+</file>
+
+<file path=ppt/notesSlides/notesSlide15.xml><?xml version="1.0" encoding="utf-8"?>
+<p:notes xmlns:a="http://schemas.openxmlformats.org/drawingml/2006/main" xmlns:r="http://schemas.openxmlformats.org/officeDocument/2006/relationships" xmlns:mc="http://schemas.openxmlformats.org/markup-compatibility/2006" xmlns:mv="urn:schemas-microsoft-com:mac:vml" xmlns:p="http://schemas.openxmlformats.org/presentationml/2006/main" xmlns:c="http://schemas.openxmlformats.org/drawingml/2006/chart" xmlns:dgm="http://schemas.openxmlformats.org/drawingml/2006/diagram" xmlns:o="urn:schemas-microsoft-com:office:office" xmlns:v="urn:schemas-microsoft-com:vml" xmlns:pvml="urn:schemas-microsoft-com:office:powerpoint" xmlns:com="http://schemas.openxmlformats.org/drawingml/2006/compatibility" xmlns:p14="http://schemas.microsoft.com/office/powerpoint/2010/main" xmlns:p15="http://schemas.microsoft.com/office/powerpoint/2012/main" xmlns:ahyp="http://schemas.microsoft.com/office/drawing/2018/hyperlinkcolor" showMasterPhAnim="0" showMasterSp="0">
+  <p:cSld>
+    <p:spTree>
+      <p:nvGrpSpPr>
+        <p:cNvPr id="174" name="Shape 174"/>
+        <p:cNvGrpSpPr/>
+        <p:nvPr/>
+      </p:nvGrpSpPr>
+      <p:grpSpPr>
+        <a:xfrm>
+          <a:off x="0" y="0"/>
+          <a:ext cx="0" cy="0"/>
+          <a:chOff x="0" y="0"/>
+          <a:chExt cx="0" cy="0"/>
+        </a:xfrm>
+      </p:grpSpPr>
+      <p:sp>
+        <p:nvSpPr>
+          <p:cNvPr id="175" name="Google Shape;175;g3849334e9f7_0_5:notes"/>
+          <p:cNvSpPr/>
+          <p:nvPr>
+            <p:ph idx="2" type="sldImg"/>
+          </p:nvPr>
+        </p:nvSpPr>
+        <p:spPr>
+          <a:xfrm>
+            <a:off x="381300" y="685800"/>
+            <a:ext cx="6096000" cy="3429000"/>
+          </a:xfrm>
+          <a:custGeom>
+            <a:rect b="b" l="l" r="r" t="t"/>
+            <a:pathLst>
+              <a:path extrusionOk="0" h="120000" w="120000">
+                <a:moveTo>
+                  <a:pt x="0" y="0"/>
+                </a:moveTo>
+                <a:lnTo>
+                  <a:pt x="120000" y="0"/>
+                </a:lnTo>
+                <a:lnTo>
+                  <a:pt x="120000" y="120000"/>
+                </a:lnTo>
+                <a:lnTo>
+                  <a:pt x="0" y="120000"/>
+                </a:lnTo>
+                <a:close/>
+              </a:path>
+            </a:pathLst>
+          </a:custGeom>
+        </p:spPr>
+      </p:sp>
+      <p:sp>
+        <p:nvSpPr>
+          <p:cNvPr id="176" name="Google Shape;176;g3849334e9f7_0_5:notes"/>
+          <p:cNvSpPr txBox="1"/>
+          <p:nvPr>
+            <p:ph idx="1" type="body"/>
+          </p:nvPr>
+        </p:nvSpPr>
+        <p:spPr>
+          <a:xfrm>
+            <a:off x="685800" y="4343400"/>
+            <a:ext cx="5486400" cy="4114800"/>
+          </a:xfrm>
+          <a:prstGeom prst="rect">
+            <a:avLst/>
+          </a:prstGeom>
+        </p:spPr>
+        <p:txBody>
+          <a:bodyPr anchorCtr="0" anchor="t" bIns="91425" lIns="91425" spcFirstLastPara="1" rIns="91425" wrap="square" tIns="91425">
+            <a:noAutofit/>
+          </a:bodyPr>
+          <a:lstStyle/>
+          <a:p>
+            <a:pPr indent="0" lvl="0" marL="0" rtl="0" algn="l">
+              <a:spcBef>
+                <a:spcPts val="0"/>
+              </a:spcBef>
+              <a:spcAft>
+                <a:spcPts val="0"/>
+              </a:spcAft>
+              <a:buNone/>
+            </a:pPr>
+            <a:r>
+              <a:t/>
+            </a:r>
+            <a:endParaRPr/>
+          </a:p>
+        </p:txBody>
+      </p:sp>
+    </p:spTree>
+  </p:cSld>
+  <p:clrMapOvr>
+    <a:masterClrMapping/>
+  </p:clrMapOvr>
+</p:notes>
+</file>
+
+<file path=ppt/notesSlides/notesSlide16.xml><?xml version="1.0" encoding="utf-8"?>
+<p:notes xmlns:a="http://schemas.openxmlformats.org/drawingml/2006/main" xmlns:r="http://schemas.openxmlformats.org/officeDocument/2006/relationships" xmlns:mc="http://schemas.openxmlformats.org/markup-compatibility/2006" xmlns:mv="urn:schemas-microsoft-com:mac:vml" xmlns:p="http://schemas.openxmlformats.org/presentationml/2006/main" xmlns:c="http://schemas.openxmlformats.org/drawingml/2006/chart" xmlns:dgm="http://schemas.openxmlformats.org/drawingml/2006/diagram" xmlns:o="urn:schemas-microsoft-com:office:office" xmlns:v="urn:schemas-microsoft-com:vml" xmlns:pvml="urn:schemas-microsoft-com:office:powerpoint" xmlns:com="http://schemas.openxmlformats.org/drawingml/2006/compatibility" xmlns:p14="http://schemas.microsoft.com/office/powerpoint/2010/main" xmlns:p15="http://schemas.microsoft.com/office/powerpoint/2012/main" xmlns:ahyp="http://schemas.microsoft.com/office/drawing/2018/hyperlinkcolor" showMasterPhAnim="0" showMasterSp="0">
+  <p:cSld>
+    <p:spTree>
+      <p:nvGrpSpPr>
+        <p:cNvPr id="185" name="Shape 185"/>
+        <p:cNvGrpSpPr/>
+        <p:nvPr/>
+      </p:nvGrpSpPr>
+      <p:grpSpPr>
+        <a:xfrm>
+          <a:off x="0" y="0"/>
+          <a:ext cx="0" cy="0"/>
+          <a:chOff x="0" y="0"/>
+          <a:chExt cx="0" cy="0"/>
+        </a:xfrm>
+      </p:grpSpPr>
+      <p:sp>
+        <p:nvSpPr>
+          <p:cNvPr id="186" name="Google Shape;186;g3640bf93304_0_18:notes"/>
+          <p:cNvSpPr/>
+          <p:nvPr>
+            <p:ph idx="2" type="sldImg"/>
+          </p:nvPr>
+        </p:nvSpPr>
+        <p:spPr>
+          <a:xfrm>
+            <a:off x="381300" y="685800"/>
+            <a:ext cx="6096000" cy="3429000"/>
+          </a:xfrm>
+          <a:custGeom>
+            <a:rect b="b" l="l" r="r" t="t"/>
+            <a:pathLst>
+              <a:path extrusionOk="0" h="120000" w="120000">
+                <a:moveTo>
+                  <a:pt x="0" y="0"/>
+                </a:moveTo>
+                <a:lnTo>
+                  <a:pt x="120000" y="0"/>
+                </a:lnTo>
+                <a:lnTo>
+                  <a:pt x="120000" y="120000"/>
+                </a:lnTo>
+                <a:lnTo>
+                  <a:pt x="0" y="120000"/>
+                </a:lnTo>
+                <a:close/>
+              </a:path>
+            </a:pathLst>
+          </a:custGeom>
+        </p:spPr>
+      </p:sp>
+      <p:sp>
+        <p:nvSpPr>
+          <p:cNvPr id="187" name="Google Shape;187;g3640bf93304_0_18:notes"/>
           <p:cNvSpPr txBox="1"/>
           <p:nvPr>
             <p:ph idx="1" type="body"/>
@@ -1610,7 +1810,7 @@
       </p:grpSpPr>
       <p:sp>
         <p:nvSpPr>
-          <p:cNvPr id="77" name="Google Shape;77;g344f3a761b0_0_189:notes"/>
+          <p:cNvPr id="77" name="Google Shape;77;g385e4c0c131_0_0:notes"/>
           <p:cNvSpPr/>
           <p:nvPr>
             <p:ph idx="2" type="sldImg"/>
@@ -1645,7 +1845,7 @@
       </p:sp>
       <p:sp>
         <p:nvSpPr>
-          <p:cNvPr id="78" name="Google Shape;78;g344f3a761b0_0_189:notes"/>
+          <p:cNvPr id="78" name="Google Shape;78;g385e4c0c131_0_0:notes"/>
           <p:cNvSpPr txBox="1"/>
           <p:nvPr>
             <p:ph idx="1" type="body"/>
@@ -1676,7 +1876,8 @@
               <a:buNone/>
             </a:pPr>
             <a:r>
-              <a:t/>
+              <a:rPr lang="en"/>
+              <a:t>Derivative of a function is itself a function of x!</a:t>
             </a:r>
             <a:endParaRPr/>
           </a:p>
@@ -1695,7 +1896,7 @@
   <p:cSld>
     <p:spTree>
       <p:nvGrpSpPr>
-        <p:cNvPr id="88" name="Shape 88"/>
+        <p:cNvPr id="83" name="Shape 83"/>
         <p:cNvGrpSpPr/>
         <p:nvPr/>
       </p:nvGrpSpPr>
@@ -1709,7 +1910,7 @@
       </p:grpSpPr>
       <p:sp>
         <p:nvSpPr>
-          <p:cNvPr id="89" name="Google Shape;89;g384a7f1d991_0_1:notes"/>
+          <p:cNvPr id="84" name="Google Shape;84;g344f3a761b0_0_189:notes"/>
           <p:cNvSpPr/>
           <p:nvPr>
             <p:ph idx="2" type="sldImg"/>
@@ -1744,7 +1945,7 @@
       </p:sp>
       <p:sp>
         <p:nvSpPr>
-          <p:cNvPr id="90" name="Google Shape;90;g384a7f1d991_0_1:notes"/>
+          <p:cNvPr id="85" name="Google Shape;85;g344f3a761b0_0_189:notes"/>
           <p:cNvSpPr txBox="1"/>
           <p:nvPr>
             <p:ph idx="1" type="body"/>
@@ -1794,7 +1995,7 @@
   <p:cSld>
     <p:spTree>
       <p:nvGrpSpPr>
-        <p:cNvPr id="96" name="Shape 96"/>
+        <p:cNvPr id="95" name="Shape 95"/>
         <p:cNvGrpSpPr/>
         <p:nvPr/>
       </p:nvGrpSpPr>
@@ -1808,7 +2009,7 @@
       </p:grpSpPr>
       <p:sp>
         <p:nvSpPr>
-          <p:cNvPr id="97" name="Google Shape;97;g38417863650_0_11:notes"/>
+          <p:cNvPr id="96" name="Google Shape;96;g384a7f1d991_0_1:notes"/>
           <p:cNvSpPr/>
           <p:nvPr>
             <p:ph idx="2" type="sldImg"/>
@@ -1843,7 +2044,7 @@
       </p:sp>
       <p:sp>
         <p:nvSpPr>
-          <p:cNvPr id="98" name="Google Shape;98;g38417863650_0_11:notes"/>
+          <p:cNvPr id="97" name="Google Shape;97;g384a7f1d991_0_1:notes"/>
           <p:cNvSpPr txBox="1"/>
           <p:nvPr>
             <p:ph idx="1" type="body"/>
@@ -1893,7 +2094,7 @@
   <p:cSld>
     <p:spTree>
       <p:nvGrpSpPr>
-        <p:cNvPr id="107" name="Shape 107"/>
+        <p:cNvPr id="103" name="Shape 103"/>
         <p:cNvGrpSpPr/>
         <p:nvPr/>
       </p:nvGrpSpPr>
@@ -1907,7 +2108,7 @@
       </p:grpSpPr>
       <p:sp>
         <p:nvSpPr>
-          <p:cNvPr id="108" name="Google Shape;108;g344f3a761b0_0_203:notes"/>
+          <p:cNvPr id="104" name="Google Shape;104;g38417863650_0_11:notes"/>
           <p:cNvSpPr/>
           <p:nvPr>
             <p:ph idx="2" type="sldImg"/>
@@ -1942,7 +2143,7 @@
       </p:sp>
       <p:sp>
         <p:nvSpPr>
-          <p:cNvPr id="109" name="Google Shape;109;g344f3a761b0_0_203:notes"/>
+          <p:cNvPr id="105" name="Google Shape;105;g38417863650_0_11:notes"/>
           <p:cNvSpPr txBox="1"/>
           <p:nvPr>
             <p:ph idx="1" type="body"/>
@@ -1992,7 +2193,7 @@
   <p:cSld>
     <p:spTree>
       <p:nvGrpSpPr>
-        <p:cNvPr id="117" name="Shape 117"/>
+        <p:cNvPr id="114" name="Shape 114"/>
         <p:cNvGrpSpPr/>
         <p:nvPr/>
       </p:nvGrpSpPr>
@@ -2006,7 +2207,7 @@
       </p:grpSpPr>
       <p:sp>
         <p:nvSpPr>
-          <p:cNvPr id="118" name="Google Shape;118;g38417863650_0_61:notes"/>
+          <p:cNvPr id="115" name="Google Shape;115;g38917b16c82_0_0:notes"/>
           <p:cNvSpPr/>
           <p:nvPr>
             <p:ph idx="2" type="sldImg"/>
@@ -2041,7 +2242,7 @@
       </p:sp>
       <p:sp>
         <p:nvSpPr>
-          <p:cNvPr id="119" name="Google Shape;119;g38417863650_0_61:notes"/>
+          <p:cNvPr id="116" name="Google Shape;116;g38917b16c82_0_0:notes"/>
           <p:cNvSpPr txBox="1"/>
           <p:nvPr>
             <p:ph idx="1" type="body"/>
@@ -6865,7 +7066,336 @@
   <p:cSld>
     <p:spTree>
       <p:nvGrpSpPr>
-        <p:cNvPr id="127" name="Shape 127"/>
+        <p:cNvPr id="125" name="Shape 125"/>
+        <p:cNvGrpSpPr/>
+        <p:nvPr/>
+      </p:nvGrpSpPr>
+      <p:grpSpPr>
+        <a:xfrm>
+          <a:off x="0" y="0"/>
+          <a:ext cx="0" cy="0"/>
+          <a:chOff x="0" y="0"/>
+          <a:chExt cx="0" cy="0"/>
+        </a:xfrm>
+      </p:grpSpPr>
+      <p:sp>
+        <p:nvSpPr>
+          <p:cNvPr id="126" name="Google Shape;126;p22"/>
+          <p:cNvSpPr txBox="1"/>
+          <p:nvPr>
+            <p:ph idx="4294967295" type="title"/>
+          </p:nvPr>
+        </p:nvSpPr>
+        <p:spPr>
+          <a:xfrm>
+            <a:off x="259350" y="157250"/>
+            <a:ext cx="8520600" cy="572700"/>
+          </a:xfrm>
+          <a:prstGeom prst="rect">
+            <a:avLst/>
+          </a:prstGeom>
+        </p:spPr>
+        <p:txBody>
+          <a:bodyPr anchorCtr="0" anchor="t" bIns="91425" lIns="91425" spcFirstLastPara="1" rIns="91425" wrap="square" tIns="91425">
+            <a:normAutofit fontScale="90000"/>
+          </a:bodyPr>
+          <a:lstStyle/>
+          <a:p>
+            <a:pPr indent="0" lvl="0" marL="0" rtl="0" algn="l">
+              <a:spcBef>
+                <a:spcPts val="0"/>
+              </a:spcBef>
+              <a:spcAft>
+                <a:spcPts val="0"/>
+              </a:spcAft>
+              <a:buNone/>
+            </a:pPr>
+            <a:r>
+              <a:rPr lang="en"/>
+              <a:t>Derivative: Important property</a:t>
+            </a:r>
+            <a:endParaRPr/>
+          </a:p>
+        </p:txBody>
+      </p:sp>
+      <p:sp>
+        <p:nvSpPr>
+          <p:cNvPr id="127" name="Google Shape;127;p22"/>
+          <p:cNvSpPr txBox="1"/>
+          <p:nvPr/>
+        </p:nvSpPr>
+        <p:spPr>
+          <a:xfrm>
+            <a:off x="381450" y="806388"/>
+            <a:ext cx="3013800" cy="461700"/>
+          </a:xfrm>
+          <a:prstGeom prst="rect">
+            <a:avLst/>
+          </a:prstGeom>
+          <a:noFill/>
+          <a:ln>
+            <a:noFill/>
+          </a:ln>
+        </p:spPr>
+        <p:txBody>
+          <a:bodyPr anchorCtr="0" anchor="t" bIns="91425" lIns="91425" spcFirstLastPara="1" rIns="91425" wrap="square" tIns="91425">
+            <a:spAutoFit/>
+          </a:bodyPr>
+          <a:lstStyle/>
+          <a:p>
+            <a:pPr indent="0" lvl="0" marL="0" rtl="0" algn="l">
+              <a:spcBef>
+                <a:spcPts val="0"/>
+              </a:spcBef>
+              <a:spcAft>
+                <a:spcPts val="0"/>
+              </a:spcAft>
+              <a:buNone/>
+            </a:pPr>
+            <a:r>
+              <a:t/>
+            </a:r>
+            <a:endParaRPr sz="1800">
+              <a:solidFill>
+                <a:schemeClr val="dk2"/>
+              </a:solidFill>
+            </a:endParaRPr>
+          </a:p>
+        </p:txBody>
+      </p:sp>
+      <p:sp>
+        <p:nvSpPr>
+          <p:cNvPr id="128" name="Google Shape;128;p22"/>
+          <p:cNvSpPr txBox="1"/>
+          <p:nvPr/>
+        </p:nvSpPr>
+        <p:spPr>
+          <a:xfrm>
+            <a:off x="259350" y="729950"/>
+            <a:ext cx="7513800" cy="1108200"/>
+          </a:xfrm>
+          <a:prstGeom prst="rect">
+            <a:avLst/>
+          </a:prstGeom>
+          <a:noFill/>
+          <a:ln>
+            <a:noFill/>
+          </a:ln>
+        </p:spPr>
+        <p:txBody>
+          <a:bodyPr anchorCtr="0" anchor="t" bIns="91425" lIns="91425" spcFirstLastPara="1" rIns="91425" wrap="square" tIns="91425">
+            <a:spAutoFit/>
+          </a:bodyPr>
+          <a:lstStyle/>
+          <a:p>
+            <a:pPr indent="-323850" lvl="0" marL="457200" rtl="0" algn="l">
+              <a:spcBef>
+                <a:spcPts val="0"/>
+              </a:spcBef>
+              <a:spcAft>
+                <a:spcPts val="0"/>
+              </a:spcAft>
+              <a:buClr>
+                <a:schemeClr val="dk2"/>
+              </a:buClr>
+              <a:buSzPts val="1500"/>
+              <a:buChar char="-"/>
+            </a:pPr>
+            <a:r>
+              <a:rPr lang="en" sz="1500">
+                <a:solidFill>
+                  <a:schemeClr val="dk2"/>
+                </a:solidFill>
+              </a:rPr>
+              <a:t>A function can have many local </a:t>
+            </a:r>
+            <a:r>
+              <a:rPr lang="en" sz="1500">
+                <a:solidFill>
+                  <a:schemeClr val="dk2"/>
+                </a:solidFill>
+              </a:rPr>
+              <a:t>minima or maxima</a:t>
+            </a:r>
+            <a:r>
+              <a:rPr lang="en" sz="1500">
+                <a:solidFill>
+                  <a:schemeClr val="dk2"/>
+                </a:solidFill>
+              </a:rPr>
+              <a:t>! We can distinguish between minimum and maximum using the second derivative test.</a:t>
+            </a:r>
+            <a:endParaRPr sz="1500">
+              <a:solidFill>
+                <a:schemeClr val="dk2"/>
+              </a:solidFill>
+            </a:endParaRPr>
+          </a:p>
+          <a:p>
+            <a:pPr indent="-323850" lvl="0" marL="457200" rtl="0" algn="l">
+              <a:spcBef>
+                <a:spcPts val="0"/>
+              </a:spcBef>
+              <a:spcAft>
+                <a:spcPts val="0"/>
+              </a:spcAft>
+              <a:buClr>
+                <a:schemeClr val="dk2"/>
+              </a:buClr>
+              <a:buSzPts val="1500"/>
+              <a:buChar char="-"/>
+            </a:pPr>
+            <a:r>
+              <a:rPr lang="en" sz="1500">
+                <a:solidFill>
+                  <a:schemeClr val="dk2"/>
+                </a:solidFill>
+              </a:rPr>
+              <a:t>Sometimes, we can analytically solve f_prime(x) = 0, but usually not. </a:t>
+            </a:r>
+            <a:br>
+              <a:rPr lang="en" sz="1500">
+                <a:solidFill>
+                  <a:schemeClr val="dk2"/>
+                </a:solidFill>
+              </a:rPr>
+            </a:br>
+            <a:r>
+              <a:rPr lang="en" sz="1500">
+                <a:solidFill>
+                  <a:schemeClr val="dk2"/>
+                </a:solidFill>
+              </a:rPr>
+              <a:t> </a:t>
+            </a:r>
+            <a:endParaRPr sz="1500">
+              <a:solidFill>
+                <a:schemeClr val="dk2"/>
+              </a:solidFill>
+            </a:endParaRPr>
+          </a:p>
+        </p:txBody>
+      </p:sp>
+      <p:sp>
+        <p:nvSpPr>
+          <p:cNvPr id="129" name="Google Shape;129;p22"/>
+          <p:cNvSpPr txBox="1"/>
+          <p:nvPr/>
+        </p:nvSpPr>
+        <p:spPr>
+          <a:xfrm>
+            <a:off x="6002200" y="4684575"/>
+            <a:ext cx="3000000" cy="369300"/>
+          </a:xfrm>
+          <a:prstGeom prst="rect">
+            <a:avLst/>
+          </a:prstGeom>
+          <a:noFill/>
+          <a:ln>
+            <a:noFill/>
+          </a:ln>
+        </p:spPr>
+        <p:txBody>
+          <a:bodyPr anchorCtr="0" anchor="t" bIns="91425" lIns="91425" spcFirstLastPara="1" rIns="91425" wrap="square" tIns="91425">
+            <a:spAutoFit/>
+          </a:bodyPr>
+          <a:lstStyle/>
+          <a:p>
+            <a:pPr indent="0" lvl="0" marL="0" rtl="0" algn="l">
+              <a:spcBef>
+                <a:spcPts val="0"/>
+              </a:spcBef>
+              <a:spcAft>
+                <a:spcPts val="0"/>
+              </a:spcAft>
+              <a:buNone/>
+            </a:pPr>
+            <a:r>
+              <a:rPr lang="en" sz="1200">
+                <a:solidFill>
+                  <a:schemeClr val="dk2"/>
+                </a:solidFill>
+              </a:rPr>
+              <a:t>Code: multiple_local_minima.py</a:t>
+            </a:r>
+            <a:endParaRPr sz="1200">
+              <a:solidFill>
+                <a:schemeClr val="dk2"/>
+              </a:solidFill>
+            </a:endParaRPr>
+          </a:p>
+        </p:txBody>
+      </p:sp>
+      <p:pic>
+        <p:nvPicPr>
+          <p:cNvPr id="130" name="Google Shape;130;p22"/>
+          <p:cNvPicPr preferRelativeResize="0"/>
+          <p:nvPr/>
+        </p:nvPicPr>
+        <p:blipFill>
+          <a:blip r:embed="rId3">
+            <a:alphaModFix/>
+          </a:blip>
+          <a:stretch>
+            <a:fillRect/>
+          </a:stretch>
+        </p:blipFill>
+        <p:spPr>
+          <a:xfrm>
+            <a:off x="192850" y="1519650"/>
+            <a:ext cx="4085726" cy="3064301"/>
+          </a:xfrm>
+          <a:prstGeom prst="rect">
+            <a:avLst/>
+          </a:prstGeom>
+          <a:noFill/>
+          <a:ln>
+            <a:noFill/>
+          </a:ln>
+        </p:spPr>
+      </p:pic>
+      <p:pic>
+        <p:nvPicPr>
+          <p:cNvPr descr="{&quot;font&quot;:{&quot;family&quot;:&quot;Arial&quot;,&quot;size&quot;:12,&quot;color&quot;:&quot;#000000&quot;},&quot;code&quot;:&quot;\\begin{lalign*}\n&amp;{f\\left(x\\right)=\\,x^{4}-3x^{2\\,}+\\,2}\\\\\n&amp;{f^{\\prime}\\left(x\\right)=4x^{3}-6x}\\\\\n&amp;{f^{\\prime}\\left(x\\right)=0\\,\\text{at}\\;x=0,\\,x=\\pm{\\sqrt[]{3/2}}}\\\\\n&amp;{f^{\&quot;}\\left(x\\right)=12x^{2}-6}\\\\\n&amp;{\\text{At}\\;x=0,\\,f^{\&quot;}\\left(x\\right)=-6,\\,\\to\\,\\text{local}\\;\\text{maximum}}\\\\\n&amp;{\\text{At}\\;x=\\pm{\\sqrt[]{3/2}},\\,f^{\&quot;}\\left(x\\right)=12\\,\\to\\,\\text{local}\\;\\text{mimumim}}\t\n\\end{lalign*}&quot;,&quot;id&quot;:&quot;3&quot;,&quot;backgroundColorModified&quot;:false,&quot;backgroundColor&quot;:&quot;#FFFFFF&quot;,&quot;type&quot;:&quot;lalign*&quot;,&quot;aid&quot;:null,&quot;ts&quot;:1759096556198,&quot;cs&quot;:&quot;quHJXim4oEGS/g3o2jgA/A==&quot;,&quot;size&quot;:{&quot;width&quot;:389.3333333333333,&quot;height&quot;:182}}" id="131" name="Google Shape;131;p22"/>
+          <p:cNvPicPr preferRelativeResize="0"/>
+          <p:nvPr/>
+        </p:nvPicPr>
+        <p:blipFill>
+          <a:blip r:embed="rId4">
+            <a:alphaModFix/>
+          </a:blip>
+          <a:stretch>
+            <a:fillRect/>
+          </a:stretch>
+        </p:blipFill>
+        <p:spPr>
+          <a:xfrm>
+            <a:off x="4373525" y="1840488"/>
+            <a:ext cx="3708400" cy="1733550"/>
+          </a:xfrm>
+          <a:prstGeom prst="rect">
+            <a:avLst/>
+          </a:prstGeom>
+          <a:noFill/>
+          <a:ln>
+            <a:noFill/>
+          </a:ln>
+        </p:spPr>
+      </p:pic>
+    </p:spTree>
+  </p:cSld>
+  <p:clrMapOvr>
+    <a:masterClrMapping/>
+  </p:clrMapOvr>
+</p:sld>
+</file>
+
+<file path=ppt/slides/slide11.xml><?xml version="1.0" encoding="utf-8"?>
+<p:sld xmlns:a="http://schemas.openxmlformats.org/drawingml/2006/main" xmlns:r="http://schemas.openxmlformats.org/officeDocument/2006/relationships" xmlns:mc="http://schemas.openxmlformats.org/markup-compatibility/2006" xmlns:mv="urn:schemas-microsoft-com:mac:vml" xmlns:p="http://schemas.openxmlformats.org/presentationml/2006/main" xmlns:c="http://schemas.openxmlformats.org/drawingml/2006/chart" xmlns:dgm="http://schemas.openxmlformats.org/drawingml/2006/diagram" xmlns:o="urn:schemas-microsoft-com:office:office" xmlns:v="urn:schemas-microsoft-com:vml" xmlns:pvml="urn:schemas-microsoft-com:office:powerpoint" xmlns:com="http://schemas.openxmlformats.org/drawingml/2006/compatibility" xmlns:p14="http://schemas.microsoft.com/office/powerpoint/2010/main" xmlns:p15="http://schemas.microsoft.com/office/powerpoint/2012/main" xmlns:ahyp="http://schemas.microsoft.com/office/drawing/2018/hyperlinkcolor">
+  <p:cSld>
+    <p:spTree>
+      <p:nvGrpSpPr>
+        <p:cNvPr id="135" name="Shape 135"/>
         <p:cNvGrpSpPr/>
         <p:nvPr/>
       </p:nvGrpSpPr>
@@ -6879,7 +7409,7 @@
       </p:grpSpPr>
       <p:pic>
         <p:nvPicPr>
-          <p:cNvPr id="128" name="Google Shape;128;p22"/>
+          <p:cNvPr id="136" name="Google Shape;136;p23"/>
           <p:cNvPicPr preferRelativeResize="0"/>
           <p:nvPr/>
         </p:nvPicPr>
@@ -6907,7 +7437,165 @@
       </p:pic>
       <p:sp>
         <p:nvSpPr>
-          <p:cNvPr id="129" name="Google Shape;129;p22"/>
+          <p:cNvPr id="137" name="Google Shape;137;p23"/>
+          <p:cNvSpPr txBox="1"/>
+          <p:nvPr/>
+        </p:nvSpPr>
+        <p:spPr>
+          <a:xfrm>
+            <a:off x="259350" y="729950"/>
+            <a:ext cx="7513800" cy="646500"/>
+          </a:xfrm>
+          <a:prstGeom prst="rect">
+            <a:avLst/>
+          </a:prstGeom>
+          <a:noFill/>
+          <a:ln>
+            <a:noFill/>
+          </a:ln>
+        </p:spPr>
+        <p:txBody>
+          <a:bodyPr anchorCtr="0" anchor="t" bIns="91425" lIns="91425" spcFirstLastPara="1" rIns="91425" wrap="square" tIns="91425">
+            <a:spAutoFit/>
+          </a:bodyPr>
+          <a:lstStyle/>
+          <a:p>
+            <a:pPr indent="0" lvl="0" marL="0" rtl="0" algn="l">
+              <a:spcBef>
+                <a:spcPts val="0"/>
+              </a:spcBef>
+              <a:spcAft>
+                <a:spcPts val="0"/>
+              </a:spcAft>
+              <a:buNone/>
+            </a:pPr>
+            <a:r>
+              <a:rPr lang="en" sz="1500">
+                <a:solidFill>
+                  <a:schemeClr val="dk2"/>
+                </a:solidFill>
+              </a:rPr>
+              <a:t>In this case below, we can’t easily solve for f_prime(x) = 0</a:t>
+            </a:r>
+            <a:br>
+              <a:rPr lang="en" sz="1500">
+                <a:solidFill>
+                  <a:schemeClr val="dk2"/>
+                </a:solidFill>
+              </a:rPr>
+            </a:br>
+            <a:r>
+              <a:rPr lang="en" sz="1500">
+                <a:solidFill>
+                  <a:schemeClr val="dk2"/>
+                </a:solidFill>
+              </a:rPr>
+              <a:t> </a:t>
+            </a:r>
+            <a:endParaRPr sz="1500">
+              <a:solidFill>
+                <a:schemeClr val="dk2"/>
+              </a:solidFill>
+            </a:endParaRPr>
+          </a:p>
+        </p:txBody>
+      </p:sp>
+      <p:sp>
+        <p:nvSpPr>
+          <p:cNvPr id="138" name="Google Shape;138;p23"/>
+          <p:cNvSpPr txBox="1"/>
+          <p:nvPr>
+            <p:ph idx="4294967295" type="title"/>
+          </p:nvPr>
+        </p:nvSpPr>
+        <p:spPr>
+          <a:xfrm>
+            <a:off x="259350" y="157250"/>
+            <a:ext cx="8520600" cy="572700"/>
+          </a:xfrm>
+          <a:prstGeom prst="rect">
+            <a:avLst/>
+          </a:prstGeom>
+        </p:spPr>
+        <p:txBody>
+          <a:bodyPr anchorCtr="0" anchor="t" bIns="91425" lIns="91425" spcFirstLastPara="1" rIns="91425" wrap="square" tIns="91425">
+            <a:normAutofit fontScale="90000"/>
+          </a:bodyPr>
+          <a:lstStyle/>
+          <a:p>
+            <a:pPr indent="0" lvl="0" marL="0" rtl="0" algn="l">
+              <a:spcBef>
+                <a:spcPts val="0"/>
+              </a:spcBef>
+              <a:spcAft>
+                <a:spcPts val="0"/>
+              </a:spcAft>
+              <a:buNone/>
+            </a:pPr>
+            <a:r>
+              <a:rPr lang="en"/>
+              <a:t>Derivative: Important property</a:t>
+            </a:r>
+            <a:endParaRPr/>
+          </a:p>
+        </p:txBody>
+      </p:sp>
+    </p:spTree>
+  </p:cSld>
+  <p:clrMapOvr>
+    <a:masterClrMapping/>
+  </p:clrMapOvr>
+</p:sld>
+</file>
+
+<file path=ppt/slides/slide12.xml><?xml version="1.0" encoding="utf-8"?>
+<p:sld xmlns:a="http://schemas.openxmlformats.org/drawingml/2006/main" xmlns:r="http://schemas.openxmlformats.org/officeDocument/2006/relationships" xmlns:mc="http://schemas.openxmlformats.org/markup-compatibility/2006" xmlns:mv="urn:schemas-microsoft-com:mac:vml" xmlns:p="http://schemas.openxmlformats.org/presentationml/2006/main" xmlns:c="http://schemas.openxmlformats.org/drawingml/2006/chart" xmlns:dgm="http://schemas.openxmlformats.org/drawingml/2006/diagram" xmlns:o="urn:schemas-microsoft-com:office:office" xmlns:v="urn:schemas-microsoft-com:vml" xmlns:pvml="urn:schemas-microsoft-com:office:powerpoint" xmlns:com="http://schemas.openxmlformats.org/drawingml/2006/compatibility" xmlns:p14="http://schemas.microsoft.com/office/powerpoint/2010/main" xmlns:p15="http://schemas.microsoft.com/office/powerpoint/2012/main" xmlns:ahyp="http://schemas.microsoft.com/office/drawing/2018/hyperlinkcolor">
+  <p:cSld>
+    <p:spTree>
+      <p:nvGrpSpPr>
+        <p:cNvPr id="142" name="Shape 142"/>
+        <p:cNvGrpSpPr/>
+        <p:nvPr/>
+      </p:nvGrpSpPr>
+      <p:grpSpPr>
+        <a:xfrm>
+          <a:off x="0" y="0"/>
+          <a:ext cx="0" cy="0"/>
+          <a:chOff x="0" y="0"/>
+          <a:chExt cx="0" cy="0"/>
+        </a:xfrm>
+      </p:grpSpPr>
+      <p:pic>
+        <p:nvPicPr>
+          <p:cNvPr id="143" name="Google Shape;143;p24"/>
+          <p:cNvPicPr preferRelativeResize="0"/>
+          <p:nvPr/>
+        </p:nvPicPr>
+        <p:blipFill>
+          <a:blip r:embed="rId3">
+            <a:alphaModFix/>
+          </a:blip>
+          <a:stretch>
+            <a:fillRect/>
+          </a:stretch>
+        </p:blipFill>
+        <p:spPr>
+          <a:xfrm>
+            <a:off x="340100" y="1449475"/>
+            <a:ext cx="4124400" cy="3049964"/>
+          </a:xfrm>
+          <a:prstGeom prst="rect">
+            <a:avLst/>
+          </a:prstGeom>
+          <a:noFill/>
+          <a:ln>
+            <a:noFill/>
+          </a:ln>
+        </p:spPr>
+      </p:pic>
+      <p:sp>
+        <p:nvSpPr>
+          <p:cNvPr id="144" name="Google Shape;144;p24"/>
           <p:cNvSpPr txBox="1"/>
           <p:nvPr/>
         </p:nvSpPr>
@@ -6957,7 +7645,7 @@
       </p:sp>
       <p:sp>
         <p:nvSpPr>
-          <p:cNvPr id="130" name="Google Shape;130;p22"/>
+          <p:cNvPr id="145" name="Google Shape;145;p24"/>
           <p:cNvSpPr txBox="1"/>
           <p:nvPr>
             <p:ph idx="4294967295" type="title"/>
@@ -6997,7 +7685,7 @@
       </p:sp>
       <p:pic>
         <p:nvPicPr>
-          <p:cNvPr descr="{&quot;backgroundColor&quot;:&quot;#FFFFFF&quot;,&quot;id&quot;:&quot;4&quot;,&quot;code&quot;:&quot;$$x_{t+1}=x_{t}-\\eta _{t}f^{\\prime}\\left(x_{t}\\right)$$&quot;,&quot;type&quot;:&quot;$$&quot;,&quot;aid&quot;:null,&quot;font&quot;:{&quot;size&quot;:19.5,&quot;color&quot;:&quot;#000000&quot;,&quot;family&quot;:&quot;Arial&quot;},&quot;backgroundColorModified&quot;:false,&quot;ts&quot;:1759099433651,&quot;cs&quot;:&quot;q81oGM4uyhEVauqAthXJgQ==&quot;,&quot;size&quot;:{&quot;width&quot;:266.20000000000005,&quot;height&quot;:32.600000000000016}}" id="131" name="Google Shape;131;p22"/>
+          <p:cNvPr descr="{&quot;backgroundColor&quot;:&quot;#FFFFFF&quot;,&quot;id&quot;:&quot;4&quot;,&quot;code&quot;:&quot;$$x_{t+1}=x_{t}-\\eta _{t}f^{\\prime}\\left(x_{t}\\right)$$&quot;,&quot;type&quot;:&quot;$$&quot;,&quot;aid&quot;:null,&quot;font&quot;:{&quot;size&quot;:19.5,&quot;color&quot;:&quot;#000000&quot;,&quot;family&quot;:&quot;Arial&quot;},&quot;backgroundColorModified&quot;:false,&quot;ts&quot;:1759099433651,&quot;cs&quot;:&quot;q81oGM4uyhEVauqAthXJgQ==&quot;,&quot;size&quot;:{&quot;width&quot;:266.20000000000005,&quot;height&quot;:32.600000000000016}}" id="146" name="Google Shape;146;p24"/>
           <p:cNvPicPr preferRelativeResize="0"/>
           <p:nvPr/>
         </p:nvPicPr>
@@ -7025,7 +7713,7 @@
       </p:pic>
       <p:sp>
         <p:nvSpPr>
-          <p:cNvPr id="132" name="Google Shape;132;p22"/>
+          <p:cNvPr id="147" name="Google Shape;147;p24"/>
           <p:cNvSpPr txBox="1"/>
           <p:nvPr/>
         </p:nvSpPr>
@@ -7083,9 +7771,9 @@
       </p:sp>
       <p:cxnSp>
         <p:nvCxnSpPr>
-          <p:cNvPr id="133" name="Google Shape;133;p22"/>
+          <p:cNvPr id="148" name="Google Shape;148;p24"/>
           <p:cNvCxnSpPr>
-            <a:stCxn id="132" idx="0"/>
+            <a:stCxn id="147" idx="0"/>
           </p:cNvCxnSpPr>
           <p:nvPr/>
         </p:nvCxnSpPr>
@@ -7111,7 +7799,7 @@
       </p:cxnSp>
       <p:sp>
         <p:nvSpPr>
-          <p:cNvPr id="134" name="Google Shape;134;p22"/>
+          <p:cNvPr id="149" name="Google Shape;149;p24"/>
           <p:cNvSpPr txBox="1"/>
           <p:nvPr/>
         </p:nvSpPr>
@@ -7161,9 +7849,9 @@
       </p:sp>
       <p:cxnSp>
         <p:nvCxnSpPr>
-          <p:cNvPr id="135" name="Google Shape;135;p22"/>
+          <p:cNvPr id="150" name="Google Shape;150;p24"/>
           <p:cNvCxnSpPr>
-            <a:stCxn id="134" idx="0"/>
+            <a:stCxn id="149" idx="0"/>
           </p:cNvCxnSpPr>
           <p:nvPr/>
         </p:nvCxnSpPr>
@@ -7189,7 +7877,7 @@
       </p:cxnSp>
       <p:sp>
         <p:nvSpPr>
-          <p:cNvPr id="136" name="Google Shape;136;p22"/>
+          <p:cNvPr id="151" name="Google Shape;151;p24"/>
           <p:cNvSpPr txBox="1"/>
           <p:nvPr/>
         </p:nvSpPr>
@@ -7329,12 +8017,12 @@
 </p:sld>
 </file>
 
-<file path=ppt/slides/slide11.xml><?xml version="1.0" encoding="utf-8"?>
+<file path=ppt/slides/slide13.xml><?xml version="1.0" encoding="utf-8"?>
 <p:sld xmlns:a="http://schemas.openxmlformats.org/drawingml/2006/main" xmlns:r="http://schemas.openxmlformats.org/officeDocument/2006/relationships" xmlns:mc="http://schemas.openxmlformats.org/markup-compatibility/2006" xmlns:mv="urn:schemas-microsoft-com:mac:vml" xmlns:p="http://schemas.openxmlformats.org/presentationml/2006/main" xmlns:c="http://schemas.openxmlformats.org/drawingml/2006/chart" xmlns:dgm="http://schemas.openxmlformats.org/drawingml/2006/diagram" xmlns:o="urn:schemas-microsoft-com:office:office" xmlns:v="urn:schemas-microsoft-com:vml" xmlns:pvml="urn:schemas-microsoft-com:office:powerpoint" xmlns:com="http://schemas.openxmlformats.org/drawingml/2006/compatibility" xmlns:p14="http://schemas.microsoft.com/office/powerpoint/2010/main" xmlns:p15="http://schemas.microsoft.com/office/powerpoint/2012/main" xmlns:ahyp="http://schemas.microsoft.com/office/drawing/2018/hyperlinkcolor">
   <p:cSld>
     <p:spTree>
       <p:nvGrpSpPr>
-        <p:cNvPr id="140" name="Shape 140"/>
+        <p:cNvPr id="155" name="Shape 155"/>
         <p:cNvGrpSpPr/>
         <p:nvPr/>
       </p:nvGrpSpPr>
@@ -7348,7 +8036,7 @@
       </p:grpSpPr>
       <p:sp>
         <p:nvSpPr>
-          <p:cNvPr id="141" name="Google Shape;141;p23"/>
+          <p:cNvPr id="156" name="Google Shape;156;p25"/>
           <p:cNvSpPr txBox="1"/>
           <p:nvPr/>
         </p:nvSpPr>
@@ -7398,7 +8086,7 @@
       </p:sp>
       <p:sp>
         <p:nvSpPr>
-          <p:cNvPr id="142" name="Google Shape;142;p23"/>
+          <p:cNvPr id="157" name="Google Shape;157;p25"/>
           <p:cNvSpPr txBox="1"/>
           <p:nvPr>
             <p:ph idx="4294967295" type="title"/>
@@ -7438,7 +8126,7 @@
       </p:sp>
       <p:pic>
         <p:nvPicPr>
-          <p:cNvPr descr="{&quot;backgroundColor&quot;:&quot;#FFFFFF&quot;,&quot;id&quot;:&quot;4&quot;,&quot;code&quot;:&quot;$$x_{t+1}=x_{t}-\\eta _{t}f^{\\prime}\\left(x_{t}\\right)$$&quot;,&quot;type&quot;:&quot;$$&quot;,&quot;aid&quot;:null,&quot;font&quot;:{&quot;size&quot;:19.5,&quot;color&quot;:&quot;#000000&quot;,&quot;family&quot;:&quot;Arial&quot;},&quot;backgroundColorModified&quot;:false,&quot;ts&quot;:1759099433651,&quot;cs&quot;:&quot;q81oGM4uyhEVauqAthXJgQ==&quot;,&quot;size&quot;:{&quot;width&quot;:266.20000000000005,&quot;height&quot;:32.600000000000016}}" id="143" name="Google Shape;143;p23"/>
+          <p:cNvPr descr="{&quot;backgroundColor&quot;:&quot;#FFFFFF&quot;,&quot;id&quot;:&quot;4&quot;,&quot;code&quot;:&quot;$$x_{t+1}=x_{t}-\\eta _{t}f^{\\prime}\\left(x_{t}\\right)$$&quot;,&quot;type&quot;:&quot;$$&quot;,&quot;aid&quot;:null,&quot;font&quot;:{&quot;size&quot;:19.5,&quot;color&quot;:&quot;#000000&quot;,&quot;family&quot;:&quot;Arial&quot;},&quot;backgroundColorModified&quot;:false,&quot;ts&quot;:1759099433651,&quot;cs&quot;:&quot;q81oGM4uyhEVauqAthXJgQ==&quot;,&quot;size&quot;:{&quot;width&quot;:266.20000000000005,&quot;height&quot;:32.600000000000016}}" id="158" name="Google Shape;158;p25"/>
           <p:cNvPicPr preferRelativeResize="0"/>
           <p:nvPr/>
         </p:nvPicPr>
@@ -7466,7 +8154,7 @@
       </p:pic>
       <p:sp>
         <p:nvSpPr>
-          <p:cNvPr id="144" name="Google Shape;144;p23"/>
+          <p:cNvPr id="159" name="Google Shape;159;p25"/>
           <p:cNvSpPr txBox="1"/>
           <p:nvPr/>
         </p:nvSpPr>
@@ -7516,9 +8204,9 @@
       </p:sp>
       <p:cxnSp>
         <p:nvCxnSpPr>
-          <p:cNvPr id="145" name="Google Shape;145;p23"/>
+          <p:cNvPr id="160" name="Google Shape;160;p25"/>
           <p:cNvCxnSpPr>
-            <a:stCxn id="144" idx="0"/>
+            <a:stCxn id="159" idx="0"/>
           </p:cNvCxnSpPr>
           <p:nvPr/>
         </p:nvCxnSpPr>
@@ -7544,7 +8232,7 @@
       </p:cxnSp>
       <p:sp>
         <p:nvSpPr>
-          <p:cNvPr id="146" name="Google Shape;146;p23"/>
+          <p:cNvPr id="161" name="Google Shape;161;p25"/>
           <p:cNvSpPr txBox="1"/>
           <p:nvPr/>
         </p:nvSpPr>
@@ -7594,9 +8282,9 @@
       </p:sp>
       <p:cxnSp>
         <p:nvCxnSpPr>
-          <p:cNvPr id="147" name="Google Shape;147;p23"/>
+          <p:cNvPr id="162" name="Google Shape;162;p25"/>
           <p:cNvCxnSpPr>
-            <a:stCxn id="146" idx="0"/>
+            <a:stCxn id="161" idx="0"/>
           </p:cNvCxnSpPr>
           <p:nvPr/>
         </p:nvCxnSpPr>
@@ -7622,7 +8310,7 @@
       </p:cxnSp>
       <p:pic>
         <p:nvPicPr>
-          <p:cNvPr id="148" name="Google Shape;148;p23"/>
+          <p:cNvPr id="163" name="Google Shape;163;p25"/>
           <p:cNvPicPr preferRelativeResize="0"/>
           <p:nvPr/>
         </p:nvPicPr>
@@ -7656,12 +8344,12 @@
 </p:sld>
 </file>
 
-<file path=ppt/slides/slide12.xml><?xml version="1.0" encoding="utf-8"?>
+<file path=ppt/slides/slide14.xml><?xml version="1.0" encoding="utf-8"?>
 <p:sld xmlns:a="http://schemas.openxmlformats.org/drawingml/2006/main" xmlns:r="http://schemas.openxmlformats.org/officeDocument/2006/relationships" xmlns:mc="http://schemas.openxmlformats.org/markup-compatibility/2006" xmlns:mv="urn:schemas-microsoft-com:mac:vml" xmlns:p="http://schemas.openxmlformats.org/presentationml/2006/main" xmlns:c="http://schemas.openxmlformats.org/drawingml/2006/chart" xmlns:dgm="http://schemas.openxmlformats.org/drawingml/2006/diagram" xmlns:o="urn:schemas-microsoft-com:office:office" xmlns:v="urn:schemas-microsoft-com:vml" xmlns:pvml="urn:schemas-microsoft-com:office:powerpoint" xmlns:com="http://schemas.openxmlformats.org/drawingml/2006/compatibility" xmlns:p14="http://schemas.microsoft.com/office/powerpoint/2010/main" xmlns:p15="http://schemas.microsoft.com/office/powerpoint/2012/main" xmlns:ahyp="http://schemas.microsoft.com/office/drawing/2018/hyperlinkcolor">
   <p:cSld>
     <p:spTree>
       <p:nvGrpSpPr>
-        <p:cNvPr id="152" name="Shape 152"/>
+        <p:cNvPr id="167" name="Shape 167"/>
         <p:cNvGrpSpPr/>
         <p:nvPr/>
       </p:nvGrpSpPr>
@@ -7675,7 +8363,7 @@
       </p:grpSpPr>
       <p:sp>
         <p:nvSpPr>
-          <p:cNvPr id="153" name="Google Shape;153;p24"/>
+          <p:cNvPr id="168" name="Google Shape;168;p26"/>
           <p:cNvSpPr txBox="1"/>
           <p:nvPr>
             <p:ph idx="4294967295" type="title"/>
@@ -7715,7 +8403,7 @@
       </p:sp>
       <p:sp>
         <p:nvSpPr>
-          <p:cNvPr id="154" name="Google Shape;154;p24"/>
+          <p:cNvPr id="169" name="Google Shape;169;p26"/>
           <p:cNvSpPr txBox="1"/>
           <p:nvPr/>
         </p:nvSpPr>
@@ -7760,7 +8448,7 @@
       </p:sp>
       <p:sp>
         <p:nvSpPr>
-          <p:cNvPr id="155" name="Google Shape;155;p24"/>
+          <p:cNvPr id="170" name="Google Shape;170;p26"/>
           <p:cNvSpPr txBox="1"/>
           <p:nvPr/>
         </p:nvSpPr>
@@ -7810,7 +8498,7 @@
       </p:sp>
       <p:sp>
         <p:nvSpPr>
-          <p:cNvPr id="156" name="Google Shape;156;p24"/>
+          <p:cNvPr id="171" name="Google Shape;171;p26"/>
           <p:cNvSpPr txBox="1"/>
           <p:nvPr/>
         </p:nvSpPr>
@@ -7860,7 +8548,7 @@
       </p:sp>
       <p:pic>
         <p:nvPicPr>
-          <p:cNvPr id="157" name="Google Shape;157;p24"/>
+          <p:cNvPr id="172" name="Google Shape;172;p26"/>
           <p:cNvPicPr preferRelativeResize="0"/>
           <p:nvPr/>
         </p:nvPicPr>
@@ -7888,7 +8576,7 @@
       </p:pic>
       <p:pic>
         <p:nvPicPr>
-          <p:cNvPr id="158" name="Google Shape;158;p24"/>
+          <p:cNvPr id="173" name="Google Shape;173;p26"/>
           <p:cNvPicPr preferRelativeResize="0"/>
           <p:nvPr/>
         </p:nvPicPr>
@@ -7922,12 +8610,12 @@
 </p:sld>
 </file>
 
-<file path=ppt/slides/slide13.xml><?xml version="1.0" encoding="utf-8"?>
+<file path=ppt/slides/slide15.xml><?xml version="1.0" encoding="utf-8"?>
 <p:sld xmlns:a="http://schemas.openxmlformats.org/drawingml/2006/main" xmlns:r="http://schemas.openxmlformats.org/officeDocument/2006/relationships" xmlns:mc="http://schemas.openxmlformats.org/markup-compatibility/2006" xmlns:mv="urn:schemas-microsoft-com:mac:vml" xmlns:p="http://schemas.openxmlformats.org/presentationml/2006/main" xmlns:c="http://schemas.openxmlformats.org/drawingml/2006/chart" xmlns:dgm="http://schemas.openxmlformats.org/drawingml/2006/diagram" xmlns:o="urn:schemas-microsoft-com:office:office" xmlns:v="urn:schemas-microsoft-com:vml" xmlns:pvml="urn:schemas-microsoft-com:office:powerpoint" xmlns:com="http://schemas.openxmlformats.org/drawingml/2006/compatibility" xmlns:p14="http://schemas.microsoft.com/office/powerpoint/2010/main" xmlns:p15="http://schemas.microsoft.com/office/powerpoint/2012/main" xmlns:ahyp="http://schemas.microsoft.com/office/drawing/2018/hyperlinkcolor">
   <p:cSld>
     <p:spTree>
       <p:nvGrpSpPr>
-        <p:cNvPr id="162" name="Shape 162"/>
+        <p:cNvPr id="177" name="Shape 177"/>
         <p:cNvGrpSpPr/>
         <p:nvPr/>
       </p:nvGrpSpPr>
@@ -7941,7 +8629,7 @@
       </p:grpSpPr>
       <p:sp>
         <p:nvSpPr>
-          <p:cNvPr id="163" name="Google Shape;163;p25"/>
+          <p:cNvPr id="178" name="Google Shape;178;p27"/>
           <p:cNvSpPr txBox="1"/>
           <p:nvPr>
             <p:ph idx="4294967295" type="title"/>
@@ -7981,7 +8669,7 @@
       </p:sp>
       <p:sp>
         <p:nvSpPr>
-          <p:cNvPr id="164" name="Google Shape;164;p25"/>
+          <p:cNvPr id="179" name="Google Shape;179;p27"/>
           <p:cNvSpPr txBox="1"/>
           <p:nvPr/>
         </p:nvSpPr>
@@ -8026,7 +8714,7 @@
       </p:sp>
       <p:sp>
         <p:nvSpPr>
-          <p:cNvPr id="165" name="Google Shape;165;p25"/>
+          <p:cNvPr id="180" name="Google Shape;180;p27"/>
           <p:cNvSpPr txBox="1"/>
           <p:nvPr/>
         </p:nvSpPr>
@@ -8071,7 +8759,7 @@
       </p:sp>
       <p:pic>
         <p:nvPicPr>
-          <p:cNvPr descr="{&quot;code&quot;:&quot;\\begin{lalign*}\n&amp;{\\text{Calculate}\\;\\text{derivatives}\\;\\text{of:}}\\\\\n&amp;{f\\left(x\\right)\\,=\\,\\left(3x^{2}+1\\right)\\left(5x+2\\right)\\,\\text{using}\\;\\text{product}\\;\\text{rule}}\\\\\n&amp;{f\\left(x\\right)=\\frac{x^{2}+1}{2x-3}\\text{using}\\;\\text{quotient}\\;\\text{rule}}\\\\\n&amp;{f\\left(x\\right)=\\sin\\left(3x^{2}\\right)\\,\\text{using}\\;\\text{chain}\\;\\text{rule}}\\\\\n&amp;{f\\left(x\\right)=x\\sigma\\left(x\\right),\\,\\text{where}\\;\\sigma\\left(x\\right)=\\frac{1}{1+e^{-x}}}\\\\\n&amp;{}\t\n\\end{lalign*}&quot;,&quot;backgroundColor&quot;:&quot;#FFFFFF&quot;,&quot;type&quot;:&quot;lalign*&quot;,&quot;id&quot;:&quot;2&quot;,&quot;backgroundColorModified&quot;:false,&quot;font&quot;:{&quot;family&quot;:&quot;Arial&quot;,&quot;color&quot;:&quot;#000000&quot;,&quot;size&quot;:12},&quot;aid&quot;:null,&quot;ts&quot;:1759187517188,&quot;cs&quot;:&quot;nB7DipQgoPNqVYbHBxDYcA==&quot;,&quot;size&quot;:{&quot;width&quot;:368.3333333333333,&quot;height&quot;:169.33333333333334}}" id="166" name="Google Shape;166;p25"/>
+          <p:cNvPr descr="{&quot;code&quot;:&quot;\\begin{lalign*}\n&amp;{\\text{Calculate}\\;\\text{derivatives}\\;\\text{of:}}\\\\\n&amp;{f\\left(x\\right)\\,=\\,\\left(3x^{2}+1\\right)\\left(5x+2\\right)\\,\\text{using}\\;\\text{product}\\;\\text{rule}}\\\\\n&amp;{f\\left(x\\right)=\\frac{x^{2}+1}{2x-3}\\text{using}\\;\\text{quotient}\\;\\text{rule}}\\\\\n&amp;{f\\left(x\\right)=\\sin\\left(3x^{2}\\right)\\,\\text{using}\\;\\text{chain}\\;\\text{rule}}\\\\\n&amp;{f\\left(x\\right)=x\\sigma\\left(x\\right),\\,\\text{where}\\;\\sigma\\left(x\\right)=\\frac{1}{1+e^{-x}}}\\\\\n&amp;{}\t\n\\end{lalign*}&quot;,&quot;backgroundColor&quot;:&quot;#FFFFFF&quot;,&quot;type&quot;:&quot;lalign*&quot;,&quot;id&quot;:&quot;2&quot;,&quot;backgroundColorModified&quot;:false,&quot;font&quot;:{&quot;family&quot;:&quot;Arial&quot;,&quot;color&quot;:&quot;#000000&quot;,&quot;size&quot;:12},&quot;aid&quot;:null,&quot;ts&quot;:1759187517188,&quot;cs&quot;:&quot;nB7DipQgoPNqVYbHBxDYcA==&quot;,&quot;size&quot;:{&quot;width&quot;:368.3333333333333,&quot;height&quot;:169.33333333333334}}" id="181" name="Google Shape;181;p27"/>
           <p:cNvPicPr preferRelativeResize="0"/>
           <p:nvPr/>
         </p:nvPicPr>
@@ -8099,7 +8787,7 @@
       </p:pic>
       <p:pic>
         <p:nvPicPr>
-          <p:cNvPr descr="{&quot;type&quot;:&quot;lalign*&quot;,&quot;aid&quot;:null,&quot;code&quot;:&quot;\\begin{lalign*}\n&amp;{\\text{Calculate}\\;\\text{critical}\\;\\text{points}\\;\\text{(minima/maxima}\\text{)}\\;\\text{of}}\\\\\n&amp;{f\\left(x\\right)\\,=\\,x^{3}-6x^{2}+9x.\\,\\text{Use}\\;\\text{second}\\;\\text{derivative}\\;\\text{test}}\\\\\n&amp;{\\text{to}\\;\\text{classify}\\;\\text{minima/maxima}}\\\\\n&amp;{\\text{Explain}\\;\\text{why}\\;\\text{gradient}\\;\\text{descent}\\;\\text{on}\\;f\\left(x\\right)=\\left(x-2\\right)^{2}\\,\\text{converges}}\\\\\n&amp;{\\text{to}\\;\\text{the}\\;\\text{same}\\;\\text{minimum}\\;\\text{(2)}\\;\\text{from}\\;\\text{any}\\;\\text{starting}\\;\\text{point}}\t\n\\end{lalign*}&quot;,&quot;backgroundColorModified&quot;:false,&quot;backgroundColor&quot;:&quot;#FFFFFF&quot;,&quot;font&quot;:{&quot;color&quot;:&quot;#000000&quot;,&quot;family&quot;:&quot;Arial&quot;,&quot;size&quot;:12},&quot;id&quot;:&quot;2&quot;,&quot;ts&quot;:1759187866334,&quot;cs&quot;:&quot;+LvwsusBs/gPeNPvYxh7ag==&quot;,&quot;size&quot;:{&quot;width&quot;:482.3333333333333,&quot;height&quot;:122.66666666666667}}" id="167" name="Google Shape;167;p25"/>
+          <p:cNvPr descr="{&quot;type&quot;:&quot;lalign*&quot;,&quot;aid&quot;:null,&quot;code&quot;:&quot;\\begin{lalign*}\n&amp;{\\text{Calculate}\\;\\text{critical}\\;\\text{points}\\;\\text{(minima/maxima}\\text{)}\\;\\text{of}}\\\\\n&amp;{f\\left(x\\right)\\,=\\,x^{3}-6x^{2}+9x.\\,\\text{Use}\\;\\text{second}\\;\\text{derivative}\\;\\text{test}}\\\\\n&amp;{\\text{to}\\;\\text{classify}\\;\\text{minima/maxima}}\\\\\n&amp;{\\text{Explain}\\;\\text{why}\\;\\text{gradient}\\;\\text{descent}\\;\\text{on}\\;f\\left(x\\right)=\\left(x-2\\right)^{2}\\,\\text{converges}}\\\\\n&amp;{\\text{to}\\;\\text{the}\\;\\text{same}\\;\\text{minimum}\\;\\text{(2)}\\;\\text{from}\\;\\text{any}\\;\\text{starting}\\;\\text{point}}\t\n\\end{lalign*}&quot;,&quot;backgroundColorModified&quot;:false,&quot;backgroundColor&quot;:&quot;#FFFFFF&quot;,&quot;font&quot;:{&quot;color&quot;:&quot;#000000&quot;,&quot;family&quot;:&quot;Arial&quot;,&quot;size&quot;:12},&quot;id&quot;:&quot;2&quot;,&quot;ts&quot;:1759187866334,&quot;cs&quot;:&quot;+LvwsusBs/gPeNPvYxh7ag==&quot;,&quot;size&quot;:{&quot;width&quot;:482.3333333333333,&quot;height&quot;:122.66666666666667}}" id="182" name="Google Shape;182;p27"/>
           <p:cNvPicPr preferRelativeResize="0"/>
           <p:nvPr/>
         </p:nvPicPr>
@@ -8127,7 +8815,7 @@
       </p:pic>
       <p:sp>
         <p:nvSpPr>
-          <p:cNvPr id="168" name="Google Shape;168;p25"/>
+          <p:cNvPr id="183" name="Google Shape;183;p27"/>
           <p:cNvSpPr txBox="1"/>
           <p:nvPr/>
         </p:nvSpPr>
@@ -8185,7 +8873,7 @@
       </p:sp>
       <p:sp>
         <p:nvSpPr>
-          <p:cNvPr id="169" name="Google Shape;169;p25"/>
+          <p:cNvPr id="184" name="Google Shape;184;p27"/>
           <p:cNvSpPr txBox="1"/>
           <p:nvPr/>
         </p:nvSpPr>
@@ -8249,12 +8937,12 @@
 </p:sld>
 </file>
 
-<file path=ppt/slides/slide14.xml><?xml version="1.0" encoding="utf-8"?>
+<file path=ppt/slides/slide16.xml><?xml version="1.0" encoding="utf-8"?>
 <p:sld xmlns:a="http://schemas.openxmlformats.org/drawingml/2006/main" xmlns:r="http://schemas.openxmlformats.org/officeDocument/2006/relationships" xmlns:mc="http://schemas.openxmlformats.org/markup-compatibility/2006" xmlns:mv="urn:schemas-microsoft-com:mac:vml" xmlns:p="http://schemas.openxmlformats.org/presentationml/2006/main" xmlns:c="http://schemas.openxmlformats.org/drawingml/2006/chart" xmlns:dgm="http://schemas.openxmlformats.org/drawingml/2006/diagram" xmlns:o="urn:schemas-microsoft-com:office:office" xmlns:v="urn:schemas-microsoft-com:vml" xmlns:pvml="urn:schemas-microsoft-com:office:powerpoint" xmlns:com="http://schemas.openxmlformats.org/drawingml/2006/compatibility" xmlns:p14="http://schemas.microsoft.com/office/powerpoint/2010/main" xmlns:p15="http://schemas.microsoft.com/office/powerpoint/2012/main" xmlns:ahyp="http://schemas.microsoft.com/office/drawing/2018/hyperlinkcolor">
   <p:cSld>
     <p:spTree>
       <p:nvGrpSpPr>
-        <p:cNvPr id="173" name="Shape 173"/>
+        <p:cNvPr id="188" name="Shape 188"/>
         <p:cNvGrpSpPr/>
         <p:nvPr/>
       </p:nvGrpSpPr>
@@ -8268,7 +8956,7 @@
       </p:grpSpPr>
       <p:sp>
         <p:nvSpPr>
-          <p:cNvPr id="174" name="Google Shape;174;p26"/>
+          <p:cNvPr id="189" name="Google Shape;189;p28"/>
           <p:cNvSpPr txBox="1"/>
           <p:nvPr>
             <p:ph idx="4294967295" type="title"/>
@@ -8308,7 +8996,7 @@
       </p:sp>
       <p:sp>
         <p:nvSpPr>
-          <p:cNvPr id="175" name="Google Shape;175;p26"/>
+          <p:cNvPr id="190" name="Google Shape;190;p28"/>
           <p:cNvSpPr txBox="1"/>
           <p:nvPr/>
         </p:nvSpPr>
@@ -8353,7 +9041,7 @@
       </p:sp>
       <p:sp>
         <p:nvSpPr>
-          <p:cNvPr id="176" name="Google Shape;176;p26"/>
+          <p:cNvPr id="191" name="Google Shape;191;p28"/>
           <p:cNvSpPr txBox="1"/>
           <p:nvPr/>
         </p:nvSpPr>
@@ -8398,7 +9086,7 @@
       </p:sp>
       <p:pic>
         <p:nvPicPr>
-          <p:cNvPr descr="{&quot;font&quot;:{&quot;family&quot;:&quot;Arial&quot;,&quot;size&quot;:12,&quot;color&quot;:&quot;#000000&quot;},&quot;code&quot;:&quot;\\begin{lalign*}\n&amp;{\\text{1.}\\;\\text{}\\text{Calculate}\\;\\int_{0}^{1}x^{2}dx\\,\\text{manually}\\;\\text{and}\\;\\text{using}\\;\\text{numerical}\\;\\text{approximation}.\\,}\\\\\n&amp;{\\text{Calculate}\\;\\text{the}\\;\\text{area}\\;\\text{of}\\;\\text{the}\\;\\text{quadilaterals}\\;\\text{under}\\;\\text{the}\\;\\text{curve}\\;\\text{using}\\;\\text{a}\\;\\text{trapezoid}\\;\\text{}}\\\\\n&amp;{\\text{approximation.}\\;\\text{Vary}\\;\\text{the}\\;\\text{number}\\;\\text{of}\\;\\text{trapezoids.}\\;\\text{}}\\\\\n&amp;{2.\\,\\text{Numerical}\\;\\text{approximation}\\;\\text{of}\\;\\text{the}\\;\\text{derivative}\\;\\text{of}\\;x^{2}\\text{at}\\;x=2,\\,\\text{for}\\;\\text{different}\\;\\text{values}}\\\\\n&amp;{\\text{of}\\;\\delta x\\,\\text{(0.1,}\\;\\text{0.01,}\\;\\text{0.002).}\\;\\text{Compare}\\;\\text{with}\\;\\text{the}\\;\\text{exact}\\;\\text{value}\\;\\text{of}\\;\\text{the}\\;\\text{derivative}}\\\\\n&amp;{3.\\,\\text{Implement}\\;\\text{gradient}\\;\\text{descent}\\;\\text{for}\\;f\\left(x\\right)=\\left(x-3\\right)^{2}\\,\\text{starting}\\;\\text{with}\\;\\text{different}\\;\\text{values}\\text{}}\\\\\n&amp;{\\text{of}\\;\\text{starting}\\;\\text{points.}\\;\\text{Try}\\;\\text{different}\\;\\text{values}\\;\\text{of}\\;\\text{the}\\;\\text{learning}\\;\\text{rate}\\;\\text{(0.1,}\\;\\text{0.5)}}\\\\\n&amp;{}\t\n\\end{lalign*}&quot;,&quot;type&quot;:&quot;lalign*&quot;,&quot;backgroundColorModified&quot;:false,&quot;id&quot;:&quot;5&quot;,&quot;aid&quot;:null,&quot;backgroundColor&quot;:&quot;#FFFFFF&quot;,&quot;ts&quot;:1759189729748,&quot;cs&quot;:&quot;RA48TYB0GGK8minOmdaXdA==&quot;,&quot;size&quot;:{&quot;width&quot;:645,&quot;height&quot;:199}}" id="177" name="Google Shape;177;p26"/>
+          <p:cNvPr descr="{&quot;code&quot;:&quot;\\begin{lalign*}\n&amp;{\\text{1.}\\;\\text{}\\text{Calculate}\\;\\int_{0}^{1}x^{2}dx\\,\\text{manually}\\;\\text{and}\\;\\text{using}\\;\\text{numerical}\\;\\text{approximation}.\\,}\\\\\n&amp;{\\text{Calculate}\\;\\text{the}\\;\\text{area}\\;\\text{of}\\;\\text{the}\\;\\text{quadilaterals}\\;\\text{under}\\;\\text{the}\\;\\text{curve}\\;\\text{using}\\;\\text{a}\\;\\text{trapezoid}\\;\\text{}}\\\\\n&amp;{\\text{approximation.}\\;\\text{Vary}\\;\\text{the}\\;\\text{number}\\;\\text{of}\\;\\text{trapezoids.}\\;\\text{}}\\\\\n&amp;{2.\\,\\text{Using}\\;\\text{numerical}\\;\\text{approximation}\\;\\text{(use}\\;\\text{central}\\;\\text{difference),}\\;}\\\\\n&amp;{\\text{calculate}\\;\\text{derivative}\\;\\text{of}\\;x^{2}\\text{at}\\;x=2,\\,\\text{for}\\;\\text{different}\\;\\text{values}}\\\\\n&amp;{\\text{of}\\;\\delta x\\,\\text{(0.1,}\\;\\text{0.01,}\\;\\text{0.002).}\\;\\text{Compare}\\;\\text{with}\\;\\text{the}\\;\\text{exact}\\;\\text{value}\\;\\text{of}\\;\\text{the}\\;\\text{derivative}}\\\\\n&amp;{3.\\,\\text{Implement}\\;\\text{gradient}\\;\\text{descent}\\;\\text{for}\\;f\\left(x\\right)=\\left(x-3\\right)^{2}\\,\\text{starting}\\;\\text{with}\\;\\text{different}\\;\\text{values}\\text{}}\\\\\n&amp;{\\text{of}\\;\\text{starting}\\;\\text{points.}\\;\\text{Try}\\;\\text{two}\\;\\text{different}\\;\\text{values}\\;\\text{of}\\;\\text{the}\\;\\text{learning}\\;\\text{rate}\\;\\text{(0.1,}\\;\\text{0.5)}}\\\\\n&amp;{}\t\n\\end{lalign*}&quot;,&quot;backgroundColor&quot;:&quot;#FFFFFF&quot;,&quot;backgroundColorModified&quot;:false,&quot;font&quot;:{&quot;color&quot;:&quot;#000000&quot;,&quot;size&quot;:12,&quot;family&quot;:&quot;Arial&quot;},&quot;type&quot;:&quot;lalign*&quot;,&quot;id&quot;:&quot;5&quot;,&quot;aid&quot;:null,&quot;ts&quot;:1760201579040,&quot;cs&quot;:&quot;8wehhPDoAC3OIVfxnX8vng==&quot;,&quot;size&quot;:{&quot;width&quot;:645,&quot;height&quot;:223.5}}" id="192" name="Google Shape;192;p28"/>
           <p:cNvPicPr preferRelativeResize="0"/>
           <p:nvPr/>
         </p:nvPicPr>
@@ -8412,8 +9100,8 @@
         </p:blipFill>
         <p:spPr>
           <a:xfrm>
-            <a:off x="381450" y="1405775"/>
-            <a:ext cx="6143625" cy="1895475"/>
+            <a:off x="474956" y="1344550"/>
+            <a:ext cx="6143625" cy="2128838"/>
           </a:xfrm>
           <a:prstGeom prst="rect">
             <a:avLst/>
@@ -8426,7 +9114,7 @@
       </p:pic>
       <p:sp>
         <p:nvSpPr>
-          <p:cNvPr id="178" name="Google Shape;178;p26"/>
+          <p:cNvPr id="193" name="Google Shape;193;p28"/>
           <p:cNvSpPr txBox="1"/>
           <p:nvPr/>
         </p:nvSpPr>
@@ -8843,7 +9531,7 @@
         <p:spPr>
           <a:xfrm>
             <a:off x="480050" y="1195250"/>
-            <a:ext cx="6747300" cy="2678100"/>
+            <a:ext cx="7663800" cy="2678100"/>
           </a:xfrm>
           <a:prstGeom prst="rect">
             <a:avLst/>
@@ -8943,7 +9631,7 @@
                   <a:schemeClr val="dk2"/>
                 </a:solidFill>
               </a:rPr>
-              <a:t>: Chapter 3.1 - 3.6, and section 3.9</a:t>
+              <a:t>: Sections 3.1 - 3.6, and section 3.9</a:t>
             </a:r>
             <a:endParaRPr sz="1800">
               <a:solidFill>
@@ -9280,6 +9968,166 @@
         </p:spPr>
         <p:txBody>
           <a:bodyPr anchorCtr="0" anchor="t" bIns="91425" lIns="91425" spcFirstLastPara="1" rIns="91425" wrap="square" tIns="91425">
+            <a:noAutofit/>
+          </a:bodyPr>
+          <a:lstStyle/>
+          <a:p>
+            <a:pPr indent="0" lvl="0" marL="0" rtl="0" algn="l">
+              <a:spcBef>
+                <a:spcPts val="0"/>
+              </a:spcBef>
+              <a:spcAft>
+                <a:spcPts val="0"/>
+              </a:spcAft>
+              <a:buSzPts val="990"/>
+              <a:buNone/>
+            </a:pPr>
+            <a:r>
+              <a:rPr lang="en" sz="2120"/>
+              <a:t>Derivatives in one dimension: Forward, Backward, Central Difference</a:t>
+            </a:r>
+            <a:endParaRPr sz="2120"/>
+          </a:p>
+        </p:txBody>
+      </p:sp>
+      <p:pic>
+        <p:nvPicPr>
+          <p:cNvPr descr="{&quot;font&quot;:{&quot;color&quot;:&quot;#000000&quot;,&quot;size&quot;:12,&quot;family&quot;:&quot;Arial&quot;},&quot;code&quot;:&quot;\\begin{gather*}\n{\\text{Forward}\\;\\text{Difference:}}\\\\\n{\\lim_{\\delta x\\to o}\\frac{f\\left(x+\\delta x\\right)-f\\left(x\\right)}{\\delta x}}\\\\\n{}\\\\\n{\\text{Backward}\\;\\text{Difference}}\\\\\n{\\lim_{\\delta x\\to o}\\frac{f\\left(x\\right)-f\\left(x-\\delta x\\right)}{\\delta x}}\\\\\n{}\\\\\n{\\text{Central}\\;\\text{Difference}}\\\\\n{\\lim_{\\delta x\\to o}\\frac{f\\left(x+\\delta x\\right)-f\\left(x-\\delta x\\right)}{2\\delta x}}\t\n\\end{gather*}&quot;,&quot;backgroundColor&quot;:&quot;#FFFFFF&quot;,&quot;type&quot;:&quot;gather*&quot;,&quot;backgroundColorModified&quot;:false,&quot;id&quot;:&quot;8&quot;,&quot;aid&quot;:null,&quot;ts&quot;:1760200586629,&quot;cs&quot;:&quot;FAqaTxFBzoQW7Zicsq/v3w==&quot;,&quot;size&quot;:{&quot;width&quot;:226.59999999999994,&quot;height&quot;:257.20000000000005}}" id="81" name="Google Shape;81;p17"/>
+          <p:cNvPicPr preferRelativeResize="0"/>
+          <p:nvPr/>
+        </p:nvPicPr>
+        <p:blipFill>
+          <a:blip r:embed="rId3">
+            <a:alphaModFix/>
+          </a:blip>
+          <a:stretch>
+            <a:fillRect/>
+          </a:stretch>
+        </p:blipFill>
+        <p:spPr>
+          <a:xfrm>
+            <a:off x="529875" y="932900"/>
+            <a:ext cx="2158365" cy="2449830"/>
+          </a:xfrm>
+          <a:prstGeom prst="rect">
+            <a:avLst/>
+          </a:prstGeom>
+          <a:noFill/>
+          <a:ln>
+            <a:noFill/>
+          </a:ln>
+        </p:spPr>
+      </p:pic>
+      <p:sp>
+        <p:nvSpPr>
+          <p:cNvPr id="82" name="Google Shape;82;p17"/>
+          <p:cNvSpPr txBox="1"/>
+          <p:nvPr/>
+        </p:nvSpPr>
+        <p:spPr>
+          <a:xfrm>
+            <a:off x="474900" y="3828500"/>
+            <a:ext cx="7904700" cy="415500"/>
+          </a:xfrm>
+          <a:prstGeom prst="rect">
+            <a:avLst/>
+          </a:prstGeom>
+          <a:noFill/>
+          <a:ln>
+            <a:noFill/>
+          </a:ln>
+        </p:spPr>
+        <p:txBody>
+          <a:bodyPr anchorCtr="0" anchor="t" bIns="91425" lIns="91425" spcFirstLastPara="1" rIns="91425" wrap="square" tIns="91425">
+            <a:spAutoFit/>
+          </a:bodyPr>
+          <a:lstStyle/>
+          <a:p>
+            <a:pPr indent="0" lvl="0" marL="0" rtl="0" algn="l">
+              <a:spcBef>
+                <a:spcPts val="0"/>
+              </a:spcBef>
+              <a:spcAft>
+                <a:spcPts val="0"/>
+              </a:spcAft>
+              <a:buNone/>
+            </a:pPr>
+            <a:r>
+              <a:rPr lang="en" sz="1500">
+                <a:solidFill>
+                  <a:schemeClr val="dk2"/>
+                </a:solidFill>
+              </a:rPr>
+              <a:t>Central difference is </a:t>
+            </a:r>
+            <a:r>
+              <a:rPr lang="en" sz="1500">
+                <a:solidFill>
+                  <a:schemeClr val="dk2"/>
+                </a:solidFill>
+              </a:rPr>
+              <a:t>preferred</a:t>
+            </a:r>
+            <a:r>
+              <a:rPr lang="en" sz="1500">
+                <a:solidFill>
+                  <a:schemeClr val="dk2"/>
+                </a:solidFill>
+              </a:rPr>
+              <a:t> for manual (finite difference) calculation of the derivative</a:t>
+            </a:r>
+            <a:endParaRPr sz="1500">
+              <a:solidFill>
+                <a:schemeClr val="dk2"/>
+              </a:solidFill>
+            </a:endParaRPr>
+          </a:p>
+        </p:txBody>
+      </p:sp>
+    </p:spTree>
+  </p:cSld>
+  <p:clrMapOvr>
+    <a:masterClrMapping/>
+  </p:clrMapOvr>
+</p:sld>
+</file>
+
+<file path=ppt/slides/slide6.xml><?xml version="1.0" encoding="utf-8"?>
+<p:sld xmlns:a="http://schemas.openxmlformats.org/drawingml/2006/main" xmlns:r="http://schemas.openxmlformats.org/officeDocument/2006/relationships" xmlns:mc="http://schemas.openxmlformats.org/markup-compatibility/2006" xmlns:mv="urn:schemas-microsoft-com:mac:vml" xmlns:p="http://schemas.openxmlformats.org/presentationml/2006/main" xmlns:c="http://schemas.openxmlformats.org/drawingml/2006/chart" xmlns:dgm="http://schemas.openxmlformats.org/drawingml/2006/diagram" xmlns:o="urn:schemas-microsoft-com:office:office" xmlns:v="urn:schemas-microsoft-com:vml" xmlns:pvml="urn:schemas-microsoft-com:office:powerpoint" xmlns:com="http://schemas.openxmlformats.org/drawingml/2006/compatibility" xmlns:p14="http://schemas.microsoft.com/office/powerpoint/2010/main" xmlns:p15="http://schemas.microsoft.com/office/powerpoint/2012/main" xmlns:ahyp="http://schemas.microsoft.com/office/drawing/2018/hyperlinkcolor">
+  <p:cSld>
+    <p:spTree>
+      <p:nvGrpSpPr>
+        <p:cNvPr id="86" name="Shape 86"/>
+        <p:cNvGrpSpPr/>
+        <p:nvPr/>
+      </p:nvGrpSpPr>
+      <p:grpSpPr>
+        <a:xfrm>
+          <a:off x="0" y="0"/>
+          <a:ext cx="0" cy="0"/>
+          <a:chOff x="0" y="0"/>
+          <a:chExt cx="0" cy="0"/>
+        </a:xfrm>
+      </p:grpSpPr>
+      <p:sp>
+        <p:nvSpPr>
+          <p:cNvPr id="87" name="Google Shape;87;p18"/>
+          <p:cNvSpPr txBox="1"/>
+          <p:nvPr>
+            <p:ph idx="4294967295" type="title"/>
+          </p:nvPr>
+        </p:nvSpPr>
+        <p:spPr>
+          <a:xfrm>
+            <a:off x="259350" y="157250"/>
+            <a:ext cx="8520600" cy="572700"/>
+          </a:xfrm>
+          <a:prstGeom prst="rect">
+            <a:avLst/>
+          </a:prstGeom>
+        </p:spPr>
+        <p:txBody>
+          <a:bodyPr anchorCtr="0" anchor="t" bIns="91425" lIns="91425" spcFirstLastPara="1" rIns="91425" wrap="square" tIns="91425">
             <a:normAutofit fontScale="90000"/>
           </a:bodyPr>
           <a:lstStyle/>
@@ -9303,7 +10151,7 @@
       </p:sp>
       <p:pic>
         <p:nvPicPr>
-          <p:cNvPr id="81" name="Google Shape;81;p17"/>
+          <p:cNvPr id="88" name="Google Shape;88;p18"/>
           <p:cNvPicPr preferRelativeResize="0"/>
           <p:nvPr/>
         </p:nvPicPr>
@@ -9330,7 +10178,7 @@
       </p:pic>
       <p:sp>
         <p:nvSpPr>
-          <p:cNvPr id="82" name="Google Shape;82;p17"/>
+          <p:cNvPr id="89" name="Google Shape;89;p18"/>
           <p:cNvSpPr txBox="1"/>
           <p:nvPr/>
         </p:nvSpPr>
@@ -9452,7 +10300,7 @@
       </p:sp>
       <p:pic>
         <p:nvPicPr>
-          <p:cNvPr descr="{&quot;code&quot;:&quot;$$f\\left(x\\right)=x^{n\\,},\\,x=1,\\,n=4$$&quot;,&quot;font&quot;:{&quot;color&quot;:&quot;#595959&quot;,&quot;size&quot;:18,&quot;family&quot;:&quot;Arial&quot;},&quot;aid&quot;:null,&quot;type&quot;:&quot;$$&quot;,&quot;backgroundColorModified&quot;:false,&quot;backgroundColor&quot;:&quot;#FFFFFF&quot;,&quot;id&quot;:&quot;11&quot;,&quot;ts&quot;:1753571615042,&quot;cs&quot;:&quot;WUkzv0uV0+JLXUtHEhV4yg==&quot;,&quot;size&quot;:{&quot;width&quot;:299.25,&quot;height&quot;:28.25}}" id="83" name="Google Shape;83;p17"/>
+          <p:cNvPr descr="{&quot;code&quot;:&quot;$$f\\left(x\\right)=x^{n\\,},\\,x=1,\\,n=4$$&quot;,&quot;font&quot;:{&quot;color&quot;:&quot;#595959&quot;,&quot;size&quot;:18,&quot;family&quot;:&quot;Arial&quot;},&quot;aid&quot;:null,&quot;type&quot;:&quot;$$&quot;,&quot;backgroundColorModified&quot;:false,&quot;backgroundColor&quot;:&quot;#FFFFFF&quot;,&quot;id&quot;:&quot;11&quot;,&quot;ts&quot;:1753571615042,&quot;cs&quot;:&quot;WUkzv0uV0+JLXUtHEhV4yg==&quot;,&quot;size&quot;:{&quot;width&quot;:299.25,&quot;height&quot;:28.25}}" id="90" name="Google Shape;90;p18"/>
           <p:cNvPicPr preferRelativeResize="0"/>
           <p:nvPr/>
         </p:nvPicPr>
@@ -9480,7 +10328,7 @@
       </p:pic>
       <p:sp>
         <p:nvSpPr>
-          <p:cNvPr id="84" name="Google Shape;84;p17"/>
+          <p:cNvPr id="91" name="Google Shape;91;p18"/>
           <p:cNvSpPr txBox="1"/>
           <p:nvPr/>
         </p:nvSpPr>
@@ -9614,7 +10462,7 @@
       </p:sp>
       <p:pic>
         <p:nvPicPr>
-          <p:cNvPr descr="{&quot;code&quot;:&quot;$$f\\left(x\\right)=x^{n\\,},\\,x=1,\\,n=2$$&quot;,&quot;type&quot;:&quot;$$&quot;,&quot;backgroundColorModified&quot;:false,&quot;id&quot;:&quot;11&quot;,&quot;font&quot;:{&quot;color&quot;:&quot;#595959&quot;,&quot;family&quot;:&quot;Arial&quot;,&quot;size&quot;:18},&quot;backgroundColor&quot;:&quot;#FFFFFF&quot;,&quot;aid&quot;:null,&quot;ts&quot;:1753571806976,&quot;cs&quot;:&quot;Dwgn60dH/3wlJREq6EUU/g==&quot;,&quot;size&quot;:{&quot;width&quot;:298.5,&quot;height&quot;:28.25}}" id="85" name="Google Shape;85;p17"/>
+          <p:cNvPr descr="{&quot;code&quot;:&quot;$$f\\left(x\\right)=x^{n\\,},\\,x=1,\\,n=2$$&quot;,&quot;type&quot;:&quot;$$&quot;,&quot;backgroundColorModified&quot;:false,&quot;id&quot;:&quot;11&quot;,&quot;font&quot;:{&quot;color&quot;:&quot;#595959&quot;,&quot;family&quot;:&quot;Arial&quot;,&quot;size&quot;:18},&quot;backgroundColor&quot;:&quot;#FFFFFF&quot;,&quot;aid&quot;:null,&quot;ts&quot;:1753571806976,&quot;cs&quot;:&quot;Dwgn60dH/3wlJREq6EUU/g==&quot;,&quot;size&quot;:{&quot;width&quot;:298.5,&quot;height&quot;:28.25}}" id="92" name="Google Shape;92;p18"/>
           <p:cNvPicPr preferRelativeResize="0"/>
           <p:nvPr/>
         </p:nvPicPr>
@@ -9642,7 +10490,7 @@
       </p:pic>
       <p:sp>
         <p:nvSpPr>
-          <p:cNvPr id="86" name="Google Shape;86;p17"/>
+          <p:cNvPr id="93" name="Google Shape;93;p18"/>
           <p:cNvSpPr txBox="1"/>
           <p:nvPr/>
         </p:nvSpPr>
@@ -9767,7 +10615,7 @@
       </p:sp>
       <p:sp>
         <p:nvSpPr>
-          <p:cNvPr id="87" name="Google Shape;87;p17"/>
+          <p:cNvPr id="94" name="Google Shape;94;p18"/>
           <p:cNvSpPr txBox="1"/>
           <p:nvPr/>
         </p:nvSpPr>
@@ -9823,12 +10671,12 @@
 </p:sld>
 </file>
 
-<file path=ppt/slides/slide6.xml><?xml version="1.0" encoding="utf-8"?>
+<file path=ppt/slides/slide7.xml><?xml version="1.0" encoding="utf-8"?>
 <p:sld xmlns:a="http://schemas.openxmlformats.org/drawingml/2006/main" xmlns:r="http://schemas.openxmlformats.org/officeDocument/2006/relationships" xmlns:mc="http://schemas.openxmlformats.org/markup-compatibility/2006" xmlns:mv="urn:schemas-microsoft-com:mac:vml" xmlns:p="http://schemas.openxmlformats.org/presentationml/2006/main" xmlns:c="http://schemas.openxmlformats.org/drawingml/2006/chart" xmlns:dgm="http://schemas.openxmlformats.org/drawingml/2006/diagram" xmlns:o="urn:schemas-microsoft-com:office:office" xmlns:v="urn:schemas-microsoft-com:vml" xmlns:pvml="urn:schemas-microsoft-com:office:powerpoint" xmlns:com="http://schemas.openxmlformats.org/drawingml/2006/compatibility" xmlns:p14="http://schemas.microsoft.com/office/powerpoint/2010/main" xmlns:p15="http://schemas.microsoft.com/office/powerpoint/2012/main" xmlns:ahyp="http://schemas.microsoft.com/office/drawing/2018/hyperlinkcolor">
   <p:cSld>
     <p:spTree>
       <p:nvGrpSpPr>
-        <p:cNvPr id="91" name="Shape 91"/>
+        <p:cNvPr id="98" name="Shape 98"/>
         <p:cNvGrpSpPr/>
         <p:nvPr/>
       </p:nvGrpSpPr>
@@ -9842,7 +10690,7 @@
       </p:grpSpPr>
       <p:sp>
         <p:nvSpPr>
-          <p:cNvPr id="92" name="Google Shape;92;p18"/>
+          <p:cNvPr id="99" name="Google Shape;99;p19"/>
           <p:cNvSpPr txBox="1"/>
           <p:nvPr>
             <p:ph idx="4294967295" type="title"/>
@@ -9882,7 +10730,7 @@
       </p:sp>
       <p:sp>
         <p:nvSpPr>
-          <p:cNvPr id="93" name="Google Shape;93;p18"/>
+          <p:cNvPr id="100" name="Google Shape;100;p19"/>
           <p:cNvSpPr txBox="1"/>
           <p:nvPr/>
         </p:nvSpPr>
@@ -9932,7 +10780,7 @@
       </p:sp>
       <p:pic>
         <p:nvPicPr>
-          <p:cNvPr descr="{&quot;aid&quot;:null,&quot;font&quot;:{&quot;color&quot;:&quot;#000000&quot;,&quot;size&quot;:12,&quot;family&quot;:&quot;Arial&quot;},&quot;backgroundColorModified&quot;:false,&quot;backgroundColor&quot;:&quot;#FFFFFF&quot;,&quot;code&quot;:&quot;\\begin{lalign*}\n&amp;{\\text{Product}\\;\\text{Rule}}\\\\\n&amp;{f\\left(x\\right)=g\\left(x\\right)f\\left(x\\right)}\\\\\n&amp;{f^{\\prime}\\left(x\\right)=\\frac{\\dd f}{\\dd x}=f\\left(x\\right)g^{\\prime}\\left(x\\right)+g\\left(x\\right)f^{\\prime}\\left(x\\right)}\\\\\n&amp;{\\text{eg.,}\\;f\\left(x\\right)=\\sin\\left(x\\right)\\log_{}\\left(x\\right)}\\\\\n&amp;{f^{\\prime}\\left(x\\right)=\\,\\frac{\\sin\\left(x\\right)}{x}+\\log_{}\\left(x\\right)\\cos\\left(x\\right)\\,}\\\\\n&amp;{\\because \\frac{\\dd \\log_{}\\left(x\\right)}{\\dd x}=\\frac{1}{x},\\,\\frac{\\dd sin\\left(x\\right)}{\\dd x}=\\cos\\left(x\\right)}\\\\\n&amp;{}\\\\\n&amp;{\\text{Chain}\\;\\text{Rule}}\\\\\n&amp;{f\\left(x\\right)=g\\left(h\\left(x\\right)\\right)}\\\\\n&amp;{f^{\\prime}\\left(x\\right)=h^{\\prime}\\left(x\\right)g^{\\prime}\\left(h\\left(x\\right)\\right)}\\\\\n&amp;{\\text{eg.,}\\;f\\left(x\\right)=\\sin\\left(\\log_{}\\left(x\\right)\\right)}\\\\\n&amp;{f^{\\prime}\\left(x\\right)=\\frac{1}{x}\\cos\\left(\\log_{}\\left(x\\right)\\right)\\,}\\\\\n&amp;{\\text{eg}\\;\\text{2:}\\;\\frac{\\dd \\log_{}\\left(f\\left(x\\right)\\right)}{\\dd x}=\\frac{f^{\\prime}\\left(x\\right)}{f\\left(x\\right)}}\t\n\\end{lalign*}&quot;,&quot;id&quot;:&quot;1&quot;,&quot;type&quot;:&quot;lalign*&quot;,&quot;ts&quot;:1758933737120,&quot;cs&quot;:&quot;ywcLxi8nzu3yP2BigWBsVQ==&quot;,&quot;size&quot;:{&quot;width&quot;:309.33333333333337,&quot;height&quot;:421.6666666666667}}" id="94" name="Google Shape;94;p18"/>
+          <p:cNvPr descr="{&quot;aid&quot;:null,&quot;font&quot;:{&quot;color&quot;:&quot;#000000&quot;,&quot;size&quot;:12,&quot;family&quot;:&quot;Arial&quot;},&quot;backgroundColorModified&quot;:false,&quot;backgroundColor&quot;:&quot;#FFFFFF&quot;,&quot;code&quot;:&quot;\\begin{lalign*}\n&amp;{\\text{Product}\\;\\text{Rule}}\\\\\n&amp;{f\\left(x\\right)=g\\left(x\\right)f\\left(x\\right)}\\\\\n&amp;{f^{\\prime}\\left(x\\right)=\\frac{\\dd f}{\\dd x}=f\\left(x\\right)g^{\\prime}\\left(x\\right)+g\\left(x\\right)f^{\\prime}\\left(x\\right)}\\\\\n&amp;{\\text{eg.,}\\;f\\left(x\\right)=\\sin\\left(x\\right)\\log_{}\\left(x\\right)}\\\\\n&amp;{f^{\\prime}\\left(x\\right)=\\,\\frac{\\sin\\left(x\\right)}{x}+\\log_{}\\left(x\\right)\\cos\\left(x\\right)\\,}\\\\\n&amp;{\\because \\frac{\\dd \\log_{}\\left(x\\right)}{\\dd x}=\\frac{1}{x},\\,\\frac{\\dd sin\\left(x\\right)}{\\dd x}=\\cos\\left(x\\right)}\\\\\n&amp;{}\\\\\n&amp;{\\text{Chain}\\;\\text{Rule}}\\\\\n&amp;{f\\left(x\\right)=g\\left(h\\left(x\\right)\\right)}\\\\\n&amp;{f^{\\prime}\\left(x\\right)=h^{\\prime}\\left(x\\right)g^{\\prime}\\left(h\\left(x\\right)\\right)}\\\\\n&amp;{\\text{eg.,}\\;f\\left(x\\right)=\\sin\\left(\\log_{}\\left(x\\right)\\right)}\\\\\n&amp;{f^{\\prime}\\left(x\\right)=\\frac{1}{x}\\cos\\left(\\log_{}\\left(x\\right)\\right)\\,}\\\\\n&amp;{\\text{eg}\\;\\text{2:}\\;\\frac{\\dd \\log_{}\\left(f\\left(x\\right)\\right)}{\\dd x}=\\frac{f^{\\prime}\\left(x\\right)}{f\\left(x\\right)}}\t\n\\end{lalign*}&quot;,&quot;id&quot;:&quot;1&quot;,&quot;type&quot;:&quot;lalign*&quot;,&quot;ts&quot;:1758933737120,&quot;cs&quot;:&quot;ywcLxi8nzu3yP2BigWBsVQ==&quot;,&quot;size&quot;:{&quot;width&quot;:309.33333333333337,&quot;height&quot;:421.6666666666667}}" id="101" name="Google Shape;101;p19"/>
           <p:cNvPicPr preferRelativeResize="0"/>
           <p:nvPr/>
         </p:nvPicPr>
@@ -9960,7 +10808,7 @@
       </p:pic>
       <p:pic>
         <p:nvPicPr>
-          <p:cNvPr descr="{&quot;backgroundColorModified&quot;:false,&quot;font&quot;:{&quot;size&quot;:12,&quot;color&quot;:&quot;#000000&quot;,&quot;family&quot;:&quot;Arial&quot;},&quot;type&quot;:&quot;lalign*&quot;,&quot;backgroundColor&quot;:&quot;#FFFFFF&quot;,&quot;id&quot;:&quot;1&quot;,&quot;code&quot;:&quot;\\begin{lalign*}\n&amp;{\\text{Quotient}\\;\\text{Rule}}\\\\\n&amp;{f\\left(x\\right)=\\frac{f\\left(x\\right)}{g\\left(x\\right)}}\\\\\n&amp;{f^{\\prime}\\left(x\\right)=\\frac{\\dd}{\\dd x}\\left(f\\left(x\\right)\\times\\frac{1}{g\\left(x\\right)}\\right)}\\\\\n&amp;{\\,\\,\\,\\,\\,\\,\\,\\,\\,\\,\\,\\,\\,\\,\\,\\,=\\,\\frac{f^{\\prime}\\left(x\\right)}{g\\left(x\\right)}-\\frac{f\\left(x\\right)g^{\\prime}\\left(x\\right)}{g^{2}\\left(x\\right)}}\\\\\n&amp;{\\,\\,\\,\\,\\,\\,\\,\\,\\,\\,\\,\\,\\,\\,\\,\\,=\\,\\frac{g\\left(x\\right)f^{\\prime}\\left(x\\right)-f\\left(x\\right)g^{\\prime}\\left(x\\right)}{g^{2}\\left(x\\right)}}\\\\\n&amp;{\\text{eg.,}\\;f\\left(x\\right)=\\frac{\\sin\\left(x\\right)}{\\log_{}\\left(x\\right)}}\\\\\n&amp;{f^{\\prime}\\left(x\\right)=\\,\\frac{\\log_{}\\left(x\\right)\\cos\\left(x\\right)-\\frac{\\sin\\left(x\\right)}{x}}{\\log_{}^{2}\\left(x\\right)}}\\\\\n&amp;{\\,\\,\\,\\,\\,\\,\\,\\,\\,\\,\\,\\,\\,\\,}\t\n\\end{lalign*}&quot;,&quot;aid&quot;:null,&quot;ts&quot;:1758630090527,&quot;cs&quot;:&quot;/zlI6TmmZSvZLyFo4hyS8w==&quot;,&quot;size&quot;:{&quot;width&quot;:265.66666666666674,&quot;height&quot;:335.3333333333333}}" id="95" name="Google Shape;95;p18"/>
+          <p:cNvPr descr="{&quot;backgroundColorModified&quot;:false,&quot;font&quot;:{&quot;size&quot;:12,&quot;color&quot;:&quot;#000000&quot;,&quot;family&quot;:&quot;Arial&quot;},&quot;type&quot;:&quot;lalign*&quot;,&quot;backgroundColor&quot;:&quot;#FFFFFF&quot;,&quot;id&quot;:&quot;1&quot;,&quot;code&quot;:&quot;\\begin{lalign*}\n&amp;{\\text{Quotient}\\;\\text{Rule}}\\\\\n&amp;{f\\left(x\\right)=\\frac{f\\left(x\\right)}{g\\left(x\\right)}}\\\\\n&amp;{f^{\\prime}\\left(x\\right)=\\frac{\\dd}{\\dd x}\\left(f\\left(x\\right)\\times\\frac{1}{g\\left(x\\right)}\\right)}\\\\\n&amp;{\\,\\,\\,\\,\\,\\,\\,\\,\\,\\,\\,\\,\\,\\,\\,\\,=\\,\\frac{f^{\\prime}\\left(x\\right)}{g\\left(x\\right)}-\\frac{f\\left(x\\right)g^{\\prime}\\left(x\\right)}{g^{2}\\left(x\\right)}}\\\\\n&amp;{\\,\\,\\,\\,\\,\\,\\,\\,\\,\\,\\,\\,\\,\\,\\,\\,=\\,\\frac{g\\left(x\\right)f^{\\prime}\\left(x\\right)-f\\left(x\\right)g^{\\prime}\\left(x\\right)}{g^{2}\\left(x\\right)}}\\\\\n&amp;{\\text{eg.,}\\;f\\left(x\\right)=\\frac{\\sin\\left(x\\right)}{\\log_{}\\left(x\\right)}}\\\\\n&amp;{f^{\\prime}\\left(x\\right)=\\,\\frac{\\log_{}\\left(x\\right)\\cos\\left(x\\right)-\\frac{\\sin\\left(x\\right)}{x}}{\\log_{}^{2}\\left(x\\right)}}\\\\\n&amp;{\\,\\,\\,\\,\\,\\,\\,\\,\\,\\,\\,\\,\\,\\,}\t\n\\end{lalign*}&quot;,&quot;aid&quot;:null,&quot;ts&quot;:1758630090527,&quot;cs&quot;:&quot;/zlI6TmmZSvZLyFo4hyS8w==&quot;,&quot;size&quot;:{&quot;width&quot;:265.66666666666674,&quot;height&quot;:335.3333333333333}}" id="102" name="Google Shape;102;p19"/>
           <p:cNvPicPr preferRelativeResize="0"/>
           <p:nvPr/>
         </p:nvPicPr>
@@ -9994,12 +10842,12 @@
 </p:sld>
 </file>
 
-<file path=ppt/slides/slide7.xml><?xml version="1.0" encoding="utf-8"?>
+<file path=ppt/slides/slide8.xml><?xml version="1.0" encoding="utf-8"?>
 <p:sld xmlns:a="http://schemas.openxmlformats.org/drawingml/2006/main" xmlns:r="http://schemas.openxmlformats.org/officeDocument/2006/relationships" xmlns:mc="http://schemas.openxmlformats.org/markup-compatibility/2006" xmlns:mv="urn:schemas-microsoft-com:mac:vml" xmlns:p="http://schemas.openxmlformats.org/presentationml/2006/main" xmlns:c="http://schemas.openxmlformats.org/drawingml/2006/chart" xmlns:dgm="http://schemas.openxmlformats.org/drawingml/2006/diagram" xmlns:o="urn:schemas-microsoft-com:office:office" xmlns:v="urn:schemas-microsoft-com:vml" xmlns:pvml="urn:schemas-microsoft-com:office:powerpoint" xmlns:com="http://schemas.openxmlformats.org/drawingml/2006/compatibility" xmlns:p14="http://schemas.microsoft.com/office/powerpoint/2010/main" xmlns:p15="http://schemas.microsoft.com/office/powerpoint/2012/main" xmlns:ahyp="http://schemas.microsoft.com/office/drawing/2018/hyperlinkcolor">
   <p:cSld>
     <p:spTree>
       <p:nvGrpSpPr>
-        <p:cNvPr id="99" name="Shape 99"/>
+        <p:cNvPr id="106" name="Shape 106"/>
         <p:cNvGrpSpPr/>
         <p:nvPr/>
       </p:nvGrpSpPr>
@@ -10013,7 +10861,7 @@
       </p:grpSpPr>
       <p:sp>
         <p:nvSpPr>
-          <p:cNvPr id="100" name="Google Shape;100;p19"/>
+          <p:cNvPr id="107" name="Google Shape;107;p20"/>
           <p:cNvSpPr txBox="1"/>
           <p:nvPr>
             <p:ph idx="4294967295" type="title"/>
@@ -10053,7 +10901,7 @@
       </p:sp>
       <p:sp>
         <p:nvSpPr>
-          <p:cNvPr id="101" name="Google Shape;101;p19"/>
+          <p:cNvPr id="108" name="Google Shape;108;p20"/>
           <p:cNvSpPr txBox="1"/>
           <p:nvPr/>
         </p:nvSpPr>
@@ -10098,7 +10946,7 @@
       </p:sp>
       <p:pic>
         <p:nvPicPr>
-          <p:cNvPr id="102" name="Google Shape;102;p19"/>
+          <p:cNvPr id="109" name="Google Shape;109;p20"/>
           <p:cNvPicPr preferRelativeResize="0"/>
           <p:nvPr/>
         </p:nvPicPr>
@@ -10126,7 +10974,7 @@
       </p:pic>
       <p:sp>
         <p:nvSpPr>
-          <p:cNvPr id="103" name="Google Shape;103;p19"/>
+          <p:cNvPr id="110" name="Google Shape;110;p20"/>
           <p:cNvSpPr txBox="1"/>
           <p:nvPr/>
         </p:nvSpPr>
@@ -10223,7 +11071,7 @@
       </p:sp>
       <p:sp>
         <p:nvSpPr>
-          <p:cNvPr id="104" name="Google Shape;104;p19"/>
+          <p:cNvPr id="111" name="Google Shape;111;p20"/>
           <p:cNvSpPr txBox="1"/>
           <p:nvPr/>
         </p:nvSpPr>
@@ -10273,7 +11121,7 @@
       </p:sp>
       <p:pic>
         <p:nvPicPr>
-          <p:cNvPr id="105" name="Google Shape;105;p19"/>
+          <p:cNvPr id="112" name="Google Shape;112;p20"/>
           <p:cNvPicPr preferRelativeResize="0"/>
           <p:nvPr/>
         </p:nvPicPr>
@@ -10300,7 +11148,7 @@
       </p:pic>
       <p:pic>
         <p:nvPicPr>
-          <p:cNvPr descr="{&quot;backgroundColor&quot;:&quot;#FFFFFF&quot;,&quot;backgroundColorModified&quot;:false,&quot;type&quot;:&quot;lalign*&quot;,&quot;font&quot;:{&quot;size&quot;:9,&quot;family&quot;:&quot;Arial&quot;,&quot;color&quot;:&quot;#000000&quot;},&quot;id&quot;:&quot;6&quot;,&quot;code&quot;:&quot;\\begin{lalign*}\n&amp;{\\text{To}\\;\\text{move}\\;\\text{towards}\\;\\text{the}\\;\\text{minimum}\\;\\text{from}\\;\\text{any}\\;\\text{point,}\\;\\text{I}\\;\\text{need}\\;\\text{to}\\;\\text{know:}}\\\\\n&amp;{1.\\,\\text{Which}\\;\\text{direction}\\;\\text{should}\\;\\text{I}\\;\\text{move}\\;\\text{(left/right)}}\\\\\n&amp;{2.\\,\\text{How}\\;\\text{much}\\;\\text{should}\\;\\text{I}\\;\\text{move}}\\\\\n&amp;{\\text{Gradient}\\;\\text{gives}\\;\\text{us}\\;\\text{both.}\\;\\text{}}\\\\\n&amp;{Eg.,\\,\\text{At}\\;\\text{x}\\;\\text{=}\\;\\text{4.5,}\\;f^{\\prime}\\left(x\\right)=3.\\,\\text{Since}\\;f^{\\prime}\\left(x\\right)&gt;0,\\,\\text{w}\\text{e}\\;\\text{step}\\;\\text{to}\\;\\text{the}\\;\\text{left,}\\;\\text{by}\\;\\text{}}\\\\\n&amp;{\\text{learning}\\;\\text{rate}\\;\\times\\,3}\\\\\n&amp;{\\text{At}\\;\\text{x=-4.5,}\\;f^{\\prime}\\left(x\\right)=-15.\\,\\,\\text{Since}\\;f^{\\prime}\\left(x\\right)&lt;0,\\,\\text{w}\\text{e}\\;\\text{step}\\;\\text{to}\\;\\text{the}\\;\\text{right,}\\;\\text{by}}\\\\\n&amp;{\\text{learning}\\;\\text{rate}\\;\\times\\,15}\t\n\\end{lalign*}&quot;,&quot;aid&quot;:null,&quot;ts&quot;:1759605483807,&quot;cs&quot;:&quot;H30tX8KikYsIGLeUjTG74Q==&quot;,&quot;size&quot;:{&quot;width&quot;:424.99478267716535,&quot;height&quot;:149.5144}}" id="106" name="Google Shape;106;p19"/>
+          <p:cNvPr descr="{&quot;backgroundColor&quot;:&quot;#FFFFFF&quot;,&quot;backgroundColorModified&quot;:false,&quot;type&quot;:&quot;lalign*&quot;,&quot;font&quot;:{&quot;size&quot;:9,&quot;family&quot;:&quot;Arial&quot;,&quot;color&quot;:&quot;#000000&quot;},&quot;id&quot;:&quot;6&quot;,&quot;code&quot;:&quot;\\begin{lalign*}\n&amp;{\\text{To}\\;\\text{move}\\;\\text{towards}\\;\\text{the}\\;\\text{minimum}\\;\\text{from}\\;\\text{any}\\;\\text{point,}\\;\\text{I}\\;\\text{need}\\;\\text{to}\\;\\text{know:}}\\\\\n&amp;{1.\\,\\text{Which}\\;\\text{direction}\\;\\text{should}\\;\\text{I}\\;\\text{move}\\;\\text{(left/right)}}\\\\\n&amp;{2.\\,\\text{How}\\;\\text{much}\\;\\text{should}\\;\\text{I}\\;\\text{move}}\\\\\n&amp;{\\text{Gradient}\\;\\text{gives}\\;\\text{us}\\;\\text{both.}\\;\\text{}}\\\\\n&amp;{Eg.,\\,\\text{At}\\;\\text{x}\\;\\text{=}\\;\\text{4.5,}\\;f^{\\prime}\\left(x\\right)=3.\\,\\text{Since}\\;f^{\\prime}\\left(x\\right)&gt;0,\\,\\text{w}\\text{e}\\;\\text{step}\\;\\text{to}\\;\\text{the}\\;\\text{left,}\\;\\text{by}\\;\\text{}}\\\\\n&amp;{\\text{learning}\\;\\text{rate}\\;\\times\\,3}\\\\\n&amp;{\\text{At}\\;\\text{x=-4.5,}\\;f^{\\prime}\\left(x\\right)=-15.\\,\\,\\text{Since}\\;f^{\\prime}\\left(x\\right)&lt;0,\\,\\text{w}\\text{e}\\;\\text{step}\\;\\text{to}\\;\\text{the}\\;\\text{right,}\\;\\text{by}}\\\\\n&amp;{\\text{learning}\\;\\text{rate}\\;\\times\\,15}\t\n\\end{lalign*}&quot;,&quot;aid&quot;:null,&quot;ts&quot;:1759605483807,&quot;cs&quot;:&quot;H30tX8KikYsIGLeUjTG74Q==&quot;,&quot;size&quot;:{&quot;width&quot;:424.99478267716535,&quot;height&quot;:149.5144}}" id="113" name="Google Shape;113;p20"/>
           <p:cNvPicPr preferRelativeResize="0"/>
           <p:nvPr/>
         </p:nvPicPr>
@@ -10316,335 +11164,6 @@
           <a:xfrm>
             <a:off x="4686600" y="3205375"/>
             <a:ext cx="4048075" cy="1424125"/>
-          </a:xfrm>
-          <a:prstGeom prst="rect">
-            <a:avLst/>
-          </a:prstGeom>
-          <a:noFill/>
-          <a:ln>
-            <a:noFill/>
-          </a:ln>
-        </p:spPr>
-      </p:pic>
-    </p:spTree>
-  </p:cSld>
-  <p:clrMapOvr>
-    <a:masterClrMapping/>
-  </p:clrMapOvr>
-</p:sld>
-</file>
-
-<file path=ppt/slides/slide8.xml><?xml version="1.0" encoding="utf-8"?>
-<p:sld xmlns:a="http://schemas.openxmlformats.org/drawingml/2006/main" xmlns:r="http://schemas.openxmlformats.org/officeDocument/2006/relationships" xmlns:mc="http://schemas.openxmlformats.org/markup-compatibility/2006" xmlns:mv="urn:schemas-microsoft-com:mac:vml" xmlns:p="http://schemas.openxmlformats.org/presentationml/2006/main" xmlns:c="http://schemas.openxmlformats.org/drawingml/2006/chart" xmlns:dgm="http://schemas.openxmlformats.org/drawingml/2006/diagram" xmlns:o="urn:schemas-microsoft-com:office:office" xmlns:v="urn:schemas-microsoft-com:vml" xmlns:pvml="urn:schemas-microsoft-com:office:powerpoint" xmlns:com="http://schemas.openxmlformats.org/drawingml/2006/compatibility" xmlns:p14="http://schemas.microsoft.com/office/powerpoint/2010/main" xmlns:p15="http://schemas.microsoft.com/office/powerpoint/2012/main" xmlns:ahyp="http://schemas.microsoft.com/office/drawing/2018/hyperlinkcolor">
-  <p:cSld>
-    <p:spTree>
-      <p:nvGrpSpPr>
-        <p:cNvPr id="110" name="Shape 110"/>
-        <p:cNvGrpSpPr/>
-        <p:nvPr/>
-      </p:nvGrpSpPr>
-      <p:grpSpPr>
-        <a:xfrm>
-          <a:off x="0" y="0"/>
-          <a:ext cx="0" cy="0"/>
-          <a:chOff x="0" y="0"/>
-          <a:chExt cx="0" cy="0"/>
-        </a:xfrm>
-      </p:grpSpPr>
-      <p:sp>
-        <p:nvSpPr>
-          <p:cNvPr id="111" name="Google Shape;111;p20"/>
-          <p:cNvSpPr txBox="1"/>
-          <p:nvPr>
-            <p:ph idx="4294967295" type="title"/>
-          </p:nvPr>
-        </p:nvSpPr>
-        <p:spPr>
-          <a:xfrm>
-            <a:off x="259350" y="157250"/>
-            <a:ext cx="8520600" cy="572700"/>
-          </a:xfrm>
-          <a:prstGeom prst="rect">
-            <a:avLst/>
-          </a:prstGeom>
-        </p:spPr>
-        <p:txBody>
-          <a:bodyPr anchorCtr="0" anchor="t" bIns="91425" lIns="91425" spcFirstLastPara="1" rIns="91425" wrap="square" tIns="91425">
-            <a:normAutofit fontScale="90000"/>
-          </a:bodyPr>
-          <a:lstStyle/>
-          <a:p>
-            <a:pPr indent="0" lvl="0" marL="0" rtl="0" algn="l">
-              <a:spcBef>
-                <a:spcPts val="0"/>
-              </a:spcBef>
-              <a:spcAft>
-                <a:spcPts val="0"/>
-              </a:spcAft>
-              <a:buNone/>
-            </a:pPr>
-            <a:r>
-              <a:rPr lang="en"/>
-              <a:t>Derivative: Important property</a:t>
-            </a:r>
-            <a:endParaRPr/>
-          </a:p>
-        </p:txBody>
-      </p:sp>
-      <p:sp>
-        <p:nvSpPr>
-          <p:cNvPr id="112" name="Google Shape;112;p20"/>
-          <p:cNvSpPr txBox="1"/>
-          <p:nvPr/>
-        </p:nvSpPr>
-        <p:spPr>
-          <a:xfrm>
-            <a:off x="381450" y="806388"/>
-            <a:ext cx="3013800" cy="461700"/>
-          </a:xfrm>
-          <a:prstGeom prst="rect">
-            <a:avLst/>
-          </a:prstGeom>
-          <a:noFill/>
-          <a:ln>
-            <a:noFill/>
-          </a:ln>
-        </p:spPr>
-        <p:txBody>
-          <a:bodyPr anchorCtr="0" anchor="t" bIns="91425" lIns="91425" spcFirstLastPara="1" rIns="91425" wrap="square" tIns="91425">
-            <a:spAutoFit/>
-          </a:bodyPr>
-          <a:lstStyle/>
-          <a:p>
-            <a:pPr indent="0" lvl="0" marL="0" rtl="0" algn="l">
-              <a:spcBef>
-                <a:spcPts val="0"/>
-              </a:spcBef>
-              <a:spcAft>
-                <a:spcPts val="0"/>
-              </a:spcAft>
-              <a:buNone/>
-            </a:pPr>
-            <a:r>
-              <a:t/>
-            </a:r>
-            <a:endParaRPr sz="1800">
-              <a:solidFill>
-                <a:schemeClr val="dk2"/>
-              </a:solidFill>
-            </a:endParaRPr>
-          </a:p>
-        </p:txBody>
-      </p:sp>
-      <p:sp>
-        <p:nvSpPr>
-          <p:cNvPr id="113" name="Google Shape;113;p20"/>
-          <p:cNvSpPr txBox="1"/>
-          <p:nvPr/>
-        </p:nvSpPr>
-        <p:spPr>
-          <a:xfrm>
-            <a:off x="259350" y="729950"/>
-            <a:ext cx="7513800" cy="1108200"/>
-          </a:xfrm>
-          <a:prstGeom prst="rect">
-            <a:avLst/>
-          </a:prstGeom>
-          <a:noFill/>
-          <a:ln>
-            <a:noFill/>
-          </a:ln>
-        </p:spPr>
-        <p:txBody>
-          <a:bodyPr anchorCtr="0" anchor="t" bIns="91425" lIns="91425" spcFirstLastPara="1" rIns="91425" wrap="square" tIns="91425">
-            <a:spAutoFit/>
-          </a:bodyPr>
-          <a:lstStyle/>
-          <a:p>
-            <a:pPr indent="-323850" lvl="0" marL="457200" rtl="0" algn="l">
-              <a:spcBef>
-                <a:spcPts val="0"/>
-              </a:spcBef>
-              <a:spcAft>
-                <a:spcPts val="0"/>
-              </a:spcAft>
-              <a:buClr>
-                <a:schemeClr val="dk2"/>
-              </a:buClr>
-              <a:buSzPts val="1500"/>
-              <a:buChar char="-"/>
-            </a:pPr>
-            <a:r>
-              <a:rPr lang="en" sz="1500">
-                <a:solidFill>
-                  <a:schemeClr val="dk2"/>
-                </a:solidFill>
-              </a:rPr>
-              <a:t>A function can have many local </a:t>
-            </a:r>
-            <a:r>
-              <a:rPr lang="en" sz="1500">
-                <a:solidFill>
-                  <a:schemeClr val="dk2"/>
-                </a:solidFill>
-              </a:rPr>
-              <a:t>minima or maxima</a:t>
-            </a:r>
-            <a:r>
-              <a:rPr lang="en" sz="1500">
-                <a:solidFill>
-                  <a:schemeClr val="dk2"/>
-                </a:solidFill>
-              </a:rPr>
-              <a:t>! We can distinguish between minimum and maximum using the second derivative test.</a:t>
-            </a:r>
-            <a:endParaRPr sz="1500">
-              <a:solidFill>
-                <a:schemeClr val="dk2"/>
-              </a:solidFill>
-            </a:endParaRPr>
-          </a:p>
-          <a:p>
-            <a:pPr indent="-323850" lvl="0" marL="457200" rtl="0" algn="l">
-              <a:spcBef>
-                <a:spcPts val="0"/>
-              </a:spcBef>
-              <a:spcAft>
-                <a:spcPts val="0"/>
-              </a:spcAft>
-              <a:buClr>
-                <a:schemeClr val="dk2"/>
-              </a:buClr>
-              <a:buSzPts val="1500"/>
-              <a:buChar char="-"/>
-            </a:pPr>
-            <a:r>
-              <a:rPr lang="en" sz="1500">
-                <a:solidFill>
-                  <a:schemeClr val="dk2"/>
-                </a:solidFill>
-              </a:rPr>
-              <a:t>Sometimes, we can analytically solve f_prime(x) = 0, but usually not. </a:t>
-            </a:r>
-            <a:br>
-              <a:rPr lang="en" sz="1500">
-                <a:solidFill>
-                  <a:schemeClr val="dk2"/>
-                </a:solidFill>
-              </a:rPr>
-            </a:br>
-            <a:r>
-              <a:rPr lang="en" sz="1500">
-                <a:solidFill>
-                  <a:schemeClr val="dk2"/>
-                </a:solidFill>
-              </a:rPr>
-              <a:t> </a:t>
-            </a:r>
-            <a:endParaRPr sz="1500">
-              <a:solidFill>
-                <a:schemeClr val="dk2"/>
-              </a:solidFill>
-            </a:endParaRPr>
-          </a:p>
-        </p:txBody>
-      </p:sp>
-      <p:sp>
-        <p:nvSpPr>
-          <p:cNvPr id="114" name="Google Shape;114;p20"/>
-          <p:cNvSpPr txBox="1"/>
-          <p:nvPr/>
-        </p:nvSpPr>
-        <p:spPr>
-          <a:xfrm>
-            <a:off x="6002200" y="4684575"/>
-            <a:ext cx="3000000" cy="369300"/>
-          </a:xfrm>
-          <a:prstGeom prst="rect">
-            <a:avLst/>
-          </a:prstGeom>
-          <a:noFill/>
-          <a:ln>
-            <a:noFill/>
-          </a:ln>
-        </p:spPr>
-        <p:txBody>
-          <a:bodyPr anchorCtr="0" anchor="t" bIns="91425" lIns="91425" spcFirstLastPara="1" rIns="91425" wrap="square" tIns="91425">
-            <a:spAutoFit/>
-          </a:bodyPr>
-          <a:lstStyle/>
-          <a:p>
-            <a:pPr indent="0" lvl="0" marL="0" rtl="0" algn="l">
-              <a:spcBef>
-                <a:spcPts val="0"/>
-              </a:spcBef>
-              <a:spcAft>
-                <a:spcPts val="0"/>
-              </a:spcAft>
-              <a:buNone/>
-            </a:pPr>
-            <a:r>
-              <a:rPr lang="en" sz="1200">
-                <a:solidFill>
-                  <a:schemeClr val="dk2"/>
-                </a:solidFill>
-              </a:rPr>
-              <a:t>Code: multiple_local_minima.py</a:t>
-            </a:r>
-            <a:endParaRPr sz="1200">
-              <a:solidFill>
-                <a:schemeClr val="dk2"/>
-              </a:solidFill>
-            </a:endParaRPr>
-          </a:p>
-        </p:txBody>
-      </p:sp>
-      <p:pic>
-        <p:nvPicPr>
-          <p:cNvPr id="115" name="Google Shape;115;p20"/>
-          <p:cNvPicPr preferRelativeResize="0"/>
-          <p:nvPr/>
-        </p:nvPicPr>
-        <p:blipFill>
-          <a:blip r:embed="rId3">
-            <a:alphaModFix/>
-          </a:blip>
-          <a:stretch>
-            <a:fillRect/>
-          </a:stretch>
-        </p:blipFill>
-        <p:spPr>
-          <a:xfrm>
-            <a:off x="192850" y="1519650"/>
-            <a:ext cx="4085726" cy="3064301"/>
-          </a:xfrm>
-          <a:prstGeom prst="rect">
-            <a:avLst/>
-          </a:prstGeom>
-          <a:noFill/>
-          <a:ln>
-            <a:noFill/>
-          </a:ln>
-        </p:spPr>
-      </p:pic>
-      <p:pic>
-        <p:nvPicPr>
-          <p:cNvPr descr="{&quot;font&quot;:{&quot;family&quot;:&quot;Arial&quot;,&quot;size&quot;:12,&quot;color&quot;:&quot;#000000&quot;},&quot;code&quot;:&quot;\\begin{lalign*}\n&amp;{f\\left(x\\right)=\\,x^{4}-3x^{2\\,}+\\,2}\\\\\n&amp;{f^{\\prime}\\left(x\\right)=4x^{3}-6x}\\\\\n&amp;{f^{\\prime}\\left(x\\right)=0\\,\\text{at}\\;x=0,\\,x=\\pm{\\sqrt[]{3/2}}}\\\\\n&amp;{f^{\&quot;}\\left(x\\right)=12x^{2}-6}\\\\\n&amp;{\\text{At}\\;x=0,\\,f^{\&quot;}\\left(x\\right)=-6,\\,\\to\\,\\text{local}\\;\\text{maximum}}\\\\\n&amp;{\\text{At}\\;x=\\pm{\\sqrt[]{3/2}},\\,f^{\&quot;}\\left(x\\right)=12\\,\\to\\,\\text{local}\\;\\text{mimumim}}\t\n\\end{lalign*}&quot;,&quot;id&quot;:&quot;3&quot;,&quot;backgroundColorModified&quot;:false,&quot;backgroundColor&quot;:&quot;#FFFFFF&quot;,&quot;type&quot;:&quot;lalign*&quot;,&quot;aid&quot;:null,&quot;ts&quot;:1759096556198,&quot;cs&quot;:&quot;quHJXim4oEGS/g3o2jgA/A==&quot;,&quot;size&quot;:{&quot;width&quot;:389.3333333333333,&quot;height&quot;:182}}" id="116" name="Google Shape;116;p20"/>
-          <p:cNvPicPr preferRelativeResize="0"/>
-          <p:nvPr/>
-        </p:nvPicPr>
-        <p:blipFill>
-          <a:blip r:embed="rId4">
-            <a:alphaModFix/>
-          </a:blip>
-          <a:stretch>
-            <a:fillRect/>
-          </a:stretch>
-        </p:blipFill>
-        <p:spPr>
-          <a:xfrm>
-            <a:off x="4373525" y="1840488"/>
-            <a:ext cx="3708400" cy="1733550"/>
           </a:xfrm>
           <a:prstGeom prst="rect">
             <a:avLst/>
@@ -10668,7 +11187,7 @@
   <p:cSld>
     <p:spTree>
       <p:nvGrpSpPr>
-        <p:cNvPr id="120" name="Shape 120"/>
+        <p:cNvPr id="117" name="Shape 117"/>
         <p:cNvGrpSpPr/>
         <p:nvPr/>
       </p:nvGrpSpPr>
@@ -10680,9 +11199,94 @@
           <a:chExt cx="0" cy="0"/>
         </a:xfrm>
       </p:grpSpPr>
+      <p:sp>
+        <p:nvSpPr>
+          <p:cNvPr id="118" name="Google Shape;118;p21"/>
+          <p:cNvSpPr txBox="1"/>
+          <p:nvPr>
+            <p:ph idx="4294967295" type="title"/>
+          </p:nvPr>
+        </p:nvSpPr>
+        <p:spPr>
+          <a:xfrm>
+            <a:off x="259350" y="157250"/>
+            <a:ext cx="8520600" cy="572700"/>
+          </a:xfrm>
+          <a:prstGeom prst="rect">
+            <a:avLst/>
+          </a:prstGeom>
+        </p:spPr>
+        <p:txBody>
+          <a:bodyPr anchorCtr="0" anchor="t" bIns="91425" lIns="91425" spcFirstLastPara="1" rIns="91425" wrap="square" tIns="91425">
+            <a:normAutofit fontScale="90000"/>
+          </a:bodyPr>
+          <a:lstStyle/>
+          <a:p>
+            <a:pPr indent="0" lvl="0" marL="0" rtl="0" algn="l">
+              <a:spcBef>
+                <a:spcPts val="0"/>
+              </a:spcBef>
+              <a:spcAft>
+                <a:spcPts val="0"/>
+              </a:spcAft>
+              <a:buNone/>
+            </a:pPr>
+            <a:r>
+              <a:rPr lang="en"/>
+              <a:t>Second derivative test</a:t>
+            </a:r>
+            <a:endParaRPr/>
+          </a:p>
+        </p:txBody>
+      </p:sp>
+      <p:sp>
+        <p:nvSpPr>
+          <p:cNvPr id="119" name="Google Shape;119;p21"/>
+          <p:cNvSpPr txBox="1"/>
+          <p:nvPr/>
+        </p:nvSpPr>
+        <p:spPr>
+          <a:xfrm>
+            <a:off x="381450" y="806388"/>
+            <a:ext cx="3013800" cy="461700"/>
+          </a:xfrm>
+          <a:prstGeom prst="rect">
+            <a:avLst/>
+          </a:prstGeom>
+          <a:noFill/>
+          <a:ln>
+            <a:noFill/>
+          </a:ln>
+        </p:spPr>
+        <p:txBody>
+          <a:bodyPr anchorCtr="0" anchor="t" bIns="91425" lIns="91425" spcFirstLastPara="1" rIns="91425" wrap="square" tIns="91425">
+            <a:spAutoFit/>
+          </a:bodyPr>
+          <a:lstStyle/>
+          <a:p>
+            <a:pPr indent="0" lvl="0" marL="0" rtl="0" algn="l">
+              <a:spcBef>
+                <a:spcPts val="0"/>
+              </a:spcBef>
+              <a:spcAft>
+                <a:spcPts val="0"/>
+              </a:spcAft>
+              <a:buNone/>
+            </a:pPr>
+            <a:r>
+              <a:t/>
+            </a:r>
+            <a:endParaRPr sz="1800">
+              <a:solidFill>
+                <a:schemeClr val="dk2"/>
+              </a:solidFill>
+            </a:endParaRPr>
+          </a:p>
+        </p:txBody>
+      </p:sp>
       <p:pic>
         <p:nvPicPr>
-          <p:cNvPr id="121" name="Google Shape;121;p21"/>
+          <p:cNvPr descr="{&quot;type&quot;:&quot;lalign*&quot;,&quot;code&quot;:&quot;\\begin{lalign*}\n&amp;{f\\left(x_{0}+h\\right)=f\\left(x_{0}\\right)+f^{\\prime}\\left(x_{0}\\right)h+\\frac{1}{2}f^{\&quot;}\\left(x_{0}\\right)h^{2}+\\frac{1}{6}f^{\&quot;\\prime}\\left(x_{0}\\right)h^{3}...}\\\\\n&amp;{\\,\\,\\,\\,\\,\\,\\,\\,\\,\\,\\,\\,\\,\\,\\,\\,\\,\\,\\,\\,\\,\\,\\,\\,\\,\\,\\,=f\\left(x_{0}\\right)+f^{\\prime}\\left(x_{0}\\right)h+\\frac{1}{2}f^{\&quot;}\\left(x_{0}\\right)h^{2}+R\\left(x_{0},h\\right)}\\\\\n&amp;{\\,\\text{When}\\;x_{0}\\;\\text{is}\\;\\text{a}\\;\\text{local}\\;\\text{min/max,}\\;f^{\\prime}\\left(x_{0}\\right)=0.\\,\\text{In}\\;\\text{a}\\;\\text{sufficiently}\\;\\text{small}\\relempty }\\\\\n&amp;{\\text{neighborhood}\\;\\text{of}\\;x_{0}\\,\\text{i.e.,}\\;h\\,\\text{is}\\;\\text{\&quot;small\&quot;,}\\;R\\left(x_{0},h\\right)\\,\\text{is}\\;\\text{negligibly}\\;\\text{small}\\text{}}\\\\\n&amp;{f\\left(x_{0}+h\\right)\\approx f\\left(x_{0}\\right)+\\frac{1}{2}f^{\&quot;}\\left(x_{0}\\right)h^{2}}\\\\\n&amp;{\\text{So,}\\;\\text{when}\\;f^{\&quot;}\\left(x_{0}\\right)&gt;0,\\,f\\left(x_{0}+h\\right)&gt;f\\left(x_{0}\\right),\\,\\text{i.e.,}\\;x_{0\\,}\\text{is}\\;\\text{a}\\;\\text{local}\\;\\text{minimum}}\\\\\n&amp;{\\text{and,}\\;\\text{when}\\;f^{\&quot;}\\left(x_{0}\\right)&lt;0,\\,f\\left(x_{0}+h\\right)&lt;f\\left(x_{0}\\right),\\,\\text{i.e.,}\\;x_{0\\,}\\text{is}\\;\\text{local}\\;\\text{maximum}\\text{}}\\\\\n&amp;{\\text{when}\\;f^{\&quot;}\\left(x_{0}\\right)=0,\\,\\text{test}\\;\\text{i}\\text{s}\\;\\text{inconclusive}}\t\n\\end{lalign*}&quot;,&quot;font&quot;:{&quot;size&quot;:12,&quot;family&quot;:&quot;Arial&quot;,&quot;color&quot;:&quot;#000000&quot;},&quot;backgroundColor&quot;:&quot;#FFFFFF&quot;,&quot;aid&quot;:null,&quot;id&quot;:&quot;7&quot;,&quot;backgroundColorModified&quot;:false,&quot;ts&quot;:1759972713682,&quot;cs&quot;:&quot;Z7Au1euBn/qCTAPHo5tOjQ==&quot;,&quot;size&quot;:{&quot;width&quot;:555,&quot;height&quot;:252.5}}" id="120" name="Google Shape;120;p21"/>
           <p:cNvPicPr preferRelativeResize="0"/>
           <p:nvPr/>
         </p:nvPicPr>
@@ -10696,8 +11300,8 @@
         </p:blipFill>
         <p:spPr>
           <a:xfrm>
-            <a:off x="340100" y="1449475"/>
-            <a:ext cx="4124400" cy="3049964"/>
+            <a:off x="445979" y="806391"/>
+            <a:ext cx="5286375" cy="2405063"/>
           </a:xfrm>
           <a:prstGeom prst="rect">
             <a:avLst/>
@@ -10710,14 +11314,14 @@
       </p:pic>
       <p:sp>
         <p:nvSpPr>
-          <p:cNvPr id="122" name="Google Shape;122;p21"/>
+          <p:cNvPr id="121" name="Google Shape;121;p21"/>
           <p:cNvSpPr txBox="1"/>
           <p:nvPr/>
         </p:nvSpPr>
         <p:spPr>
           <a:xfrm>
-            <a:off x="259350" y="729950"/>
-            <a:ext cx="7513800" cy="646500"/>
+            <a:off x="381450" y="3293550"/>
+            <a:ext cx="7053000" cy="615600"/>
           </a:xfrm>
           <a:prstGeom prst="rect">
             <a:avLst/>
@@ -10743,73 +11347,50 @@
               <a:buNone/>
             </a:pPr>
             <a:r>
-              <a:rPr lang="en" sz="1500">
+              <a:rPr lang="en">
                 <a:solidFill>
                   <a:schemeClr val="dk2"/>
                 </a:solidFill>
               </a:rPr>
-              <a:t>In this case below, we can’t easily solve for f_prime(x) = 0</a:t>
+              <a:t>For some functions (eg., sin(x), log(x)) all higher order derivatives exist. For others, only derivatives up to a </a:t>
             </a:r>
-            <a:br>
-              <a:rPr lang="en" sz="1500">
+            <a:r>
+              <a:rPr lang="en">
                 <a:solidFill>
                   <a:schemeClr val="dk2"/>
                 </a:solidFill>
               </a:rPr>
-            </a:br>
+              <a:t>certain</a:t>
+            </a:r>
             <a:r>
-              <a:rPr lang="en" sz="1500">
+              <a:rPr lang="en">
                 <a:solidFill>
                   <a:schemeClr val="dk2"/>
                 </a:solidFill>
               </a:rPr>
-              <a:t> </a:t>
+              <a:t> order </a:t>
             </a:r>
-            <a:endParaRPr sz="1500">
+            <a:r>
+              <a:rPr lang="en">
+                <a:solidFill>
+                  <a:schemeClr val="dk2"/>
+                </a:solidFill>
+              </a:rPr>
+              <a:t>exist</a:t>
+            </a:r>
+            <a:r>
+              <a:rPr lang="en">
+                <a:solidFill>
+                  <a:schemeClr val="dk2"/>
+                </a:solidFill>
+              </a:rPr>
+              <a:t> (x^n) and higher order derivatives are zero..</a:t>
+            </a:r>
+            <a:endParaRPr>
               <a:solidFill>
                 <a:schemeClr val="dk2"/>
               </a:solidFill>
             </a:endParaRPr>
-          </a:p>
-        </p:txBody>
-      </p:sp>
-      <p:sp>
-        <p:nvSpPr>
-          <p:cNvPr id="123" name="Google Shape;123;p21"/>
-          <p:cNvSpPr txBox="1"/>
-          <p:nvPr>
-            <p:ph idx="4294967295" type="title"/>
-          </p:nvPr>
-        </p:nvSpPr>
-        <p:spPr>
-          <a:xfrm>
-            <a:off x="259350" y="157250"/>
-            <a:ext cx="8520600" cy="572700"/>
-          </a:xfrm>
-          <a:prstGeom prst="rect">
-            <a:avLst/>
-          </a:prstGeom>
-        </p:spPr>
-        <p:txBody>
-          <a:bodyPr anchorCtr="0" anchor="t" bIns="91425" lIns="91425" spcFirstLastPara="1" rIns="91425" wrap="square" tIns="91425">
-            <a:normAutofit fontScale="90000"/>
-          </a:bodyPr>
-          <a:lstStyle/>
-          <a:p>
-            <a:pPr indent="0" lvl="0" marL="0" rtl="0" algn="l">
-              <a:spcBef>
-                <a:spcPts val="0"/>
-              </a:spcBef>
-              <a:spcAft>
-                <a:spcPts val="0"/>
-              </a:spcAft>
-              <a:buNone/>
-            </a:pPr>
-            <a:r>
-              <a:rPr lang="en"/>
-              <a:t>Derivative: Important property</a:t>
-            </a:r>
-            <a:endParaRPr/>
           </a:p>
         </p:txBody>
       </p:sp>
@@ -10822,6 +11403,285 @@
 </file>
 
 <file path=ppt/theme/theme1.xml><?xml version="1.0" encoding="utf-8"?>
+<a:theme xmlns:a="http://schemas.openxmlformats.org/drawingml/2006/main" xmlns:r="http://schemas.openxmlformats.org/officeDocument/2006/relationships" name="Simple Light">
+  <a:themeElements>
+    <a:clrScheme name="Simple Light">
+      <a:dk1>
+        <a:srgbClr val="000000"/>
+      </a:dk1>
+      <a:lt1>
+        <a:srgbClr val="FFFFFF"/>
+      </a:lt1>
+      <a:dk2>
+        <a:srgbClr val="595959"/>
+      </a:dk2>
+      <a:lt2>
+        <a:srgbClr val="EEEEEE"/>
+      </a:lt2>
+      <a:accent1>
+        <a:srgbClr val="4285F4"/>
+      </a:accent1>
+      <a:accent2>
+        <a:srgbClr val="212121"/>
+      </a:accent2>
+      <a:accent3>
+        <a:srgbClr val="78909C"/>
+      </a:accent3>
+      <a:accent4>
+        <a:srgbClr val="FFAB40"/>
+      </a:accent4>
+      <a:accent5>
+        <a:srgbClr val="0097A7"/>
+      </a:accent5>
+      <a:accent6>
+        <a:srgbClr val="EEFF41"/>
+      </a:accent6>
+      <a:hlink>
+        <a:srgbClr val="0097A7"/>
+      </a:hlink>
+      <a:folHlink>
+        <a:srgbClr val="0097A7"/>
+      </a:folHlink>
+    </a:clrScheme>
+    <a:fontScheme name="Office">
+      <a:majorFont>
+        <a:latin typeface="Arial"/>
+        <a:ea typeface=""/>
+        <a:cs typeface=""/>
+        <a:font script="Jpan" typeface="ＭＳ Ｐゴシック"/>
+        <a:font script="Hang" typeface="맑은 고딕"/>
+        <a:font script="Hans" typeface="宋体"/>
+        <a:font script="Hant" typeface="新細明體"/>
+        <a:font script="Arab" typeface="Times New Roman"/>
+        <a:font script="Hebr" typeface="Times New Roman"/>
+        <a:font script="Thai" typeface="Angsana New"/>
+        <a:font script="Ethi" typeface="Nyala"/>
+        <a:font script="Beng" typeface="Vrinda"/>
+        <a:font script="Gujr" typeface="Shruti"/>
+        <a:font script="Khmr" typeface="MoolBoran"/>
+        <a:font script="Knda" typeface="Tunga"/>
+        <a:font script="Guru" typeface="Raavi"/>
+        <a:font script="Cans" typeface="Euphemia"/>
+        <a:font script="Cher" typeface="Plantagenet Cherokee"/>
+        <a:font script="Yiii" typeface="Microsoft Yi Baiti"/>
+        <a:font script="Tibt" typeface="Microsoft Himalaya"/>
+        <a:font script="Thaa" typeface="MV Boli"/>
+        <a:font script="Deva" typeface="Mangal"/>
+        <a:font script="Telu" typeface="Gautami"/>
+        <a:font script="Taml" typeface="Latha"/>
+        <a:font script="Syrc" typeface="Estrangelo Edessa"/>
+        <a:font script="Orya" typeface="Kalinga"/>
+        <a:font script="Mlym" typeface="Kartika"/>
+        <a:font script="Laoo" typeface="DokChampa"/>
+        <a:font script="Sinh" typeface="Iskoola Pota"/>
+        <a:font script="Mong" typeface="Mongolian Baiti"/>
+        <a:font script="Viet" typeface="Times New Roman"/>
+        <a:font script="Uigh" typeface="Microsoft Uighur"/>
+        <a:font script="Geor" typeface="Sylfaen"/>
+      </a:majorFont>
+      <a:minorFont>
+        <a:latin typeface="Arial"/>
+        <a:ea typeface=""/>
+        <a:cs typeface=""/>
+        <a:font script="Jpan" typeface="ＭＳ Ｐゴシック"/>
+        <a:font script="Hang" typeface="맑은 고딕"/>
+        <a:font script="Hans" typeface="宋体"/>
+        <a:font script="Hant" typeface="新細明體"/>
+        <a:font script="Arab" typeface="Arial"/>
+        <a:font script="Hebr" typeface="Arial"/>
+        <a:font script="Thai" typeface="Cordia New"/>
+        <a:font script="Ethi" typeface="Nyala"/>
+        <a:font script="Beng" typeface="Vrinda"/>
+        <a:font script="Gujr" typeface="Shruti"/>
+        <a:font script="Khmr" typeface="DaunPenh"/>
+        <a:font script="Knda" typeface="Tunga"/>
+        <a:font script="Guru" typeface="Raavi"/>
+        <a:font script="Cans" typeface="Euphemia"/>
+        <a:font script="Cher" typeface="Plantagenet Cherokee"/>
+        <a:font script="Yiii" typeface="Microsoft Yi Baiti"/>
+        <a:font script="Tibt" typeface="Microsoft Himalaya"/>
+        <a:font script="Thaa" typeface="MV Boli"/>
+        <a:font script="Deva" typeface="Mangal"/>
+        <a:font script="Telu" typeface="Gautami"/>
+        <a:font script="Taml" typeface="Latha"/>
+        <a:font script="Syrc" typeface="Estrangelo Edessa"/>
+        <a:font script="Orya" typeface="Kalinga"/>
+        <a:font script="Mlym" typeface="Kartika"/>
+        <a:font script="Laoo" typeface="DokChampa"/>
+        <a:font script="Sinh" typeface="Iskoola Pota"/>
+        <a:font script="Mong" typeface="Mongolian Baiti"/>
+        <a:font script="Viet" typeface="Arial"/>
+        <a:font script="Uigh" typeface="Microsoft Uighur"/>
+        <a:font script="Geor" typeface="Sylfaen"/>
+      </a:minorFont>
+    </a:fontScheme>
+    <a:fmtScheme name="Office">
+      <a:fillStyleLst>
+        <a:solidFill>
+          <a:schemeClr val="phClr"/>
+        </a:solidFill>
+        <a:gradFill rotWithShape="1">
+          <a:gsLst>
+            <a:gs pos="0">
+              <a:schemeClr val="phClr">
+                <a:tint val="50000"/>
+                <a:satMod val="300000"/>
+              </a:schemeClr>
+            </a:gs>
+            <a:gs pos="35000">
+              <a:schemeClr val="phClr">
+                <a:tint val="37000"/>
+                <a:satMod val="300000"/>
+              </a:schemeClr>
+            </a:gs>
+            <a:gs pos="100000">
+              <a:schemeClr val="phClr">
+                <a:tint val="15000"/>
+                <a:satMod val="350000"/>
+              </a:schemeClr>
+            </a:gs>
+          </a:gsLst>
+          <a:lin ang="16200000" scaled="1"/>
+        </a:gradFill>
+        <a:gradFill rotWithShape="1">
+          <a:gsLst>
+            <a:gs pos="0">
+              <a:schemeClr val="phClr">
+                <a:tint val="100000"/>
+                <a:shade val="100000"/>
+                <a:satMod val="130000"/>
+              </a:schemeClr>
+            </a:gs>
+            <a:gs pos="100000">
+              <a:schemeClr val="phClr">
+                <a:tint val="50000"/>
+                <a:shade val="100000"/>
+                <a:satMod val="350000"/>
+              </a:schemeClr>
+            </a:gs>
+          </a:gsLst>
+          <a:lin ang="16200000" scaled="0"/>
+        </a:gradFill>
+      </a:fillStyleLst>
+      <a:lnStyleLst>
+        <a:ln w="9525" cap="flat" cmpd="sng" algn="ctr">
+          <a:solidFill>
+            <a:schemeClr val="phClr">
+              <a:shade val="95000"/>
+              <a:satMod val="105000"/>
+            </a:schemeClr>
+          </a:solidFill>
+          <a:prstDash val="solid"/>
+        </a:ln>
+        <a:ln w="25400" cap="flat" cmpd="sng" algn="ctr">
+          <a:solidFill>
+            <a:schemeClr val="phClr"/>
+          </a:solidFill>
+          <a:prstDash val="solid"/>
+        </a:ln>
+        <a:ln w="38100" cap="flat" cmpd="sng" algn="ctr">
+          <a:solidFill>
+            <a:schemeClr val="phClr"/>
+          </a:solidFill>
+          <a:prstDash val="solid"/>
+        </a:ln>
+      </a:lnStyleLst>
+      <a:effectStyleLst>
+        <a:effectStyle>
+          <a:effectLst>
+            <a:outerShdw blurRad="40000" dist="20000" dir="5400000" rotWithShape="0">
+              <a:srgbClr val="000000">
+                <a:alpha val="38000"/>
+              </a:srgbClr>
+            </a:outerShdw>
+          </a:effectLst>
+        </a:effectStyle>
+        <a:effectStyle>
+          <a:effectLst>
+            <a:outerShdw blurRad="40000" dist="23000" dir="5400000" rotWithShape="0">
+              <a:srgbClr val="000000">
+                <a:alpha val="35000"/>
+              </a:srgbClr>
+            </a:outerShdw>
+          </a:effectLst>
+        </a:effectStyle>
+        <a:effectStyle>
+          <a:effectLst>
+            <a:outerShdw blurRad="40000" dist="23000" dir="5400000" rotWithShape="0">
+              <a:srgbClr val="000000">
+                <a:alpha val="35000"/>
+              </a:srgbClr>
+            </a:outerShdw>
+          </a:effectLst>
+          <a:scene3d>
+            <a:camera prst="orthographicFront">
+              <a:rot lat="0" lon="0" rev="0"/>
+            </a:camera>
+            <a:lightRig rig="threePt" dir="t">
+              <a:rot lat="0" lon="0" rev="1200000"/>
+            </a:lightRig>
+          </a:scene3d>
+          <a:sp3d>
+            <a:bevelT w="63500" h="25400"/>
+          </a:sp3d>
+        </a:effectStyle>
+      </a:effectStyleLst>
+      <a:bgFillStyleLst>
+        <a:solidFill>
+          <a:schemeClr val="phClr"/>
+        </a:solidFill>
+        <a:gradFill rotWithShape="1">
+          <a:gsLst>
+            <a:gs pos="0">
+              <a:schemeClr val="phClr">
+                <a:tint val="40000"/>
+                <a:satMod val="350000"/>
+              </a:schemeClr>
+            </a:gs>
+            <a:gs pos="40000">
+              <a:schemeClr val="phClr">
+                <a:tint val="45000"/>
+                <a:shade val="99000"/>
+                <a:satMod val="350000"/>
+              </a:schemeClr>
+            </a:gs>
+            <a:gs pos="100000">
+              <a:schemeClr val="phClr">
+                <a:shade val="20000"/>
+                <a:satMod val="255000"/>
+              </a:schemeClr>
+            </a:gs>
+          </a:gsLst>
+          <a:path path="circle">
+            <a:fillToRect l="50000" t="-80000" r="50000" b="180000"/>
+          </a:path>
+        </a:gradFill>
+        <a:gradFill rotWithShape="1">
+          <a:gsLst>
+            <a:gs pos="0">
+              <a:schemeClr val="phClr">
+                <a:tint val="80000"/>
+                <a:satMod val="300000"/>
+              </a:schemeClr>
+            </a:gs>
+            <a:gs pos="100000">
+              <a:schemeClr val="phClr">
+                <a:shade val="30000"/>
+                <a:satMod val="200000"/>
+              </a:schemeClr>
+            </a:gs>
+          </a:gsLst>
+          <a:path path="circle">
+            <a:fillToRect l="50000" t="50000" r="50000" b="50000"/>
+          </a:path>
+        </a:gradFill>
+      </a:bgFillStyleLst>
+    </a:fmtScheme>
+  </a:themeElements>
+</a:theme>
+</file>
+
+<file path=ppt/theme/theme2.xml><?xml version="1.0" encoding="utf-8"?>
 <a:theme xmlns:a="http://schemas.openxmlformats.org/drawingml/2006/main" xmlns:r="http://schemas.openxmlformats.org/officeDocument/2006/relationships">
   <a:themeElements>
     <a:clrScheme name="Default">
@@ -11098,283 +11958,4 @@
     </a:fmtScheme>
   </a:themeElements>
 </a:theme>
-</file>
-
-<file path=ppt/theme/theme2.xml><?xml version="1.0" encoding="utf-8"?>
-<a:theme xmlns:a="http://schemas.openxmlformats.org/drawingml/2006/main" xmlns:r="http://schemas.openxmlformats.org/officeDocument/2006/relationships" name="Simple Light">
-  <a:themeElements>
-    <a:clrScheme name="Simple Light">
-      <a:dk1>
-        <a:srgbClr val="000000"/>
-      </a:dk1>
-      <a:lt1>
-        <a:srgbClr val="FFFFFF"/>
-      </a:lt1>
-      <a:dk2>
-        <a:srgbClr val="595959"/>
-      </a:dk2>
-      <a:lt2>
-        <a:srgbClr val="EEEEEE"/>
-      </a:lt2>
-      <a:accent1>
-        <a:srgbClr val="4285F4"/>
-      </a:accent1>
-      <a:accent2>
-        <a:srgbClr val="212121"/>
-      </a:accent2>
-      <a:accent3>
-        <a:srgbClr val="78909C"/>
-      </a:accent3>
-      <a:accent4>
-        <a:srgbClr val="FFAB40"/>
-      </a:accent4>
-      <a:accent5>
-        <a:srgbClr val="0097A7"/>
-      </a:accent5>
-      <a:accent6>
-        <a:srgbClr val="EEFF41"/>
-      </a:accent6>
-      <a:hlink>
-        <a:srgbClr val="0097A7"/>
-      </a:hlink>
-      <a:folHlink>
-        <a:srgbClr val="0097A7"/>
-      </a:folHlink>
-    </a:clrScheme>
-    <a:fontScheme name="Office">
-      <a:majorFont>
-        <a:latin typeface="Arial"/>
-        <a:ea typeface=""/>
-        <a:cs typeface=""/>
-        <a:font script="Jpan" typeface="ＭＳ Ｐゴシック"/>
-        <a:font script="Hang" typeface="맑은 고딕"/>
-        <a:font script="Hans" typeface="宋体"/>
-        <a:font script="Hant" typeface="新細明體"/>
-        <a:font script="Arab" typeface="Times New Roman"/>
-        <a:font script="Hebr" typeface="Times New Roman"/>
-        <a:font script="Thai" typeface="Angsana New"/>
-        <a:font script="Ethi" typeface="Nyala"/>
-        <a:font script="Beng" typeface="Vrinda"/>
-        <a:font script="Gujr" typeface="Shruti"/>
-        <a:font script="Khmr" typeface="MoolBoran"/>
-        <a:font script="Knda" typeface="Tunga"/>
-        <a:font script="Guru" typeface="Raavi"/>
-        <a:font script="Cans" typeface="Euphemia"/>
-        <a:font script="Cher" typeface="Plantagenet Cherokee"/>
-        <a:font script="Yiii" typeface="Microsoft Yi Baiti"/>
-        <a:font script="Tibt" typeface="Microsoft Himalaya"/>
-        <a:font script="Thaa" typeface="MV Boli"/>
-        <a:font script="Deva" typeface="Mangal"/>
-        <a:font script="Telu" typeface="Gautami"/>
-        <a:font script="Taml" typeface="Latha"/>
-        <a:font script="Syrc" typeface="Estrangelo Edessa"/>
-        <a:font script="Orya" typeface="Kalinga"/>
-        <a:font script="Mlym" typeface="Kartika"/>
-        <a:font script="Laoo" typeface="DokChampa"/>
-        <a:font script="Sinh" typeface="Iskoola Pota"/>
-        <a:font script="Mong" typeface="Mongolian Baiti"/>
-        <a:font script="Viet" typeface="Times New Roman"/>
-        <a:font script="Uigh" typeface="Microsoft Uighur"/>
-        <a:font script="Geor" typeface="Sylfaen"/>
-      </a:majorFont>
-      <a:minorFont>
-        <a:latin typeface="Arial"/>
-        <a:ea typeface=""/>
-        <a:cs typeface=""/>
-        <a:font script="Jpan" typeface="ＭＳ Ｐゴシック"/>
-        <a:font script="Hang" typeface="맑은 고딕"/>
-        <a:font script="Hans" typeface="宋体"/>
-        <a:font script="Hant" typeface="新細明體"/>
-        <a:font script="Arab" typeface="Arial"/>
-        <a:font script="Hebr" typeface="Arial"/>
-        <a:font script="Thai" typeface="Cordia New"/>
-        <a:font script="Ethi" typeface="Nyala"/>
-        <a:font script="Beng" typeface="Vrinda"/>
-        <a:font script="Gujr" typeface="Shruti"/>
-        <a:font script="Khmr" typeface="DaunPenh"/>
-        <a:font script="Knda" typeface="Tunga"/>
-        <a:font script="Guru" typeface="Raavi"/>
-        <a:font script="Cans" typeface="Euphemia"/>
-        <a:font script="Cher" typeface="Plantagenet Cherokee"/>
-        <a:font script="Yiii" typeface="Microsoft Yi Baiti"/>
-        <a:font script="Tibt" typeface="Microsoft Himalaya"/>
-        <a:font script="Thaa" typeface="MV Boli"/>
-        <a:font script="Deva" typeface="Mangal"/>
-        <a:font script="Telu" typeface="Gautami"/>
-        <a:font script="Taml" typeface="Latha"/>
-        <a:font script="Syrc" typeface="Estrangelo Edessa"/>
-        <a:font script="Orya" typeface="Kalinga"/>
-        <a:font script="Mlym" typeface="Kartika"/>
-        <a:font script="Laoo" typeface="DokChampa"/>
-        <a:font script="Sinh" typeface="Iskoola Pota"/>
-        <a:font script="Mong" typeface="Mongolian Baiti"/>
-        <a:font script="Viet" typeface="Arial"/>
-        <a:font script="Uigh" typeface="Microsoft Uighur"/>
-        <a:font script="Geor" typeface="Sylfaen"/>
-      </a:minorFont>
-    </a:fontScheme>
-    <a:fmtScheme name="Office">
-      <a:fillStyleLst>
-        <a:solidFill>
-          <a:schemeClr val="phClr"/>
-        </a:solidFill>
-        <a:gradFill rotWithShape="1">
-          <a:gsLst>
-            <a:gs pos="0">
-              <a:schemeClr val="phClr">
-                <a:tint val="50000"/>
-                <a:satMod val="300000"/>
-              </a:schemeClr>
-            </a:gs>
-            <a:gs pos="35000">
-              <a:schemeClr val="phClr">
-                <a:tint val="37000"/>
-                <a:satMod val="300000"/>
-              </a:schemeClr>
-            </a:gs>
-            <a:gs pos="100000">
-              <a:schemeClr val="phClr">
-                <a:tint val="15000"/>
-                <a:satMod val="350000"/>
-              </a:schemeClr>
-            </a:gs>
-          </a:gsLst>
-          <a:lin ang="16200000" scaled="1"/>
-        </a:gradFill>
-        <a:gradFill rotWithShape="1">
-          <a:gsLst>
-            <a:gs pos="0">
-              <a:schemeClr val="phClr">
-                <a:tint val="100000"/>
-                <a:shade val="100000"/>
-                <a:satMod val="130000"/>
-              </a:schemeClr>
-            </a:gs>
-            <a:gs pos="100000">
-              <a:schemeClr val="phClr">
-                <a:tint val="50000"/>
-                <a:shade val="100000"/>
-                <a:satMod val="350000"/>
-              </a:schemeClr>
-            </a:gs>
-          </a:gsLst>
-          <a:lin ang="16200000" scaled="0"/>
-        </a:gradFill>
-      </a:fillStyleLst>
-      <a:lnStyleLst>
-        <a:ln w="9525" cap="flat" cmpd="sng" algn="ctr">
-          <a:solidFill>
-            <a:schemeClr val="phClr">
-              <a:shade val="95000"/>
-              <a:satMod val="105000"/>
-            </a:schemeClr>
-          </a:solidFill>
-          <a:prstDash val="solid"/>
-        </a:ln>
-        <a:ln w="25400" cap="flat" cmpd="sng" algn="ctr">
-          <a:solidFill>
-            <a:schemeClr val="phClr"/>
-          </a:solidFill>
-          <a:prstDash val="solid"/>
-        </a:ln>
-        <a:ln w="38100" cap="flat" cmpd="sng" algn="ctr">
-          <a:solidFill>
-            <a:schemeClr val="phClr"/>
-          </a:solidFill>
-          <a:prstDash val="solid"/>
-        </a:ln>
-      </a:lnStyleLst>
-      <a:effectStyleLst>
-        <a:effectStyle>
-          <a:effectLst>
-            <a:outerShdw blurRad="40000" dist="20000" dir="5400000" rotWithShape="0">
-              <a:srgbClr val="000000">
-                <a:alpha val="38000"/>
-              </a:srgbClr>
-            </a:outerShdw>
-          </a:effectLst>
-        </a:effectStyle>
-        <a:effectStyle>
-          <a:effectLst>
-            <a:outerShdw blurRad="40000" dist="23000" dir="5400000" rotWithShape="0">
-              <a:srgbClr val="000000">
-                <a:alpha val="35000"/>
-              </a:srgbClr>
-            </a:outerShdw>
-          </a:effectLst>
-        </a:effectStyle>
-        <a:effectStyle>
-          <a:effectLst>
-            <a:outerShdw blurRad="40000" dist="23000" dir="5400000" rotWithShape="0">
-              <a:srgbClr val="000000">
-                <a:alpha val="35000"/>
-              </a:srgbClr>
-            </a:outerShdw>
-          </a:effectLst>
-          <a:scene3d>
-            <a:camera prst="orthographicFront">
-              <a:rot lat="0" lon="0" rev="0"/>
-            </a:camera>
-            <a:lightRig rig="threePt" dir="t">
-              <a:rot lat="0" lon="0" rev="1200000"/>
-            </a:lightRig>
-          </a:scene3d>
-          <a:sp3d>
-            <a:bevelT w="63500" h="25400"/>
-          </a:sp3d>
-        </a:effectStyle>
-      </a:effectStyleLst>
-      <a:bgFillStyleLst>
-        <a:solidFill>
-          <a:schemeClr val="phClr"/>
-        </a:solidFill>
-        <a:gradFill rotWithShape="1">
-          <a:gsLst>
-            <a:gs pos="0">
-              <a:schemeClr val="phClr">
-                <a:tint val="40000"/>
-                <a:satMod val="350000"/>
-              </a:schemeClr>
-            </a:gs>
-            <a:gs pos="40000">
-              <a:schemeClr val="phClr">
-                <a:tint val="45000"/>
-                <a:shade val="99000"/>
-                <a:satMod val="350000"/>
-              </a:schemeClr>
-            </a:gs>
-            <a:gs pos="100000">
-              <a:schemeClr val="phClr">
-                <a:shade val="20000"/>
-                <a:satMod val="255000"/>
-              </a:schemeClr>
-            </a:gs>
-          </a:gsLst>
-          <a:path path="circle">
-            <a:fillToRect l="50000" t="-80000" r="50000" b="180000"/>
-          </a:path>
-        </a:gradFill>
-        <a:gradFill rotWithShape="1">
-          <a:gsLst>
-            <a:gs pos="0">
-              <a:schemeClr val="phClr">
-                <a:tint val="80000"/>
-                <a:satMod val="300000"/>
-              </a:schemeClr>
-            </a:gs>
-            <a:gs pos="100000">
-              <a:schemeClr val="phClr">
-                <a:shade val="30000"/>
-                <a:satMod val="200000"/>
-              </a:schemeClr>
-            </a:gs>
-          </a:gsLst>
-          <a:path path="circle">
-            <a:fillToRect l="50000" t="50000" r="50000" b="50000"/>
-          </a:path>
-        </a:gradFill>
-      </a:bgFillStyleLst>
-    </a:fmtScheme>
-  </a:themeElements>
-</a:theme>
 </file>
</xml_diff>

<commit_message>
updated code/slides for module 1, class 1
</commit_message>
<xml_diff>
--- a/Module 1/class_1.2/deep_learning_course_class_1.2.pptx
+++ b/Module 1/class_1.2/deep_learning_course_class_1.2.pptx
@@ -2075,7 +2075,8 @@
               <a:buNone/>
             </a:pPr>
             <a:r>
-              <a:t/>
+              <a:rPr lang="en"/>
+              <a:t>Talk about notation.. </a:t>
             </a:r>
             <a:endParaRPr/>
           </a:p>
@@ -10780,7 +10781,7 @@
       </p:sp>
       <p:pic>
         <p:nvPicPr>
-          <p:cNvPr descr="{&quot;aid&quot;:null,&quot;font&quot;:{&quot;color&quot;:&quot;#000000&quot;,&quot;size&quot;:12,&quot;family&quot;:&quot;Arial&quot;},&quot;backgroundColorModified&quot;:false,&quot;backgroundColor&quot;:&quot;#FFFFFF&quot;,&quot;code&quot;:&quot;\\begin{lalign*}\n&amp;{\\text{Product}\\;\\text{Rule}}\\\\\n&amp;{f\\left(x\\right)=g\\left(x\\right)f\\left(x\\right)}\\\\\n&amp;{f^{\\prime}\\left(x\\right)=\\frac{\\dd f}{\\dd x}=f\\left(x\\right)g^{\\prime}\\left(x\\right)+g\\left(x\\right)f^{\\prime}\\left(x\\right)}\\\\\n&amp;{\\text{eg.,}\\;f\\left(x\\right)=\\sin\\left(x\\right)\\log_{}\\left(x\\right)}\\\\\n&amp;{f^{\\prime}\\left(x\\right)=\\,\\frac{\\sin\\left(x\\right)}{x}+\\log_{}\\left(x\\right)\\cos\\left(x\\right)\\,}\\\\\n&amp;{\\because \\frac{\\dd \\log_{}\\left(x\\right)}{\\dd x}=\\frac{1}{x},\\,\\frac{\\dd sin\\left(x\\right)}{\\dd x}=\\cos\\left(x\\right)}\\\\\n&amp;{}\\\\\n&amp;{\\text{Chain}\\;\\text{Rule}}\\\\\n&amp;{f\\left(x\\right)=g\\left(h\\left(x\\right)\\right)}\\\\\n&amp;{f^{\\prime}\\left(x\\right)=h^{\\prime}\\left(x\\right)g^{\\prime}\\left(h\\left(x\\right)\\right)}\\\\\n&amp;{\\text{eg.,}\\;f\\left(x\\right)=\\sin\\left(\\log_{}\\left(x\\right)\\right)}\\\\\n&amp;{f^{\\prime}\\left(x\\right)=\\frac{1}{x}\\cos\\left(\\log_{}\\left(x\\right)\\right)\\,}\\\\\n&amp;{\\text{eg}\\;\\text{2:}\\;\\frac{\\dd \\log_{}\\left(f\\left(x\\right)\\right)}{\\dd x}=\\frac{f^{\\prime}\\left(x\\right)}{f\\left(x\\right)}}\t\n\\end{lalign*}&quot;,&quot;id&quot;:&quot;1&quot;,&quot;type&quot;:&quot;lalign*&quot;,&quot;ts&quot;:1758933737120,&quot;cs&quot;:&quot;ywcLxi8nzu3yP2BigWBsVQ==&quot;,&quot;size&quot;:{&quot;width&quot;:309.33333333333337,&quot;height&quot;:421.6666666666667}}" id="101" name="Google Shape;101;p19"/>
+          <p:cNvPr descr="{&quot;backgroundColorModified&quot;:false,&quot;aid&quot;:null,&quot;backgroundColor&quot;:&quot;#FFFFFF&quot;,&quot;type&quot;:&quot;lalign*&quot;,&quot;code&quot;:&quot;\\begin{lalign*}\n&amp;{\\text{Product}\\;\\text{Rule}}\\\\\n&amp;{h\\left(x\\right)=f\\left(x\\right)g\\left(x\\right)}\\\\\n&amp;{\\nabla x=h^{\\prime}\\left(x\\right)=\\frac{\\dd h\\left(x\\right)}{\\dd x}=f\\left(x\\right)g^{\\prime}\\left(x\\right)+g\\left(x\\right)f^{\\prime}\\left(x\\right)}\\\\\n&amp;{\\text{eg.,}\\;h\\left(x\\right)=\\sin\\left(x\\right)\\log_{}\\left(x\\right)}\\\\\n&amp;{h^{\\prime}\\left(x\\right)=\\,\\frac{\\sin\\left(x\\right)}{x}+\\log_{}\\left(x\\right)\\cos\\left(x\\right)\\,}\\\\\n&amp;{\\because \\frac{\\dd \\log_{}\\left(x\\right)}{\\dd x}=\\frac{1}{x},\\,\\frac{\\dd sin\\left(x\\right)}{\\dd x}=\\cos\\left(x\\right)}\\\\\n&amp;{}\\\\\n&amp;{\\text{Chain}\\;\\text{Rule}}\\\\\n&amp;{f\\left(x\\right)=g\\left(h\\left(x\\right)\\right)}\\\\\n&amp;{f^{\\prime}\\left(x\\right)=h^{\\prime}\\left(x\\right)g^{\\prime}\\left(h\\left(x\\right)\\right)}\\\\\n&amp;{\\text{eg.,}\\;f\\left(x\\right)=\\sin\\left(\\log_{}\\left(x\\right)\\right)}\\\\\n&amp;{f^{\\prime}\\left(x\\right)=\\frac{1}{x}\\cos\\left(\\log_{}\\left(x\\right)\\right)\\,}\\\\\n&amp;{\\text{eg}\\;\\text{2:}\\;\\frac{\\dd \\log_{}\\left(f\\left(x\\right)\\right)}{\\dd x}=\\frac{f^{\\prime}\\left(x\\right)}{f\\left(x\\right)}}\t\n\\end{lalign*}&quot;,&quot;id&quot;:&quot;1&quot;,&quot;font&quot;:{&quot;size&quot;:12,&quot;family&quot;:&quot;Arial&quot;,&quot;color&quot;:&quot;#000000&quot;},&quot;ts&quot;:1760702371219,&quot;cs&quot;:&quot;vFZCyKExv+0EkqeAh0/zYg==&quot;,&quot;size&quot;:{&quot;width&quot;:388.6666666666667,&quot;height&quot;:423.3333333333333}}" id="101" name="Google Shape;101;p19"/>
           <p:cNvPicPr preferRelativeResize="0"/>
           <p:nvPr/>
         </p:nvPicPr>
@@ -10794,8 +10795,8 @@
         </p:blipFill>
         <p:spPr>
           <a:xfrm>
-            <a:off x="549382" y="806450"/>
-            <a:ext cx="2946400" cy="4016375"/>
+            <a:off x="530332" y="806462"/>
+            <a:ext cx="3702050" cy="4032250"/>
           </a:xfrm>
           <a:prstGeom prst="rect">
             <a:avLst/>
@@ -11148,7 +11149,7 @@
       </p:pic>
       <p:pic>
         <p:nvPicPr>
-          <p:cNvPr descr="{&quot;backgroundColor&quot;:&quot;#FFFFFF&quot;,&quot;backgroundColorModified&quot;:false,&quot;type&quot;:&quot;lalign*&quot;,&quot;font&quot;:{&quot;size&quot;:9,&quot;family&quot;:&quot;Arial&quot;,&quot;color&quot;:&quot;#000000&quot;},&quot;id&quot;:&quot;6&quot;,&quot;code&quot;:&quot;\\begin{lalign*}\n&amp;{\\text{To}\\;\\text{move}\\;\\text{towards}\\;\\text{the}\\;\\text{minimum}\\;\\text{from}\\;\\text{any}\\;\\text{point,}\\;\\text{I}\\;\\text{need}\\;\\text{to}\\;\\text{know:}}\\\\\n&amp;{1.\\,\\text{Which}\\;\\text{direction}\\;\\text{should}\\;\\text{I}\\;\\text{move}\\;\\text{(left/right)}}\\\\\n&amp;{2.\\,\\text{How}\\;\\text{much}\\;\\text{should}\\;\\text{I}\\;\\text{move}}\\\\\n&amp;{\\text{Gradient}\\;\\text{gives}\\;\\text{us}\\;\\text{both.}\\;\\text{}}\\\\\n&amp;{Eg.,\\,\\text{At}\\;\\text{x}\\;\\text{=}\\;\\text{4.5,}\\;f^{\\prime}\\left(x\\right)=3.\\,\\text{Since}\\;f^{\\prime}\\left(x\\right)&gt;0,\\,\\text{w}\\text{e}\\;\\text{step}\\;\\text{to}\\;\\text{the}\\;\\text{left,}\\;\\text{by}\\;\\text{}}\\\\\n&amp;{\\text{learning}\\;\\text{rate}\\;\\times\\,3}\\\\\n&amp;{\\text{At}\\;\\text{x=-4.5,}\\;f^{\\prime}\\left(x\\right)=-15.\\,\\,\\text{Since}\\;f^{\\prime}\\left(x\\right)&lt;0,\\,\\text{w}\\text{e}\\;\\text{step}\\;\\text{to}\\;\\text{the}\\;\\text{right,}\\;\\text{by}}\\\\\n&amp;{\\text{learning}\\;\\text{rate}\\;\\times\\,15}\t\n\\end{lalign*}&quot;,&quot;aid&quot;:null,&quot;ts&quot;:1759605483807,&quot;cs&quot;:&quot;H30tX8KikYsIGLeUjTG74Q==&quot;,&quot;size&quot;:{&quot;width&quot;:424.99478267716535,&quot;height&quot;:149.5144}}" id="113" name="Google Shape;113;p20"/>
+          <p:cNvPr descr="{&quot;font&quot;:{&quot;size&quot;:9,&quot;family&quot;:&quot;Arial&quot;,&quot;color&quot;:&quot;#000000&quot;},&quot;type&quot;:&quot;lalign*&quot;,&quot;id&quot;:&quot;6&quot;,&quot;backgroundColor&quot;:&quot;#FFFFFF&quot;,&quot;code&quot;:&quot;\\begin{lalign*}\n&amp;{\\text{To}\\;\\text{move}\\;\\text{towards}\\;\\text{the}\\;\\text{minimum}\\;\\text{from}\\;\\text{any}\\;\\text{point,}\\;\\text{I}\\;\\text{need}\\;\\text{to}\\;\\text{know:}}\\\\\n&amp;{1.\\,\\text{Which}\\;\\text{direction}\\;\\text{should}\\;\\text{I}\\;\\text{move}\\;\\text{(left/right)}}\\\\\n&amp;{2.\\,\\text{How}\\;\\text{much}\\;\\text{should}\\;\\text{I}\\;\\text{move}}\\\\\n&amp;{\\text{Gradient}\\;\\text{gives}\\;\\text{us}\\;\\text{both.}\\;\\text{}}\\\\\n&amp;{Eg.,\\,\\text{At}\\;\\text{x}\\;\\text{=}\\;\\text{4.5,}\\;f^{\\prime}\\left(x\\right)=3.\\,\\text{Since}\\;f^{\\prime}\\left(x\\right)&gt;0,\\,\\text{w}\\text{e}\\;\\text{step}\\;\\text{to}\\;\\text{the}\\;\\text{left,}\\;\\text{by}\\;\\text{}}\\\\\n&amp;{\\text{learning}\\;\\text{rate}\\;\\times\\,3}\\\\\n&amp;{\\text{At}\\;\\text{x=2,}\\;f^{\\prime}\\left(x\\right)=-2.\\,\\,\\text{Since}\\;f^{\\prime}\\left(x\\right)&lt;0,\\,\\text{w}\\text{e}\\;\\text{step}\\;\\text{to}\\;\\text{the}\\;\\text{right,}\\;\\text{by}}\\\\\n&amp;{\\text{learning}\\;\\text{rate}\\;\\times\\,2}\t\n\\end{lalign*}&quot;,&quot;aid&quot;:null,&quot;backgroundColorModified&quot;:false,&quot;ts&quot;:1760702774072,&quot;cs&quot;:&quot;dn4x7Xar5PwxNvW6wqzAKQ==&quot;,&quot;size&quot;:{&quot;width&quot;:406,&quot;height&quot;:142.66666666666666}}" id="113" name="Google Shape;113;p20"/>
           <p:cNvPicPr preferRelativeResize="0"/>
           <p:nvPr/>
         </p:nvPicPr>
@@ -11162,8 +11163,8 @@
         </p:blipFill>
         <p:spPr>
           <a:xfrm>
-            <a:off x="4686600" y="3205375"/>
-            <a:ext cx="4048075" cy="1424125"/>
+            <a:off x="4688188" y="3206783"/>
+            <a:ext cx="3867150" cy="1358900"/>
           </a:xfrm>
           <a:prstGeom prst="rect">
             <a:avLst/>
@@ -11403,6 +11404,285 @@
 </file>
 
 <file path=ppt/theme/theme1.xml><?xml version="1.0" encoding="utf-8"?>
+<a:theme xmlns:a="http://schemas.openxmlformats.org/drawingml/2006/main" xmlns:r="http://schemas.openxmlformats.org/officeDocument/2006/relationships">
+  <a:themeElements>
+    <a:clrScheme name="Default">
+      <a:dk1>
+        <a:srgbClr val="000000"/>
+      </a:dk1>
+      <a:lt1>
+        <a:srgbClr val="FFFFFF"/>
+      </a:lt1>
+      <a:dk2>
+        <a:srgbClr val="158158"/>
+      </a:dk2>
+      <a:lt2>
+        <a:srgbClr val="F3F3F3"/>
+      </a:lt2>
+      <a:accent1>
+        <a:srgbClr val="058DC7"/>
+      </a:accent1>
+      <a:accent2>
+        <a:srgbClr val="50B432"/>
+      </a:accent2>
+      <a:accent3>
+        <a:srgbClr val="ED561B"/>
+      </a:accent3>
+      <a:accent4>
+        <a:srgbClr val="EDEF00"/>
+      </a:accent4>
+      <a:accent5>
+        <a:srgbClr val="24CBE5"/>
+      </a:accent5>
+      <a:accent6>
+        <a:srgbClr val="64E572"/>
+      </a:accent6>
+      <a:hlink>
+        <a:srgbClr val="2200CC"/>
+      </a:hlink>
+      <a:folHlink>
+        <a:srgbClr val="551A8B"/>
+      </a:folHlink>
+    </a:clrScheme>
+    <a:fontScheme name="Office">
+      <a:majorFont>
+        <a:latin typeface="Arial"/>
+        <a:ea typeface=""/>
+        <a:cs typeface=""/>
+        <a:font script="Jpan" typeface="ＭＳ Ｐゴシック"/>
+        <a:font script="Hang" typeface="맑은 고딕"/>
+        <a:font script="Hans" typeface="宋体"/>
+        <a:font script="Hant" typeface="新細明體"/>
+        <a:font script="Arab" typeface="Times New Roman"/>
+        <a:font script="Hebr" typeface="Times New Roman"/>
+        <a:font script="Thai" typeface="Angsana New"/>
+        <a:font script="Ethi" typeface="Nyala"/>
+        <a:font script="Beng" typeface="Vrinda"/>
+        <a:font script="Gujr" typeface="Shruti"/>
+        <a:font script="Khmr" typeface="MoolBoran"/>
+        <a:font script="Knda" typeface="Tunga"/>
+        <a:font script="Guru" typeface="Raavi"/>
+        <a:font script="Cans" typeface="Euphemia"/>
+        <a:font script="Cher" typeface="Plantagenet Cherokee"/>
+        <a:font script="Yiii" typeface="Microsoft Yi Baiti"/>
+        <a:font script="Tibt" typeface="Microsoft Himalaya"/>
+        <a:font script="Thaa" typeface="MV Boli"/>
+        <a:font script="Deva" typeface="Mangal"/>
+        <a:font script="Telu" typeface="Gautami"/>
+        <a:font script="Taml" typeface="Latha"/>
+        <a:font script="Syrc" typeface="Estrangelo Edessa"/>
+        <a:font script="Orya" typeface="Kalinga"/>
+        <a:font script="Mlym" typeface="Kartika"/>
+        <a:font script="Laoo" typeface="DokChampa"/>
+        <a:font script="Sinh" typeface="Iskoola Pota"/>
+        <a:font script="Mong" typeface="Mongolian Baiti"/>
+        <a:font script="Viet" typeface="Times New Roman"/>
+        <a:font script="Uigh" typeface="Microsoft Uighur"/>
+        <a:font script="Geor" typeface="Sylfaen"/>
+      </a:majorFont>
+      <a:minorFont>
+        <a:latin typeface="Arial"/>
+        <a:ea typeface=""/>
+        <a:cs typeface=""/>
+        <a:font script="Jpan" typeface="ＭＳ Ｐゴシック"/>
+        <a:font script="Hang" typeface="맑은 고딕"/>
+        <a:font script="Hans" typeface="宋体"/>
+        <a:font script="Hant" typeface="新細明體"/>
+        <a:font script="Arab" typeface="Arial"/>
+        <a:font script="Hebr" typeface="Arial"/>
+        <a:font script="Thai" typeface="Cordia New"/>
+        <a:font script="Ethi" typeface="Nyala"/>
+        <a:font script="Beng" typeface="Vrinda"/>
+        <a:font script="Gujr" typeface="Shruti"/>
+        <a:font script="Khmr" typeface="DaunPenh"/>
+        <a:font script="Knda" typeface="Tunga"/>
+        <a:font script="Guru" typeface="Raavi"/>
+        <a:font script="Cans" typeface="Euphemia"/>
+        <a:font script="Cher" typeface="Plantagenet Cherokee"/>
+        <a:font script="Yiii" typeface="Microsoft Yi Baiti"/>
+        <a:font script="Tibt" typeface="Microsoft Himalaya"/>
+        <a:font script="Thaa" typeface="MV Boli"/>
+        <a:font script="Deva" typeface="Mangal"/>
+        <a:font script="Telu" typeface="Gautami"/>
+        <a:font script="Taml" typeface="Latha"/>
+        <a:font script="Syrc" typeface="Estrangelo Edessa"/>
+        <a:font script="Orya" typeface="Kalinga"/>
+        <a:font script="Mlym" typeface="Kartika"/>
+        <a:font script="Laoo" typeface="DokChampa"/>
+        <a:font script="Sinh" typeface="Iskoola Pota"/>
+        <a:font script="Mong" typeface="Mongolian Baiti"/>
+        <a:font script="Viet" typeface="Arial"/>
+        <a:font script="Uigh" typeface="Microsoft Uighur"/>
+        <a:font script="Geor" typeface="Sylfaen"/>
+      </a:minorFont>
+    </a:fontScheme>
+    <a:fmtScheme name="Office">
+      <a:fillStyleLst>
+        <a:solidFill>
+          <a:schemeClr val="phClr"/>
+        </a:solidFill>
+        <a:gradFill rotWithShape="1">
+          <a:gsLst>
+            <a:gs pos="0">
+              <a:schemeClr val="phClr">
+                <a:tint val="50000"/>
+                <a:satMod val="300000"/>
+              </a:schemeClr>
+            </a:gs>
+            <a:gs pos="35000">
+              <a:schemeClr val="phClr">
+                <a:tint val="37000"/>
+                <a:satMod val="300000"/>
+              </a:schemeClr>
+            </a:gs>
+            <a:gs pos="100000">
+              <a:schemeClr val="phClr">
+                <a:tint val="15000"/>
+                <a:satMod val="350000"/>
+              </a:schemeClr>
+            </a:gs>
+          </a:gsLst>
+          <a:lin ang="16200000" scaled="1"/>
+        </a:gradFill>
+        <a:gradFill rotWithShape="1">
+          <a:gsLst>
+            <a:gs pos="0">
+              <a:schemeClr val="phClr">
+                <a:tint val="100000"/>
+                <a:shade val="100000"/>
+                <a:satMod val="130000"/>
+              </a:schemeClr>
+            </a:gs>
+            <a:gs pos="100000">
+              <a:schemeClr val="phClr">
+                <a:tint val="50000"/>
+                <a:shade val="100000"/>
+                <a:satMod val="350000"/>
+              </a:schemeClr>
+            </a:gs>
+          </a:gsLst>
+          <a:lin ang="16200000" scaled="0"/>
+        </a:gradFill>
+      </a:fillStyleLst>
+      <a:lnStyleLst>
+        <a:ln w="9525" cap="flat" cmpd="sng" algn="ctr">
+          <a:solidFill>
+            <a:schemeClr val="phClr">
+              <a:shade val="95000"/>
+              <a:satMod val="105000"/>
+            </a:schemeClr>
+          </a:solidFill>
+          <a:prstDash val="solid"/>
+        </a:ln>
+        <a:ln w="25400" cap="flat" cmpd="sng" algn="ctr">
+          <a:solidFill>
+            <a:schemeClr val="phClr"/>
+          </a:solidFill>
+          <a:prstDash val="solid"/>
+        </a:ln>
+        <a:ln w="38100" cap="flat" cmpd="sng" algn="ctr">
+          <a:solidFill>
+            <a:schemeClr val="phClr"/>
+          </a:solidFill>
+          <a:prstDash val="solid"/>
+        </a:ln>
+      </a:lnStyleLst>
+      <a:effectStyleLst>
+        <a:effectStyle>
+          <a:effectLst>
+            <a:outerShdw blurRad="40000" dist="20000" dir="5400000" rotWithShape="0">
+              <a:srgbClr val="000000">
+                <a:alpha val="38000"/>
+              </a:srgbClr>
+            </a:outerShdw>
+          </a:effectLst>
+        </a:effectStyle>
+        <a:effectStyle>
+          <a:effectLst>
+            <a:outerShdw blurRad="40000" dist="23000" dir="5400000" rotWithShape="0">
+              <a:srgbClr val="000000">
+                <a:alpha val="35000"/>
+              </a:srgbClr>
+            </a:outerShdw>
+          </a:effectLst>
+        </a:effectStyle>
+        <a:effectStyle>
+          <a:effectLst>
+            <a:outerShdw blurRad="40000" dist="23000" dir="5400000" rotWithShape="0">
+              <a:srgbClr val="000000">
+                <a:alpha val="35000"/>
+              </a:srgbClr>
+            </a:outerShdw>
+          </a:effectLst>
+          <a:scene3d>
+            <a:camera prst="orthographicFront">
+              <a:rot lat="0" lon="0" rev="0"/>
+            </a:camera>
+            <a:lightRig rig="threePt" dir="t">
+              <a:rot lat="0" lon="0" rev="1200000"/>
+            </a:lightRig>
+          </a:scene3d>
+          <a:sp3d>
+            <a:bevelT w="63500" h="25400"/>
+          </a:sp3d>
+        </a:effectStyle>
+      </a:effectStyleLst>
+      <a:bgFillStyleLst>
+        <a:solidFill>
+          <a:schemeClr val="phClr"/>
+        </a:solidFill>
+        <a:gradFill rotWithShape="1">
+          <a:gsLst>
+            <a:gs pos="0">
+              <a:schemeClr val="phClr">
+                <a:tint val="40000"/>
+                <a:satMod val="350000"/>
+              </a:schemeClr>
+            </a:gs>
+            <a:gs pos="40000">
+              <a:schemeClr val="phClr">
+                <a:tint val="45000"/>
+                <a:shade val="99000"/>
+                <a:satMod val="350000"/>
+              </a:schemeClr>
+            </a:gs>
+            <a:gs pos="100000">
+              <a:schemeClr val="phClr">
+                <a:shade val="20000"/>
+                <a:satMod val="255000"/>
+              </a:schemeClr>
+            </a:gs>
+          </a:gsLst>
+          <a:path path="circle">
+            <a:fillToRect l="50000" t="-80000" r="50000" b="180000"/>
+          </a:path>
+        </a:gradFill>
+        <a:gradFill rotWithShape="1">
+          <a:gsLst>
+            <a:gs pos="0">
+              <a:schemeClr val="phClr">
+                <a:tint val="80000"/>
+                <a:satMod val="300000"/>
+              </a:schemeClr>
+            </a:gs>
+            <a:gs pos="100000">
+              <a:schemeClr val="phClr">
+                <a:shade val="30000"/>
+                <a:satMod val="200000"/>
+              </a:schemeClr>
+            </a:gs>
+          </a:gsLst>
+          <a:path path="circle">
+            <a:fillToRect l="50000" t="50000" r="50000" b="50000"/>
+          </a:path>
+        </a:gradFill>
+      </a:bgFillStyleLst>
+    </a:fmtScheme>
+  </a:themeElements>
+</a:theme>
+</file>
+
+<file path=ppt/theme/theme2.xml><?xml version="1.0" encoding="utf-8"?>
 <a:theme xmlns:a="http://schemas.openxmlformats.org/drawingml/2006/main" xmlns:r="http://schemas.openxmlformats.org/officeDocument/2006/relationships" name="Simple Light">
   <a:themeElements>
     <a:clrScheme name="Simple Light">
@@ -11679,283 +11959,4 @@
     </a:fmtScheme>
   </a:themeElements>
 </a:theme>
-</file>
-
-<file path=ppt/theme/theme2.xml><?xml version="1.0" encoding="utf-8"?>
-<a:theme xmlns:a="http://schemas.openxmlformats.org/drawingml/2006/main" xmlns:r="http://schemas.openxmlformats.org/officeDocument/2006/relationships">
-  <a:themeElements>
-    <a:clrScheme name="Default">
-      <a:dk1>
-        <a:srgbClr val="000000"/>
-      </a:dk1>
-      <a:lt1>
-        <a:srgbClr val="FFFFFF"/>
-      </a:lt1>
-      <a:dk2>
-        <a:srgbClr val="158158"/>
-      </a:dk2>
-      <a:lt2>
-        <a:srgbClr val="F3F3F3"/>
-      </a:lt2>
-      <a:accent1>
-        <a:srgbClr val="058DC7"/>
-      </a:accent1>
-      <a:accent2>
-        <a:srgbClr val="50B432"/>
-      </a:accent2>
-      <a:accent3>
-        <a:srgbClr val="ED561B"/>
-      </a:accent3>
-      <a:accent4>
-        <a:srgbClr val="EDEF00"/>
-      </a:accent4>
-      <a:accent5>
-        <a:srgbClr val="24CBE5"/>
-      </a:accent5>
-      <a:accent6>
-        <a:srgbClr val="64E572"/>
-      </a:accent6>
-      <a:hlink>
-        <a:srgbClr val="2200CC"/>
-      </a:hlink>
-      <a:folHlink>
-        <a:srgbClr val="551A8B"/>
-      </a:folHlink>
-    </a:clrScheme>
-    <a:fontScheme name="Office">
-      <a:majorFont>
-        <a:latin typeface="Arial"/>
-        <a:ea typeface=""/>
-        <a:cs typeface=""/>
-        <a:font script="Jpan" typeface="ＭＳ Ｐゴシック"/>
-        <a:font script="Hang" typeface="맑은 고딕"/>
-        <a:font script="Hans" typeface="宋体"/>
-        <a:font script="Hant" typeface="新細明體"/>
-        <a:font script="Arab" typeface="Times New Roman"/>
-        <a:font script="Hebr" typeface="Times New Roman"/>
-        <a:font script="Thai" typeface="Angsana New"/>
-        <a:font script="Ethi" typeface="Nyala"/>
-        <a:font script="Beng" typeface="Vrinda"/>
-        <a:font script="Gujr" typeface="Shruti"/>
-        <a:font script="Khmr" typeface="MoolBoran"/>
-        <a:font script="Knda" typeface="Tunga"/>
-        <a:font script="Guru" typeface="Raavi"/>
-        <a:font script="Cans" typeface="Euphemia"/>
-        <a:font script="Cher" typeface="Plantagenet Cherokee"/>
-        <a:font script="Yiii" typeface="Microsoft Yi Baiti"/>
-        <a:font script="Tibt" typeface="Microsoft Himalaya"/>
-        <a:font script="Thaa" typeface="MV Boli"/>
-        <a:font script="Deva" typeface="Mangal"/>
-        <a:font script="Telu" typeface="Gautami"/>
-        <a:font script="Taml" typeface="Latha"/>
-        <a:font script="Syrc" typeface="Estrangelo Edessa"/>
-        <a:font script="Orya" typeface="Kalinga"/>
-        <a:font script="Mlym" typeface="Kartika"/>
-        <a:font script="Laoo" typeface="DokChampa"/>
-        <a:font script="Sinh" typeface="Iskoola Pota"/>
-        <a:font script="Mong" typeface="Mongolian Baiti"/>
-        <a:font script="Viet" typeface="Times New Roman"/>
-        <a:font script="Uigh" typeface="Microsoft Uighur"/>
-        <a:font script="Geor" typeface="Sylfaen"/>
-      </a:majorFont>
-      <a:minorFont>
-        <a:latin typeface="Arial"/>
-        <a:ea typeface=""/>
-        <a:cs typeface=""/>
-        <a:font script="Jpan" typeface="ＭＳ Ｐゴシック"/>
-        <a:font script="Hang" typeface="맑은 고딕"/>
-        <a:font script="Hans" typeface="宋体"/>
-        <a:font script="Hant" typeface="新細明體"/>
-        <a:font script="Arab" typeface="Arial"/>
-        <a:font script="Hebr" typeface="Arial"/>
-        <a:font script="Thai" typeface="Cordia New"/>
-        <a:font script="Ethi" typeface="Nyala"/>
-        <a:font script="Beng" typeface="Vrinda"/>
-        <a:font script="Gujr" typeface="Shruti"/>
-        <a:font script="Khmr" typeface="DaunPenh"/>
-        <a:font script="Knda" typeface="Tunga"/>
-        <a:font script="Guru" typeface="Raavi"/>
-        <a:font script="Cans" typeface="Euphemia"/>
-        <a:font script="Cher" typeface="Plantagenet Cherokee"/>
-        <a:font script="Yiii" typeface="Microsoft Yi Baiti"/>
-        <a:font script="Tibt" typeface="Microsoft Himalaya"/>
-        <a:font script="Thaa" typeface="MV Boli"/>
-        <a:font script="Deva" typeface="Mangal"/>
-        <a:font script="Telu" typeface="Gautami"/>
-        <a:font script="Taml" typeface="Latha"/>
-        <a:font script="Syrc" typeface="Estrangelo Edessa"/>
-        <a:font script="Orya" typeface="Kalinga"/>
-        <a:font script="Mlym" typeface="Kartika"/>
-        <a:font script="Laoo" typeface="DokChampa"/>
-        <a:font script="Sinh" typeface="Iskoola Pota"/>
-        <a:font script="Mong" typeface="Mongolian Baiti"/>
-        <a:font script="Viet" typeface="Arial"/>
-        <a:font script="Uigh" typeface="Microsoft Uighur"/>
-        <a:font script="Geor" typeface="Sylfaen"/>
-      </a:minorFont>
-    </a:fontScheme>
-    <a:fmtScheme name="Office">
-      <a:fillStyleLst>
-        <a:solidFill>
-          <a:schemeClr val="phClr"/>
-        </a:solidFill>
-        <a:gradFill rotWithShape="1">
-          <a:gsLst>
-            <a:gs pos="0">
-              <a:schemeClr val="phClr">
-                <a:tint val="50000"/>
-                <a:satMod val="300000"/>
-              </a:schemeClr>
-            </a:gs>
-            <a:gs pos="35000">
-              <a:schemeClr val="phClr">
-                <a:tint val="37000"/>
-                <a:satMod val="300000"/>
-              </a:schemeClr>
-            </a:gs>
-            <a:gs pos="100000">
-              <a:schemeClr val="phClr">
-                <a:tint val="15000"/>
-                <a:satMod val="350000"/>
-              </a:schemeClr>
-            </a:gs>
-          </a:gsLst>
-          <a:lin ang="16200000" scaled="1"/>
-        </a:gradFill>
-        <a:gradFill rotWithShape="1">
-          <a:gsLst>
-            <a:gs pos="0">
-              <a:schemeClr val="phClr">
-                <a:tint val="100000"/>
-                <a:shade val="100000"/>
-                <a:satMod val="130000"/>
-              </a:schemeClr>
-            </a:gs>
-            <a:gs pos="100000">
-              <a:schemeClr val="phClr">
-                <a:tint val="50000"/>
-                <a:shade val="100000"/>
-                <a:satMod val="350000"/>
-              </a:schemeClr>
-            </a:gs>
-          </a:gsLst>
-          <a:lin ang="16200000" scaled="0"/>
-        </a:gradFill>
-      </a:fillStyleLst>
-      <a:lnStyleLst>
-        <a:ln w="9525" cap="flat" cmpd="sng" algn="ctr">
-          <a:solidFill>
-            <a:schemeClr val="phClr">
-              <a:shade val="95000"/>
-              <a:satMod val="105000"/>
-            </a:schemeClr>
-          </a:solidFill>
-          <a:prstDash val="solid"/>
-        </a:ln>
-        <a:ln w="25400" cap="flat" cmpd="sng" algn="ctr">
-          <a:solidFill>
-            <a:schemeClr val="phClr"/>
-          </a:solidFill>
-          <a:prstDash val="solid"/>
-        </a:ln>
-        <a:ln w="38100" cap="flat" cmpd="sng" algn="ctr">
-          <a:solidFill>
-            <a:schemeClr val="phClr"/>
-          </a:solidFill>
-          <a:prstDash val="solid"/>
-        </a:ln>
-      </a:lnStyleLst>
-      <a:effectStyleLst>
-        <a:effectStyle>
-          <a:effectLst>
-            <a:outerShdw blurRad="40000" dist="20000" dir="5400000" rotWithShape="0">
-              <a:srgbClr val="000000">
-                <a:alpha val="38000"/>
-              </a:srgbClr>
-            </a:outerShdw>
-          </a:effectLst>
-        </a:effectStyle>
-        <a:effectStyle>
-          <a:effectLst>
-            <a:outerShdw blurRad="40000" dist="23000" dir="5400000" rotWithShape="0">
-              <a:srgbClr val="000000">
-                <a:alpha val="35000"/>
-              </a:srgbClr>
-            </a:outerShdw>
-          </a:effectLst>
-        </a:effectStyle>
-        <a:effectStyle>
-          <a:effectLst>
-            <a:outerShdw blurRad="40000" dist="23000" dir="5400000" rotWithShape="0">
-              <a:srgbClr val="000000">
-                <a:alpha val="35000"/>
-              </a:srgbClr>
-            </a:outerShdw>
-          </a:effectLst>
-          <a:scene3d>
-            <a:camera prst="orthographicFront">
-              <a:rot lat="0" lon="0" rev="0"/>
-            </a:camera>
-            <a:lightRig rig="threePt" dir="t">
-              <a:rot lat="0" lon="0" rev="1200000"/>
-            </a:lightRig>
-          </a:scene3d>
-          <a:sp3d>
-            <a:bevelT w="63500" h="25400"/>
-          </a:sp3d>
-        </a:effectStyle>
-      </a:effectStyleLst>
-      <a:bgFillStyleLst>
-        <a:solidFill>
-          <a:schemeClr val="phClr"/>
-        </a:solidFill>
-        <a:gradFill rotWithShape="1">
-          <a:gsLst>
-            <a:gs pos="0">
-              <a:schemeClr val="phClr">
-                <a:tint val="40000"/>
-                <a:satMod val="350000"/>
-              </a:schemeClr>
-            </a:gs>
-            <a:gs pos="40000">
-              <a:schemeClr val="phClr">
-                <a:tint val="45000"/>
-                <a:shade val="99000"/>
-                <a:satMod val="350000"/>
-              </a:schemeClr>
-            </a:gs>
-            <a:gs pos="100000">
-              <a:schemeClr val="phClr">
-                <a:shade val="20000"/>
-                <a:satMod val="255000"/>
-              </a:schemeClr>
-            </a:gs>
-          </a:gsLst>
-          <a:path path="circle">
-            <a:fillToRect l="50000" t="-80000" r="50000" b="180000"/>
-          </a:path>
-        </a:gradFill>
-        <a:gradFill rotWithShape="1">
-          <a:gsLst>
-            <a:gs pos="0">
-              <a:schemeClr val="phClr">
-                <a:tint val="80000"/>
-                <a:satMod val="300000"/>
-              </a:schemeClr>
-            </a:gs>
-            <a:gs pos="100000">
-              <a:schemeClr val="phClr">
-                <a:shade val="30000"/>
-                <a:satMod val="200000"/>
-              </a:schemeClr>
-            </a:gs>
-          </a:gsLst>
-          <a:path path="circle">
-            <a:fillToRect l="50000" t="50000" r="50000" b="50000"/>
-          </a:path>
-        </a:gradFill>
-      </a:bgFillStyleLst>
-    </a:fmtScheme>
-  </a:themeElements>
-</a:theme>
 </file>
</xml_diff>